<commit_message>
Demo-oriented deck + value-prop video: clear problem/pain/use-case/flow + token before-after
Co-Authored-By: Claude Opus 4.8 <noreply@anthropic.com>
</commit_message>
<xml_diff>
--- a/demo/autopilot-slides.pptx
+++ b/demo/autopilot-slides.pptx
@@ -9,6 +9,8 @@
     <p:sldId id="257" r:id="rId8"/>
     <p:sldId id="258" r:id="rId9"/>
     <p:sldId id="259" r:id="rId10"/>
+    <p:sldId id="260" r:id="rId11"/>
+    <p:sldId id="261" r:id="rId12"/>
   </p:sldIdLst>
   <p:sldSz cx="12191695" cy="6858000" type="screen4x3"/>
   <p:notesSz cx="6858000" cy="9144000"/>
@@ -3137,175 +3139,23 @@
       </p:sp>
       <p:sp>
         <p:nvSpPr>
-          <p:cNvPr id="3" name="TextBox 2"/>
-          <p:cNvSpPr txBox="1"/>
+          <p:cNvPr id="3" name="Rectangle 2"/>
+          <p:cNvSpPr/>
           <p:nvPr/>
         </p:nvSpPr>
         <p:spPr>
           <a:xfrm>
-            <a:off x="822960" y="640080"/>
-            <a:ext cx="10058400" cy="548640"/>
+            <a:off x="0" y="0"/>
+            <a:ext cx="128016" cy="6858000"/>
           </a:xfrm>
           <a:prstGeom prst="rect">
             <a:avLst/>
           </a:prstGeom>
-          <a:noFill/>
-        </p:spPr>
-        <p:txBody>
-          <a:bodyPr wrap="none">
-            <a:spAutoFit/>
-          </a:bodyPr>
-          <a:lstStyle/>
-          <a:p/>
-        </p:txBody>
-      </p:sp>
-      <p:sp>
-        <p:nvSpPr>
-          <p:cNvPr id="4" name="TextBox 3"/>
-          <p:cNvSpPr txBox="1"/>
-          <p:nvPr/>
-        </p:nvSpPr>
-        <p:spPr>
-          <a:xfrm>
-            <a:off x="822960" y="1920240"/>
-            <a:ext cx="10515600" cy="2377440"/>
-          </a:xfrm>
-          <a:prstGeom prst="rect">
-            <a:avLst/>
-          </a:prstGeom>
-          <a:noFill/>
-        </p:spPr>
-        <p:txBody>
-          <a:bodyPr wrap="none">
-            <a:spAutoFit/>
-          </a:bodyPr>
-          <a:lstStyle/>
-          <a:p>
-            <a:pPr algn="l">
-              <a:spcAft>
-                <a:spcPts val="600"/>
-              </a:spcAft>
-            </a:pPr>
-            <a:r>
-              <a:rPr sz="4600" b="1">
-                <a:solidFill>
-                  <a:srgbClr val="E8EAF2"/>
-                </a:solidFill>
-                <a:latin typeface="Helvetica Neue"/>
-              </a:rPr>
-              <a:t>Personal Coding Model Autopilot</a:t>
-            </a:r>
-          </a:p>
-          <a:p>
-            <a:pPr algn="l">
-              <a:spcAft>
-                <a:spcPts val="600"/>
-              </a:spcAft>
-            </a:pPr>
-            <a:r>
-              <a:rPr sz="2200" b="0">
-                <a:solidFill>
-                  <a:srgbClr val="9AA0B6"/>
-                </a:solidFill>
-                <a:latin typeface="Helvetica Neue"/>
-              </a:rPr>
-              <a:t>A $0 local repo-context model + skills + memory + subagents that cuts</a:t>
-            </a:r>
-          </a:p>
-          <a:p>
-            <a:pPr algn="l">
-              <a:spcAft>
-                <a:spcPts val="600"/>
-              </a:spcAft>
-            </a:pPr>
-            <a:r>
-              <a:rPr sz="2200" b="0">
-                <a:solidFill>
-                  <a:srgbClr val="9AA0B6"/>
-                </a:solidFill>
-                <a:latin typeface="Helvetica Neue"/>
-              </a:rPr>
-              <a:t>frontier token usage, cost, and latency — with an eval harness that proves it.</a:t>
-            </a:r>
-          </a:p>
-        </p:txBody>
-      </p:sp>
-      <p:sp>
-        <p:nvSpPr>
-          <p:cNvPr id="5" name="TextBox 4"/>
-          <p:cNvSpPr txBox="1"/>
-          <p:nvPr/>
-        </p:nvSpPr>
-        <p:spPr>
-          <a:xfrm>
-            <a:off x="822960" y="4663440"/>
-            <a:ext cx="10515600" cy="1371600"/>
-          </a:xfrm>
-          <a:prstGeom prst="rect">
-            <a:avLst/>
-          </a:prstGeom>
-          <a:noFill/>
-        </p:spPr>
-        <p:txBody>
-          <a:bodyPr wrap="none">
-            <a:spAutoFit/>
-          </a:bodyPr>
-          <a:lstStyle/>
-          <a:p>
-            <a:pPr algn="l">
-              <a:spcAft>
-                <a:spcPts val="600"/>
-              </a:spcAft>
-            </a:pPr>
-            <a:r>
-              <a:rPr sz="1800" b="1">
-                <a:solidFill>
-                  <a:srgbClr val="2DD4A7"/>
-                </a:solidFill>
-                <a:latin typeface="Helvetica Neue"/>
-              </a:rPr>
-              <a:t>Touchdown Labs   ·   Beta Fund × EverMind Hackathon</a:t>
-            </a:r>
-          </a:p>
-          <a:p>
-            <a:pPr algn="l">
-              <a:spcAft>
-                <a:spcPts val="600"/>
-              </a:spcAft>
-            </a:pPr>
-            <a:r>
-              <a:rPr sz="1400" b="0">
-                <a:solidFill>
-                  <a:srgbClr val="9AA0B6"/>
-                </a:solidFill>
-                <a:latin typeface="Helvetica Neue"/>
-              </a:rPr>
-              <a:t>Track: Next-Gen Infrastructure &amp; Context   ·   github.com/OCWC22/personal-coding-autopilot</a:t>
-            </a:r>
-          </a:p>
-        </p:txBody>
-      </p:sp>
-      <p:sp>
-        <p:nvSpPr>
-          <p:cNvPr id="6" name="Rounded Rectangle 5"/>
-          <p:cNvSpPr/>
-          <p:nvPr/>
-        </p:nvSpPr>
-        <p:spPr>
-          <a:xfrm>
-            <a:off x="822960" y="914400"/>
-            <a:ext cx="2377440" cy="457200"/>
-          </a:xfrm>
-          <a:prstGeom prst="roundRect">
-            <a:avLst/>
-          </a:prstGeom>
           <a:solidFill>
-            <a:srgbClr val="0A0C14"/>
+            <a:srgbClr val="2DD4A7"/>
           </a:solidFill>
-          <a:ln w="15875">
-            <a:solidFill>
-              <a:srgbClr val="A78BFA"/>
-            </a:solidFill>
+          <a:ln>
+            <a:noFill/>
           </a:ln>
           <a:effectLst/>
         </p:spPr>
@@ -3324,17 +3174,158 @@
           </a:fontRef>
         </p:style>
         <p:txBody>
-          <a:bodyPr rtlCol="0" anchor="ctr" wrap="square"/>
+          <a:bodyPr rtlCol="0" anchor="ctr"/>
           <a:lstStyle/>
           <a:p>
             <a:pPr algn="ctr"/>
-            <a:r>
-              <a:rPr sz="1200" b="1">
+          </a:p>
+        </p:txBody>
+      </p:sp>
+      <p:sp>
+        <p:nvSpPr>
+          <p:cNvPr id="4" name="TextBox 3"/>
+          <p:cNvSpPr txBox="1"/>
+          <p:nvPr/>
+        </p:nvSpPr>
+        <p:spPr>
+          <a:xfrm>
+            <a:off x="822960" y="914400"/>
+            <a:ext cx="10058400" cy="457200"/>
+          </a:xfrm>
+          <a:prstGeom prst="rect">
+            <a:avLst/>
+          </a:prstGeom>
+          <a:noFill/>
+        </p:spPr>
+        <p:txBody>
+          <a:bodyPr wrap="none">
+            <a:spAutoFit/>
+          </a:bodyPr>
+          <a:lstStyle/>
+          <a:p>
+            <a:pPr algn="l">
+              <a:spcAft>
+                <a:spcPts val="600"/>
+              </a:spcAft>
+            </a:pPr>
+            <a:r>
+              <a:rPr sz="1400" b="1">
                 <a:solidFill>
                   <a:srgbClr val="A78BFA"/>
                 </a:solidFill>
-              </a:rPr>
-              <a:t>INFERENCE ORCHESTRATION</a:t>
+                <a:latin typeface="Helvetica Neue"/>
+              </a:rPr>
+              <a:t>BETA FUND × EVERMIND  ·  NEXT-GEN INFRASTRUCTURE &amp; CONTEXT</a:t>
+            </a:r>
+          </a:p>
+        </p:txBody>
+      </p:sp>
+      <p:sp>
+        <p:nvSpPr>
+          <p:cNvPr id="5" name="TextBox 4"/>
+          <p:cNvSpPr txBox="1"/>
+          <p:nvPr/>
+        </p:nvSpPr>
+        <p:spPr>
+          <a:xfrm>
+            <a:off x="822960" y="2103120"/>
+            <a:ext cx="10698480" cy="2377440"/>
+          </a:xfrm>
+          <a:prstGeom prst="rect">
+            <a:avLst/>
+          </a:prstGeom>
+          <a:noFill/>
+        </p:spPr>
+        <p:txBody>
+          <a:bodyPr wrap="none">
+            <a:spAutoFit/>
+          </a:bodyPr>
+          <a:lstStyle/>
+          <a:p>
+            <a:pPr algn="l">
+              <a:spcAft>
+                <a:spcPts val="600"/>
+              </a:spcAft>
+            </a:pPr>
+            <a:r>
+              <a:rPr sz="4400" b="1">
+                <a:solidFill>
+                  <a:srgbClr val="E8EAF2"/>
+                </a:solidFill>
+                <a:latin typeface="Helvetica Neue"/>
+              </a:rPr>
+              <a:t>Stop paying Claude to re-read your repo</a:t>
+            </a:r>
+          </a:p>
+          <a:p>
+            <a:pPr algn="l">
+              <a:spcAft>
+                <a:spcPts val="600"/>
+              </a:spcAft>
+            </a:pPr>
+            <a:r>
+              <a:rPr sz="2100" b="0">
+                <a:solidFill>
+                  <a:srgbClr val="9AA0B6"/>
+                </a:solidFill>
+                <a:latin typeface="Helvetica Neue"/>
+              </a:rPr>
+              <a:t>A $0 local model keeps a live map of your codebase (SKILL.md + DAG) so Claude Code</a:t>
+            </a:r>
+          </a:p>
+          <a:p>
+            <a:pPr algn="l">
+              <a:spcAft>
+                <a:spcPts val="600"/>
+              </a:spcAft>
+            </a:pPr>
+            <a:r>
+              <a:rPr sz="2100" b="0">
+                <a:solidFill>
+                  <a:srgbClr val="9AA0B6"/>
+                </a:solidFill>
+                <a:latin typeface="Helvetica Neue"/>
+              </a:rPr>
+              <a:t>reads the saved context instead of re-exploring — ~99% fewer tokens, same result.</a:t>
+            </a:r>
+          </a:p>
+        </p:txBody>
+      </p:sp>
+      <p:sp>
+        <p:nvSpPr>
+          <p:cNvPr id="6" name="TextBox 5"/>
+          <p:cNvSpPr txBox="1"/>
+          <p:nvPr/>
+        </p:nvSpPr>
+        <p:spPr>
+          <a:xfrm>
+            <a:off x="822960" y="4846320"/>
+            <a:ext cx="10698480" cy="914400"/>
+          </a:xfrm>
+          <a:prstGeom prst="rect">
+            <a:avLst/>
+          </a:prstGeom>
+          <a:noFill/>
+        </p:spPr>
+        <p:txBody>
+          <a:bodyPr wrap="none">
+            <a:spAutoFit/>
+          </a:bodyPr>
+          <a:lstStyle/>
+          <a:p>
+            <a:pPr algn="l">
+              <a:spcAft>
+                <a:spcPts val="600"/>
+              </a:spcAft>
+            </a:pPr>
+            <a:r>
+              <a:rPr sz="1600" b="1">
+                <a:solidFill>
+                  <a:srgbClr val="2DD4A7"/>
+                </a:solidFill>
+                <a:latin typeface="Helvetica Neue"/>
+              </a:rPr>
+              <a:t>Touchdown Labs  ·  github.com/OCWC22/personal-coding-autopilot</a:t>
             </a:r>
           </a:p>
         </p:txBody>
@@ -3403,14 +3394,99 @@
       </p:sp>
       <p:sp>
         <p:nvSpPr>
-          <p:cNvPr id="3" name="TextBox 2"/>
+          <p:cNvPr id="3" name="Rectangle 2"/>
+          <p:cNvSpPr/>
+          <p:nvPr/>
+        </p:nvSpPr>
+        <p:spPr>
+          <a:xfrm>
+            <a:off x="0" y="0"/>
+            <a:ext cx="128016" cy="6858000"/>
+          </a:xfrm>
+          <a:prstGeom prst="rect">
+            <a:avLst/>
+          </a:prstGeom>
+          <a:solidFill>
+            <a:srgbClr val="2DD4A7"/>
+          </a:solidFill>
+          <a:ln>
+            <a:noFill/>
+          </a:ln>
+          <a:effectLst/>
+        </p:spPr>
+        <p:style>
+          <a:lnRef idx="1">
+            <a:schemeClr val="accent1"/>
+          </a:lnRef>
+          <a:fillRef idx="3">
+            <a:schemeClr val="accent1"/>
+          </a:fillRef>
+          <a:effectRef idx="2">
+            <a:schemeClr val="accent1"/>
+          </a:effectRef>
+          <a:fontRef idx="minor">
+            <a:schemeClr val="lt1"/>
+          </a:fontRef>
+        </p:style>
+        <p:txBody>
+          <a:bodyPr rtlCol="0" anchor="ctr"/>
+          <a:lstStyle/>
+          <a:p>
+            <a:pPr algn="ctr"/>
+          </a:p>
+        </p:txBody>
+      </p:sp>
+      <p:sp>
+        <p:nvSpPr>
+          <p:cNvPr id="4" name="TextBox 3"/>
           <p:cNvSpPr txBox="1"/>
           <p:nvPr/>
         </p:nvSpPr>
         <p:spPr>
           <a:xfrm>
-            <a:off x="822960" y="640080"/>
-            <a:ext cx="10515600" cy="1097280"/>
+            <a:off x="548640" y="6400800"/>
+            <a:ext cx="11155680" cy="365760"/>
+          </a:xfrm>
+          <a:prstGeom prst="rect">
+            <a:avLst/>
+          </a:prstGeom>
+          <a:noFill/>
+        </p:spPr>
+        <p:txBody>
+          <a:bodyPr wrap="none">
+            <a:spAutoFit/>
+          </a:bodyPr>
+          <a:lstStyle/>
+          <a:p>
+            <a:r>
+              <a:rPr sz="1000">
+                <a:solidFill>
+                  <a:srgbClr val="9AA0B6"/>
+                </a:solidFill>
+              </a:rPr>
+              <a:t>EverMind + Butterbase: LIVE  ·  app_b197i2548pk2  ·  build0530</a:t>
+            </a:r>
+            <a:r>
+              <a:rPr sz="1000">
+                <a:solidFill>
+                  <a:srgbClr val="9AA0B6"/>
+                </a:solidFill>
+              </a:rPr>
+              <a:t>        2/6</a:t>
+            </a:r>
+          </a:p>
+        </p:txBody>
+      </p:sp>
+      <p:sp>
+        <p:nvSpPr>
+          <p:cNvPr id="5" name="TextBox 4"/>
+          <p:cNvSpPr txBox="1"/>
+          <p:nvPr/>
+        </p:nvSpPr>
+        <p:spPr>
+          <a:xfrm>
+            <a:off x="548640" y="502920"/>
+            <a:ext cx="10972800" cy="457200"/>
           </a:xfrm>
           <a:prstGeom prst="rect">
             <a:avLst/>
@@ -3429,15 +3505,38 @@
               </a:spcAft>
             </a:pPr>
             <a:r>
-              <a:rPr sz="1600" b="1">
+              <a:rPr sz="1500" b="1">
                 <a:solidFill>
                   <a:srgbClr val="2DD4A7"/>
                 </a:solidFill>
                 <a:latin typeface="Helvetica Neue"/>
               </a:rPr>
-              <a:t>The problem</a:t>
-            </a:r>
-          </a:p>
+              <a:t>THE PAIN</a:t>
+            </a:r>
+          </a:p>
+        </p:txBody>
+      </p:sp>
+      <p:sp>
+        <p:nvSpPr>
+          <p:cNvPr id="6" name="TextBox 5"/>
+          <p:cNvSpPr txBox="1"/>
+          <p:nvPr/>
+        </p:nvSpPr>
+        <p:spPr>
+          <a:xfrm>
+            <a:off x="548640" y="914400"/>
+            <a:ext cx="10972800" cy="914400"/>
+          </a:xfrm>
+          <a:prstGeom prst="rect">
+            <a:avLst/>
+          </a:prstGeom>
+          <a:noFill/>
+        </p:spPr>
+        <p:txBody>
+          <a:bodyPr wrap="none">
+            <a:spAutoFit/>
+          </a:bodyPr>
+          <a:lstStyle/>
           <a:p>
             <a:pPr algn="l">
               <a:spcAft>
@@ -3445,38 +3544,74 @@
               </a:spcAft>
             </a:pPr>
             <a:r>
-              <a:rPr sz="3400" b="1">
+              <a:rPr sz="3200" b="1">
                 <a:solidFill>
                   <a:srgbClr val="E8EAF2"/>
                 </a:solidFill>
                 <a:latin typeface="Helvetica Neue"/>
               </a:rPr>
-              <a:t>You pay frontier prices to re-discover your repo every session</a:t>
-            </a:r>
-          </a:p>
-        </p:txBody>
-      </p:sp>
-      <p:sp>
-        <p:nvSpPr>
-          <p:cNvPr id="4" name="TextBox 3"/>
-          <p:cNvSpPr txBox="1"/>
+              <a:t>Every session, Claude Code rediscovers your repo</a:t>
+            </a:r>
+          </a:p>
+        </p:txBody>
+      </p:sp>
+      <p:sp>
+        <p:nvSpPr>
+          <p:cNvPr id="7" name="Rounded Rectangle 6"/>
+          <p:cNvSpPr/>
           <p:nvPr/>
         </p:nvSpPr>
         <p:spPr>
           <a:xfrm>
-            <a:off x="822960" y="2194560"/>
-            <a:ext cx="10515600" cy="2743200"/>
-          </a:xfrm>
-          <a:prstGeom prst="rect">
+            <a:off x="548640" y="2011680"/>
+            <a:ext cx="5394960" cy="3383280"/>
+          </a:xfrm>
+          <a:prstGeom prst="roundRect">
             <a:avLst/>
           </a:prstGeom>
-          <a:noFill/>
-        </p:spPr>
-        <p:txBody>
-          <a:bodyPr wrap="none">
-            <a:spAutoFit/>
-          </a:bodyPr>
-          <a:lstStyle/>
+          <a:solidFill>
+            <a:srgbClr val="10131E"/>
+          </a:solidFill>
+          <a:ln w="15875">
+            <a:solidFill>
+              <a:srgbClr val="FF7849"/>
+            </a:solidFill>
+          </a:ln>
+          <a:effectLst/>
+        </p:spPr>
+        <p:style>
+          <a:lnRef idx="1">
+            <a:schemeClr val="accent1"/>
+          </a:lnRef>
+          <a:fillRef idx="3">
+            <a:schemeClr val="accent1"/>
+          </a:fillRef>
+          <a:effectRef idx="2">
+            <a:schemeClr val="accent1"/>
+          </a:effectRef>
+          <a:fontRef idx="minor">
+            <a:schemeClr val="lt1"/>
+          </a:fontRef>
+        </p:style>
+        <p:txBody>
+          <a:bodyPr rtlCol="0" anchor="t" wrap="square" lIns="274320" tIns="228600"/>
+          <a:lstStyle/>
+          <a:p>
+            <a:pPr algn="l">
+              <a:spcAft>
+                <a:spcPts val="600"/>
+              </a:spcAft>
+            </a:pPr>
+            <a:r>
+              <a:rPr sz="1900" b="1">
+                <a:solidFill>
+                  <a:srgbClr val="FF7849"/>
+                </a:solidFill>
+                <a:latin typeface="Helvetica Neue"/>
+              </a:rPr>
+              <a:t>Normal Claude Code</a:t>
+            </a:r>
+          </a:p>
           <a:p>
             <a:pPr algn="l">
               <a:spcAft>
@@ -3484,13 +3619,13 @@
               </a:spcAft>
             </a:pPr>
             <a:r>
-              <a:rPr sz="1900" b="0">
+              <a:rPr sz="1600" b="0">
                 <a:solidFill>
                   <a:srgbClr val="E8EAF2"/>
                 </a:solidFill>
                 <a:latin typeface="Helvetica Neue"/>
               </a:rPr>
-              <a:t>•  Coding agents (Claude Code / Codex) re-index the codebase and re-send context every turn.</a:t>
+              <a:t>•  grep → read → read → read to relearn structure</a:t>
             </a:r>
           </a:p>
           <a:p>
@@ -3500,13 +3635,13 @@
               </a:spcAft>
             </a:pPr>
             <a:r>
-              <a:rPr sz="1900" b="0">
+              <a:rPr sz="1600" b="0">
                 <a:solidFill>
                   <a:srgbClr val="E8EAF2"/>
                 </a:solidFill>
                 <a:latin typeface="Helvetica Neue"/>
               </a:rPr>
-              <a:t>•  One request fans into dozens of hidden calls: plan, search, memory, file reads, checks, retries.</a:t>
+              <a:t>•  a 359 KB repo ≈ 90,000 tokens to reload</a:t>
             </a:r>
           </a:p>
           <a:p>
@@ -3516,13 +3651,13 @@
               </a:spcAft>
             </a:pPr>
             <a:r>
-              <a:rPr sz="1900" b="0">
+              <a:rPr sz="1600" b="0">
                 <a:solidFill>
                   <a:srgbClr val="E8EAF2"/>
                 </a:solidFill>
                 <a:latin typeface="Helvetica Neue"/>
               </a:rPr>
-              <a:t>•  On metered plans (the Jun 2026 Agent-SDK credit split), that quietly becomes a real API bill.</a:t>
+              <a:t>•  repeated every session, every task</a:t>
             </a:r>
           </a:p>
           <a:p>
@@ -3532,37 +3667,57 @@
               </a:spcAft>
             </a:pPr>
             <a:r>
-              <a:rPr sz="1900" b="0">
+              <a:rPr sz="1600" b="0">
                 <a:solidFill>
                   <a:srgbClr val="E8EAF2"/>
                 </a:solidFill>
                 <a:latin typeface="Helvetica Neue"/>
               </a:rPr>
-              <a:t>•  The waste isn't the model — it's repeated context reconstruction. An orchestration problem.</a:t>
-            </a:r>
-          </a:p>
-        </p:txBody>
-      </p:sp>
-      <p:sp>
-        <p:nvSpPr>
-          <p:cNvPr id="5" name="TextBox 4"/>
-          <p:cNvSpPr txBox="1"/>
+              <a:t>•  metered/agent billing → frontier prices for repo discovery</a:t>
+            </a:r>
+          </a:p>
+        </p:txBody>
+      </p:sp>
+      <p:sp>
+        <p:nvSpPr>
+          <p:cNvPr id="8" name="Rounded Rectangle 7"/>
+          <p:cNvSpPr/>
           <p:nvPr/>
         </p:nvSpPr>
         <p:spPr>
           <a:xfrm>
-            <a:off x="822960" y="5212080"/>
-            <a:ext cx="10515600" cy="1097280"/>
-          </a:xfrm>
-          <a:prstGeom prst="rect">
+            <a:off x="6217920" y="2011680"/>
+            <a:ext cx="5394960" cy="3383280"/>
+          </a:xfrm>
+          <a:prstGeom prst="roundRect">
             <a:avLst/>
           </a:prstGeom>
-          <a:noFill/>
-        </p:spPr>
-        <p:txBody>
-          <a:bodyPr wrap="none">
-            <a:spAutoFit/>
-          </a:bodyPr>
+          <a:solidFill>
+            <a:srgbClr val="10131E"/>
+          </a:solidFill>
+          <a:ln w="15875">
+            <a:solidFill>
+              <a:srgbClr val="2DD4A7"/>
+            </a:solidFill>
+          </a:ln>
+          <a:effectLst/>
+        </p:spPr>
+        <p:style>
+          <a:lnRef idx="1">
+            <a:schemeClr val="accent1"/>
+          </a:lnRef>
+          <a:fillRef idx="3">
+            <a:schemeClr val="accent1"/>
+          </a:fillRef>
+          <a:effectRef idx="2">
+            <a:schemeClr val="accent1"/>
+          </a:effectRef>
+          <a:fontRef idx="minor">
+            <a:schemeClr val="lt1"/>
+          </a:fontRef>
+        </p:style>
+        <p:txBody>
+          <a:bodyPr rtlCol="0" anchor="t" wrap="square" lIns="274320" tIns="228600"/>
           <a:lstStyle/>
           <a:p>
             <a:pPr algn="l">
@@ -3571,13 +3726,45 @@
               </a:spcAft>
             </a:pPr>
             <a:r>
-              <a:rPr sz="1600" b="1">
-                <a:solidFill>
-                  <a:srgbClr val="A78BFA"/>
+              <a:rPr sz="1900" b="1">
+                <a:solidFill>
+                  <a:srgbClr val="2DD4A7"/>
                 </a:solidFill>
                 <a:latin typeface="Helvetica Neue"/>
               </a:rPr>
-              <a:t>Team — Touchdown Labs</a:t>
+              <a:t>The waste</a:t>
+            </a:r>
+          </a:p>
+          <a:p>
+            <a:pPr algn="l">
+              <a:spcAft>
+                <a:spcPts val="1400"/>
+              </a:spcAft>
+            </a:pPr>
+            <a:r>
+              <a:rPr sz="1700" b="0">
+                <a:solidFill>
+                  <a:srgbClr val="E8EAF2"/>
+                </a:solidFill>
+                <a:latin typeface="Helvetica Neue"/>
+              </a:rPr>
+              <a:t>It's not the model — it's re-loading context you already have.</a:t>
+            </a:r>
+          </a:p>
+          <a:p>
+            <a:pPr algn="l">
+              <a:spcAft>
+                <a:spcPts val="1400"/>
+              </a:spcAft>
+            </a:pPr>
+            <a:r>
+              <a:rPr sz="1700" b="0">
+                <a:solidFill>
+                  <a:srgbClr val="E8EAF2"/>
+                </a:solidFill>
+                <a:latin typeface="Helvetica Neue"/>
+              </a:rPr>
+              <a:t>An inference-orchestration problem, not a code-model problem.</a:t>
             </a:r>
           </a:p>
           <a:p>
@@ -3587,13 +3774,13 @@
               </a:spcAft>
             </a:pPr>
             <a:r>
-              <a:rPr sz="1600" b="0">
+              <a:rPr sz="1400" b="0">
                 <a:solidFill>
                   <a:srgbClr val="9AA0B6"/>
                 </a:solidFill>
                 <a:latin typeface="Helvetica Neue"/>
               </a:rPr>
-              <a:t>Vendor-neutral inference-optimization research. Problem-fit: this is our daily thesis.</a:t>
+              <a:t>Backed by Repoformer, GraphCoder, LLavaCode, ContextBench.</a:t>
             </a:r>
           </a:p>
         </p:txBody>
@@ -3662,14 +3849,99 @@
       </p:sp>
       <p:sp>
         <p:nvSpPr>
-          <p:cNvPr id="3" name="TextBox 2"/>
+          <p:cNvPr id="3" name="Rectangle 2"/>
+          <p:cNvSpPr/>
+          <p:nvPr/>
+        </p:nvSpPr>
+        <p:spPr>
+          <a:xfrm>
+            <a:off x="0" y="0"/>
+            <a:ext cx="128016" cy="6858000"/>
+          </a:xfrm>
+          <a:prstGeom prst="rect">
+            <a:avLst/>
+          </a:prstGeom>
+          <a:solidFill>
+            <a:srgbClr val="2DD4A7"/>
+          </a:solidFill>
+          <a:ln>
+            <a:noFill/>
+          </a:ln>
+          <a:effectLst/>
+        </p:spPr>
+        <p:style>
+          <a:lnRef idx="1">
+            <a:schemeClr val="accent1"/>
+          </a:lnRef>
+          <a:fillRef idx="3">
+            <a:schemeClr val="accent1"/>
+          </a:fillRef>
+          <a:effectRef idx="2">
+            <a:schemeClr val="accent1"/>
+          </a:effectRef>
+          <a:fontRef idx="minor">
+            <a:schemeClr val="lt1"/>
+          </a:fontRef>
+        </p:style>
+        <p:txBody>
+          <a:bodyPr rtlCol="0" anchor="ctr"/>
+          <a:lstStyle/>
+          <a:p>
+            <a:pPr algn="ctr"/>
+          </a:p>
+        </p:txBody>
+      </p:sp>
+      <p:sp>
+        <p:nvSpPr>
+          <p:cNvPr id="4" name="TextBox 3"/>
           <p:cNvSpPr txBox="1"/>
           <p:nvPr/>
         </p:nvSpPr>
         <p:spPr>
           <a:xfrm>
-            <a:off x="822960" y="640080"/>
-            <a:ext cx="10515600" cy="822960"/>
+            <a:off x="548640" y="6400800"/>
+            <a:ext cx="11155680" cy="365760"/>
+          </a:xfrm>
+          <a:prstGeom prst="rect">
+            <a:avLst/>
+          </a:prstGeom>
+          <a:noFill/>
+        </p:spPr>
+        <p:txBody>
+          <a:bodyPr wrap="none">
+            <a:spAutoFit/>
+          </a:bodyPr>
+          <a:lstStyle/>
+          <a:p>
+            <a:r>
+              <a:rPr sz="1000">
+                <a:solidFill>
+                  <a:srgbClr val="9AA0B6"/>
+                </a:solidFill>
+              </a:rPr>
+              <a:t>EverMind + Butterbase: LIVE  ·  app_b197i2548pk2  ·  build0530</a:t>
+            </a:r>
+            <a:r>
+              <a:rPr sz="1000">
+                <a:solidFill>
+                  <a:srgbClr val="9AA0B6"/>
+                </a:solidFill>
+              </a:rPr>
+              <a:t>        3/6</a:t>
+            </a:r>
+          </a:p>
+        </p:txBody>
+      </p:sp>
+      <p:sp>
+        <p:nvSpPr>
+          <p:cNvPr id="5" name="TextBox 4"/>
+          <p:cNvSpPr txBox="1"/>
+          <p:nvPr/>
+        </p:nvSpPr>
+        <p:spPr>
+          <a:xfrm>
+            <a:off x="548640" y="502920"/>
+            <a:ext cx="10972800" cy="457200"/>
           </a:xfrm>
           <a:prstGeom prst="rect">
             <a:avLst/>
@@ -3688,15 +3960,38 @@
               </a:spcAft>
             </a:pPr>
             <a:r>
-              <a:rPr sz="1600" b="1">
+              <a:rPr sz="1500" b="1">
                 <a:solidFill>
                   <a:srgbClr val="2DD4A7"/>
                 </a:solidFill>
                 <a:latin typeface="Helvetica Neue"/>
               </a:rPr>
-              <a:t>What we built</a:t>
-            </a:r>
-          </a:p>
+              <a:t>USE CASE</a:t>
+            </a:r>
+          </a:p>
+        </p:txBody>
+      </p:sp>
+      <p:sp>
+        <p:nvSpPr>
+          <p:cNvPr id="6" name="TextBox 5"/>
+          <p:cNvSpPr txBox="1"/>
+          <p:nvPr/>
+        </p:nvSpPr>
+        <p:spPr>
+          <a:xfrm>
+            <a:off x="548640" y="914400"/>
+            <a:ext cx="10972800" cy="914400"/>
+          </a:xfrm>
+          <a:prstGeom prst="rect">
+            <a:avLst/>
+          </a:prstGeom>
+          <a:noFill/>
+        </p:spPr>
+        <p:txBody>
+          <a:bodyPr wrap="none">
+            <a:spAutoFit/>
+          </a:bodyPr>
+          <a:lstStyle/>
           <a:p>
             <a:pPr algn="l">
               <a:spcAft>
@@ -3704,27 +3999,27 @@
               </a:spcAft>
             </a:pPr>
             <a:r>
-              <a:rPr sz="3000" b="1">
+              <a:rPr sz="3200" b="1">
                 <a:solidFill>
                   <a:srgbClr val="E8EAF2"/>
                 </a:solidFill>
                 <a:latin typeface="Helvetica Neue"/>
               </a:rPr>
-              <a:t>Local-first agent stack: cheap work local, frontier only for the hard step</a:t>
-            </a:r>
-          </a:p>
-        </p:txBody>
-      </p:sp>
-      <p:sp>
-        <p:nvSpPr>
-          <p:cNvPr id="4" name="TextBox 3"/>
+              <a:t>You, on a real repo, all day</a:t>
+            </a:r>
+          </a:p>
+        </p:txBody>
+      </p:sp>
+      <p:sp>
+        <p:nvSpPr>
+          <p:cNvPr id="7" name="TextBox 6"/>
           <p:cNvSpPr txBox="1"/>
           <p:nvPr/>
         </p:nvSpPr>
         <p:spPr>
           <a:xfrm>
-            <a:off x="822960" y="2011680"/>
-            <a:ext cx="10607040" cy="3108960"/>
+            <a:off x="548640" y="2011680"/>
+            <a:ext cx="10972800" cy="3200400"/>
           </a:xfrm>
           <a:prstGeom prst="rect">
             <a:avLst/>
@@ -3743,21 +4038,13 @@
               </a:spcAft>
             </a:pPr>
             <a:r>
-              <a:rPr sz="2000" b="1">
-                <a:solidFill>
-                  <a:srgbClr val="2DD4A7"/>
+              <a:rPr sz="1900" b="0">
+                <a:solidFill>
+                  <a:srgbClr val="E8EAF2"/>
                 </a:solidFill>
                 <a:latin typeface="Helvetica Neue"/>
               </a:rPr>
-              <a:t>$0 local indexer  —  </a:t>
-            </a:r>
-            <a:r>
-              <a:rPr sz="1800">
-                <a:solidFill>
-                  <a:srgbClr val="E8EAF2"/>
-                </a:solidFill>
-              </a:rPr>
-              <a:t>commit-versioned code DAG → SKILL.md bundle, refreshed on every change</a:t>
+              <a:t>•  Solo founder / small team living in Claude Code or Codex on one codebase.</a:t>
             </a:r>
           </a:p>
           <a:p>
@@ -3767,21 +4054,13 @@
               </a:spcAft>
             </a:pPr>
             <a:r>
-              <a:rPr sz="2000" b="1">
-                <a:solidFill>
-                  <a:srgbClr val="4AA8FF"/>
+              <a:rPr sz="1900" b="0">
+                <a:solidFill>
+                  <a:srgbClr val="E8EAF2"/>
                 </a:solidFill>
                 <a:latin typeface="Helvetica Neue"/>
               </a:rPr>
-              <a:t>Selective retrieval  —  </a:t>
-            </a:r>
-            <a:r>
-              <a:rPr sz="1800">
-                <a:solidFill>
-                  <a:srgbClr val="E8EAF2"/>
-                </a:solidFill>
-              </a:rPr>
-              <a:t>Repoformer gate + GraphCoder-style symbol graph + LLavaCode compression</a:t>
+              <a:t>•  Asking codebase questions, fixing tests, scaffolding, refactoring — dozens of times a day.</a:t>
             </a:r>
           </a:p>
           <a:p>
@@ -3791,21 +4070,13 @@
               </a:spcAft>
             </a:pPr>
             <a:r>
-              <a:rPr sz="2000" b="1">
-                <a:solidFill>
-                  <a:srgbClr val="A78BFA"/>
+              <a:rPr sz="1900" b="0">
+                <a:solidFill>
+                  <a:srgbClr val="E8EAF2"/>
                 </a:solidFill>
                 <a:latin typeface="Helvetica Neue"/>
               </a:rPr>
-              <a:t>Local subagents + RLM  —  </a:t>
-            </a:r>
-            <a:r>
-              <a:rPr sz="1800">
-                <a:solidFill>
-                  <a:srgbClr val="E8EAF2"/>
-                </a:solidFill>
-              </a:rPr>
-              <a:t>routing, search, code checks, summarize — escalate only when needed</a:t>
+              <a:t>•  Each ask re-pays for repo discovery. The bill compounds outside the model call.</a:t>
             </a:r>
           </a:p>
           <a:p>
@@ -3815,84 +4086,13 @@
               </a:spcAft>
             </a:pPr>
             <a:r>
-              <a:rPr sz="2000" b="1">
-                <a:solidFill>
-                  <a:srgbClr val="FF7849"/>
+              <a:rPr sz="1900" b="0">
+                <a:solidFill>
+                  <a:srgbClr val="E8EAF2"/>
                 </a:solidFill>
                 <a:latin typeface="Helvetica Neue"/>
               </a:rPr>
-              <a:t>Eval harness  —  </a:t>
-            </a:r>
-            <a:r>
-              <a:rPr sz="1800">
-                <a:solidFill>
-                  <a:srgbClr val="E8EAF2"/>
-                </a:solidFill>
-              </a:rPr>
-              <a:t>measures tokens / time / accuracy vs normal Claude Code (the real product)</a:t>
-            </a:r>
-          </a:p>
-        </p:txBody>
-      </p:sp>
-      <p:sp>
-        <p:nvSpPr>
-          <p:cNvPr id="5" name="TextBox 4"/>
-          <p:cNvSpPr txBox="1"/>
-          <p:nvPr/>
-        </p:nvSpPr>
-        <p:spPr>
-          <a:xfrm>
-            <a:off x="822960" y="5303520"/>
-            <a:ext cx="10515600" cy="1097280"/>
-          </a:xfrm>
-          <a:prstGeom prst="rect">
-            <a:avLst/>
-          </a:prstGeom>
-          <a:noFill/>
-        </p:spPr>
-        <p:txBody>
-          <a:bodyPr wrap="none">
-            <a:spAutoFit/>
-          </a:bodyPr>
-          <a:lstStyle/>
-          <a:p>
-            <a:pPr algn="l">
-              <a:spcAft>
-                <a:spcPts val="600"/>
-              </a:spcAft>
-            </a:pPr>
-            <a:r>
-              <a:rPr sz="1600" b="1">
-                <a:solidFill>
-                  <a:srgbClr val="9AA0B6"/>
-                </a:solidFill>
-                <a:latin typeface="Helvetica Neue"/>
-              </a:rPr>
-              <a:t>Sponsors</a:t>
-            </a:r>
-          </a:p>
-          <a:p>
-            <a:pPr algn="l">
-              <a:spcAft>
-                <a:spcPts val="600"/>
-              </a:spcAft>
-            </a:pPr>
-            <a:r>
-              <a:rPr sz="1700" b="0">
-                <a:solidFill>
-                  <a:srgbClr val="2DD4A7"/>
-                </a:solidFill>
-                <a:latin typeface="Helvetica Neue"/>
-              </a:rPr>
-              <a:t>EverMind/EverOS = long-term agent memory (built on it).   </a:t>
-            </a:r>
-            <a:r>
-              <a:rPr sz="1700">
-                <a:solidFill>
-                  <a:srgbClr val="4AA8FF"/>
-                </a:solidFill>
-              </a:rPr>
-              <a:t>Butterbase = backend + judging surface (build0530).</a:t>
+              <a:t>•  You want the agent to already know your files, conventions, and prior decisions.</a:t>
             </a:r>
           </a:p>
         </p:txBody>
@@ -3961,80 +4161,23 @@
       </p:sp>
       <p:sp>
         <p:nvSpPr>
-          <p:cNvPr id="3" name="TextBox 2"/>
-          <p:cNvSpPr txBox="1"/>
+          <p:cNvPr id="3" name="Rectangle 2"/>
+          <p:cNvSpPr/>
           <p:nvPr/>
         </p:nvSpPr>
         <p:spPr>
           <a:xfrm>
-            <a:off x="822960" y="548640"/>
-            <a:ext cx="10515600" cy="822960"/>
+            <a:off x="0" y="0"/>
+            <a:ext cx="128016" cy="6858000"/>
           </a:xfrm>
           <a:prstGeom prst="rect">
             <a:avLst/>
           </a:prstGeom>
-          <a:noFill/>
-        </p:spPr>
-        <p:txBody>
-          <a:bodyPr wrap="none">
-            <a:spAutoFit/>
-          </a:bodyPr>
-          <a:lstStyle/>
-          <a:p>
-            <a:pPr algn="l">
-              <a:spcAft>
-                <a:spcPts val="600"/>
-              </a:spcAft>
-            </a:pPr>
-            <a:r>
-              <a:rPr sz="1600" b="1">
-                <a:solidFill>
-                  <a:srgbClr val="2DD4A7"/>
-                </a:solidFill>
-                <a:latin typeface="Helvetica Neue"/>
-              </a:rPr>
-              <a:t>The proof  ·  autopilot eval (measured)</a:t>
-            </a:r>
-          </a:p>
-          <a:p>
-            <a:pPr algn="l">
-              <a:spcAft>
-                <a:spcPts val="600"/>
-              </a:spcAft>
-            </a:pPr>
-            <a:r>
-              <a:rPr sz="3000" b="1">
-                <a:solidFill>
-                  <a:srgbClr val="E8EAF2"/>
-                </a:solidFill>
-                <a:latin typeface="Helvetica Neue"/>
-              </a:rPr>
-              <a:t>local-first (indexed)  vs  normal Claude Code</a:t>
-            </a:r>
-          </a:p>
-        </p:txBody>
-      </p:sp>
-      <p:sp>
-        <p:nvSpPr>
-          <p:cNvPr id="4" name="Rounded Rectangle 3"/>
-          <p:cNvSpPr/>
-          <p:nvPr/>
-        </p:nvSpPr>
-        <p:spPr>
-          <a:xfrm>
-            <a:off x="822960" y="1920240"/>
-            <a:ext cx="2606040" cy="1737360"/>
-          </a:xfrm>
-          <a:prstGeom prst="roundRect">
-            <a:avLst/>
-          </a:prstGeom>
           <a:solidFill>
-            <a:srgbClr val="10131E"/>
+            <a:srgbClr val="2DD4A7"/>
           </a:solidFill>
-          <a:ln w="19050">
-            <a:solidFill>
-              <a:srgbClr val="2DD4A7"/>
-            </a:solidFill>
+          <a:ln>
+            <a:noFill/>
           </a:ln>
           <a:effectLst/>
         </p:spPr>
@@ -4056,60 +4199,285 @@
           <a:bodyPr rtlCol="0" anchor="ctr"/>
           <a:lstStyle/>
           <a:p>
-            <a:pPr algn="ctr">
-              <a:spcAft>
-                <a:spcPts val="200"/>
-              </a:spcAft>
-            </a:pPr>
-            <a:r>
-              <a:rPr sz="4000" b="1">
-                <a:solidFill>
-                  <a:srgbClr val="2DD4A7"/>
-                </a:solidFill>
-                <a:latin typeface="Helvetica Neue"/>
-              </a:rPr>
-              <a:t>−98.7%</a:t>
-            </a:r>
-          </a:p>
-          <a:p>
-            <a:pPr algn="ctr">
+            <a:pPr algn="ctr"/>
+          </a:p>
+        </p:txBody>
+      </p:sp>
+      <p:sp>
+        <p:nvSpPr>
+          <p:cNvPr id="4" name="TextBox 3"/>
+          <p:cNvSpPr txBox="1"/>
+          <p:nvPr/>
+        </p:nvSpPr>
+        <p:spPr>
+          <a:xfrm>
+            <a:off x="548640" y="6400800"/>
+            <a:ext cx="11155680" cy="365760"/>
+          </a:xfrm>
+          <a:prstGeom prst="rect">
+            <a:avLst/>
+          </a:prstGeom>
+          <a:noFill/>
+        </p:spPr>
+        <p:txBody>
+          <a:bodyPr wrap="none">
+            <a:spAutoFit/>
+          </a:bodyPr>
+          <a:lstStyle/>
+          <a:p>
+            <a:r>
+              <a:rPr sz="1000">
+                <a:solidFill>
+                  <a:srgbClr val="9AA0B6"/>
+                </a:solidFill>
+              </a:rPr>
+              <a:t>EverMind + Butterbase: LIVE  ·  app_b197i2548pk2  ·  build0530</a:t>
+            </a:r>
+            <a:r>
+              <a:rPr sz="1000">
+                <a:solidFill>
+                  <a:srgbClr val="9AA0B6"/>
+                </a:solidFill>
+              </a:rPr>
+              <a:t>        4/6</a:t>
+            </a:r>
+          </a:p>
+        </p:txBody>
+      </p:sp>
+      <p:sp>
+        <p:nvSpPr>
+          <p:cNvPr id="5" name="TextBox 4"/>
+          <p:cNvSpPr txBox="1"/>
+          <p:nvPr/>
+        </p:nvSpPr>
+        <p:spPr>
+          <a:xfrm>
+            <a:off x="548640" y="502920"/>
+            <a:ext cx="10972800" cy="457200"/>
+          </a:xfrm>
+          <a:prstGeom prst="rect">
+            <a:avLst/>
+          </a:prstGeom>
+          <a:noFill/>
+        </p:spPr>
+        <p:txBody>
+          <a:bodyPr wrap="none">
+            <a:spAutoFit/>
+          </a:bodyPr>
+          <a:lstStyle/>
+          <a:p>
+            <a:pPr algn="l">
               <a:spcAft>
                 <a:spcPts val="600"/>
               </a:spcAft>
             </a:pPr>
             <a:r>
-              <a:rPr sz="1600" b="0">
-                <a:solidFill>
-                  <a:srgbClr val="9AA0B6"/>
+              <a:rPr sz="1500" b="1">
+                <a:solidFill>
+                  <a:srgbClr val="2DD4A7"/>
                 </a:solidFill>
                 <a:latin typeface="Helvetica Neue"/>
               </a:rPr>
-              <a:t>tokens</a:t>
-            </a:r>
-          </a:p>
-        </p:txBody>
-      </p:sp>
-      <p:sp>
-        <p:nvSpPr>
-          <p:cNvPr id="5" name="Rounded Rectangle 4"/>
+              <a:t>THE FIX</a:t>
+            </a:r>
+          </a:p>
+        </p:txBody>
+      </p:sp>
+      <p:sp>
+        <p:nvSpPr>
+          <p:cNvPr id="6" name="TextBox 5"/>
+          <p:cNvSpPr txBox="1"/>
+          <p:nvPr/>
+        </p:nvSpPr>
+        <p:spPr>
+          <a:xfrm>
+            <a:off x="548640" y="914400"/>
+            <a:ext cx="10972800" cy="822960"/>
+          </a:xfrm>
+          <a:prstGeom prst="rect">
+            <a:avLst/>
+          </a:prstGeom>
+          <a:noFill/>
+        </p:spPr>
+        <p:txBody>
+          <a:bodyPr wrap="none">
+            <a:spAutoFit/>
+          </a:bodyPr>
+          <a:lstStyle/>
+          <a:p>
+            <a:pPr algn="l">
+              <a:spcAft>
+                <a:spcPts val="600"/>
+              </a:spcAft>
+            </a:pPr>
+            <a:r>
+              <a:rPr sz="2800" b="1">
+                <a:solidFill>
+                  <a:srgbClr val="E8EAF2"/>
+                </a:solidFill>
+                <a:latin typeface="Helvetica Neue"/>
+              </a:rPr>
+              <a:t>A $0 local map Claude reads instead of the whole repo</a:t>
+            </a:r>
+          </a:p>
+        </p:txBody>
+      </p:sp>
+      <p:sp>
+        <p:nvSpPr>
+          <p:cNvPr id="7" name="TextBox 6"/>
+          <p:cNvSpPr txBox="1"/>
+          <p:nvPr/>
+        </p:nvSpPr>
+        <p:spPr>
+          <a:xfrm>
+            <a:off x="548640" y="1874519"/>
+            <a:ext cx="11064240" cy="2926080"/>
+          </a:xfrm>
+          <a:prstGeom prst="rect">
+            <a:avLst/>
+          </a:prstGeom>
+          <a:noFill/>
+        </p:spPr>
+        <p:txBody>
+          <a:bodyPr wrap="none">
+            <a:spAutoFit/>
+          </a:bodyPr>
+          <a:lstStyle/>
+          <a:p>
+            <a:pPr algn="l">
+              <a:spcAft>
+                <a:spcPts val="1400"/>
+              </a:spcAft>
+            </a:pPr>
+            <a:r>
+              <a:rPr sz="1900" b="1">
+                <a:solidFill>
+                  <a:srgbClr val="2DD4A7"/>
+                </a:solidFill>
+                <a:latin typeface="Helvetica Neue"/>
+              </a:rPr>
+              <a:t>SKILL.md + DAG  —  </a:t>
+            </a:r>
+            <a:r>
+              <a:rPr sz="1700">
+                <a:solidFill>
+                  <a:srgbClr val="E8EAF2"/>
+                </a:solidFill>
+              </a:rPr>
+              <a:t>commit-versioned: every file, every function, the call graph — refreshed on each change</a:t>
+            </a:r>
+          </a:p>
+          <a:p>
+            <a:pPr algn="l">
+              <a:spcAft>
+                <a:spcPts val="1400"/>
+              </a:spcAft>
+            </a:pPr>
+            <a:r>
+              <a:rPr sz="1900" b="1">
+                <a:solidFill>
+                  <a:srgbClr val="4AA8FF"/>
+                </a:solidFill>
+                <a:latin typeface="Helvetica Neue"/>
+              </a:rPr>
+              <a:t>Selective retrieval  —  </a:t>
+            </a:r>
+            <a:r>
+              <a:rPr sz="1700">
+                <a:solidFill>
+                  <a:srgbClr val="E8EAF2"/>
+                </a:solidFill>
+              </a:rPr>
+              <a:t>send only the relevant slice, compressed (8.8× on a real query)</a:t>
+            </a:r>
+          </a:p>
+          <a:p>
+            <a:pPr algn="l">
+              <a:spcAft>
+                <a:spcPts val="1400"/>
+              </a:spcAft>
+            </a:pPr>
+            <a:r>
+              <a:rPr sz="1900" b="1">
+                <a:solidFill>
+                  <a:srgbClr val="A78BFA"/>
+                </a:solidFill>
+                <a:latin typeface="Helvetica Neue"/>
+              </a:rPr>
+              <a:t>$0 + local  —  </a:t>
+            </a:r>
+            <a:r>
+              <a:rPr sz="1700">
+                <a:solidFill>
+                  <a:srgbClr val="E8EAF2"/>
+                </a:solidFill>
+              </a:rPr>
+              <a:t>the index runs on your machine for nothing; frontier is used only for the hard step</a:t>
+            </a:r>
+          </a:p>
+          <a:p>
+            <a:pPr algn="l">
+              <a:spcAft>
+                <a:spcPts val="1400"/>
+              </a:spcAft>
+            </a:pPr>
+            <a:r>
+              <a:rPr sz="1900" b="1">
+                <a:solidFill>
+                  <a:srgbClr val="FF7849"/>
+                </a:solidFill>
+                <a:latin typeface="Helvetica Neue"/>
+              </a:rPr>
+              <a:t>Sponsors  —  </a:t>
+            </a:r>
+            <a:r>
+              <a:rPr sz="1700">
+                <a:solidFill>
+                  <a:srgbClr val="E8EAF2"/>
+                </a:solidFill>
+              </a:rPr>
+              <a:t>EverMind = long-term memory (prior decisions) · Butterbase = state/backend + judging</a:t>
+            </a:r>
+          </a:p>
+        </p:txBody>
+      </p:sp>
+    </p:spTree>
+  </p:cSld>
+  <p:clrMapOvr>
+    <a:masterClrMapping/>
+  </p:clrMapOvr>
+</p:sld>
+</file>
+
+<file path=ppt/slides/slide5.xml><?xml version="1.0" encoding="utf-8"?>
+<p:sld xmlns:a="http://schemas.openxmlformats.org/drawingml/2006/main" xmlns:p="http://schemas.openxmlformats.org/presentationml/2006/main" xmlns:r="http://schemas.openxmlformats.org/officeDocument/2006/relationships">
+  <p:cSld>
+    <p:spTree>
+      <p:nvGrpSpPr>
+        <p:cNvPr id="1" name=""/>
+        <p:cNvGrpSpPr/>
+        <p:nvPr/>
+      </p:nvGrpSpPr>
+      <p:grpSpPr/>
+      <p:sp>
+        <p:nvSpPr>
+          <p:cNvPr id="2" name="Rectangle 1"/>
           <p:cNvSpPr/>
           <p:nvPr/>
         </p:nvSpPr>
         <p:spPr>
           <a:xfrm>
-            <a:off x="3566160" y="1920240"/>
-            <a:ext cx="2606040" cy="1737360"/>
-          </a:xfrm>
-          <a:prstGeom prst="roundRect">
+            <a:off x="0" y="0"/>
+            <a:ext cx="12191695" cy="6858000"/>
+          </a:xfrm>
+          <a:prstGeom prst="rect">
             <a:avLst/>
           </a:prstGeom>
           <a:solidFill>
-            <a:srgbClr val="10131E"/>
+            <a:srgbClr val="0A0C14"/>
           </a:solidFill>
-          <a:ln w="19050">
-            <a:solidFill>
-              <a:srgbClr val="4AA8FF"/>
-            </a:solidFill>
+          <a:ln>
+            <a:noFill/>
           </a:ln>
           <a:effectLst/>
         </p:spPr>
@@ -4131,60 +4499,29 @@
           <a:bodyPr rtlCol="0" anchor="ctr"/>
           <a:lstStyle/>
           <a:p>
-            <a:pPr algn="ctr">
-              <a:spcAft>
-                <a:spcPts val="200"/>
-              </a:spcAft>
-            </a:pPr>
-            <a:r>
-              <a:rPr sz="4000" b="1">
-                <a:solidFill>
-                  <a:srgbClr val="4AA8FF"/>
-                </a:solidFill>
-                <a:latin typeface="Helvetica Neue"/>
-              </a:rPr>
-              <a:t>−98.0%</a:t>
-            </a:r>
-          </a:p>
-          <a:p>
-            <a:pPr algn="ctr">
-              <a:spcAft>
-                <a:spcPts val="600"/>
-              </a:spcAft>
-            </a:pPr>
-            <a:r>
-              <a:rPr sz="1600" b="0">
-                <a:solidFill>
-                  <a:srgbClr val="9AA0B6"/>
-                </a:solidFill>
-                <a:latin typeface="Helvetica Neue"/>
-              </a:rPr>
-              <a:t>time</a:t>
-            </a:r>
-          </a:p>
-        </p:txBody>
-      </p:sp>
-      <p:sp>
-        <p:nvSpPr>
-          <p:cNvPr id="6" name="Rounded Rectangle 5"/>
+            <a:pPr algn="ctr"/>
+          </a:p>
+        </p:txBody>
+      </p:sp>
+      <p:sp>
+        <p:nvSpPr>
+          <p:cNvPr id="3" name="Rectangle 2"/>
           <p:cNvSpPr/>
           <p:nvPr/>
         </p:nvSpPr>
         <p:spPr>
           <a:xfrm>
-            <a:off x="6309360" y="1920240"/>
-            <a:ext cx="2606040" cy="1737360"/>
-          </a:xfrm>
-          <a:prstGeom prst="roundRect">
+            <a:off x="0" y="0"/>
+            <a:ext cx="128016" cy="6858000"/>
+          </a:xfrm>
+          <a:prstGeom prst="rect">
             <a:avLst/>
           </a:prstGeom>
           <a:solidFill>
-            <a:srgbClr val="10131E"/>
+            <a:srgbClr val="2DD4A7"/>
           </a:solidFill>
-          <a:ln w="19050">
-            <a:solidFill>
-              <a:srgbClr val="A78BFA"/>
-            </a:solidFill>
+          <a:ln>
+            <a:noFill/>
           </a:ln>
           <a:effectLst/>
         </p:spPr>
@@ -4206,60 +4543,285 @@
           <a:bodyPr rtlCol="0" anchor="ctr"/>
           <a:lstStyle/>
           <a:p>
-            <a:pPr algn="ctr">
-              <a:spcAft>
-                <a:spcPts val="200"/>
-              </a:spcAft>
-            </a:pPr>
-            <a:r>
-              <a:rPr sz="4000" b="1">
-                <a:solidFill>
-                  <a:srgbClr val="A78BFA"/>
-                </a:solidFill>
-                <a:latin typeface="Helvetica Neue"/>
-              </a:rPr>
-              <a:t>−93.9%</a:t>
-            </a:r>
-          </a:p>
-          <a:p>
-            <a:pPr algn="ctr">
+            <a:pPr algn="ctr"/>
+          </a:p>
+        </p:txBody>
+      </p:sp>
+      <p:sp>
+        <p:nvSpPr>
+          <p:cNvPr id="4" name="TextBox 3"/>
+          <p:cNvSpPr txBox="1"/>
+          <p:nvPr/>
+        </p:nvSpPr>
+        <p:spPr>
+          <a:xfrm>
+            <a:off x="548640" y="6400800"/>
+            <a:ext cx="11155680" cy="365760"/>
+          </a:xfrm>
+          <a:prstGeom prst="rect">
+            <a:avLst/>
+          </a:prstGeom>
+          <a:noFill/>
+        </p:spPr>
+        <p:txBody>
+          <a:bodyPr wrap="none">
+            <a:spAutoFit/>
+          </a:bodyPr>
+          <a:lstStyle/>
+          <a:p>
+            <a:r>
+              <a:rPr sz="1000">
+                <a:solidFill>
+                  <a:srgbClr val="9AA0B6"/>
+                </a:solidFill>
+              </a:rPr>
+              <a:t>EverMind + Butterbase: LIVE  ·  app_b197i2548pk2  ·  build0530</a:t>
+            </a:r>
+            <a:r>
+              <a:rPr sz="1000">
+                <a:solidFill>
+                  <a:srgbClr val="9AA0B6"/>
+                </a:solidFill>
+              </a:rPr>
+              <a:t>        5/6</a:t>
+            </a:r>
+          </a:p>
+        </p:txBody>
+      </p:sp>
+      <p:sp>
+        <p:nvSpPr>
+          <p:cNvPr id="5" name="TextBox 4"/>
+          <p:cNvSpPr txBox="1"/>
+          <p:nvPr/>
+        </p:nvSpPr>
+        <p:spPr>
+          <a:xfrm>
+            <a:off x="548640" y="502920"/>
+            <a:ext cx="10972800" cy="457200"/>
+          </a:xfrm>
+          <a:prstGeom prst="rect">
+            <a:avLst/>
+          </a:prstGeom>
+          <a:noFill/>
+        </p:spPr>
+        <p:txBody>
+          <a:bodyPr wrap="none">
+            <a:spAutoFit/>
+          </a:bodyPr>
+          <a:lstStyle/>
+          <a:p>
+            <a:pPr algn="l">
               <a:spcAft>
                 <a:spcPts val="600"/>
               </a:spcAft>
             </a:pPr>
             <a:r>
-              <a:rPr sz="1600" b="0">
-                <a:solidFill>
-                  <a:srgbClr val="9AA0B6"/>
+              <a:rPr sz="1500" b="1">
+                <a:solidFill>
+                  <a:srgbClr val="2DD4A7"/>
                 </a:solidFill>
                 <a:latin typeface="Helvetica Neue"/>
               </a:rPr>
-              <a:t>cost</a:t>
-            </a:r>
-          </a:p>
-        </p:txBody>
-      </p:sp>
-      <p:sp>
-        <p:nvSpPr>
-          <p:cNvPr id="7" name="Rounded Rectangle 6"/>
+              <a:t>DEMO FLOW  (what I'll show live)</a:t>
+            </a:r>
+          </a:p>
+        </p:txBody>
+      </p:sp>
+      <p:sp>
+        <p:nvSpPr>
+          <p:cNvPr id="6" name="TextBox 5"/>
+          <p:cNvSpPr txBox="1"/>
+          <p:nvPr/>
+        </p:nvSpPr>
+        <p:spPr>
+          <a:xfrm>
+            <a:off x="548640" y="914400"/>
+            <a:ext cx="10972800" cy="731520"/>
+          </a:xfrm>
+          <a:prstGeom prst="rect">
+            <a:avLst/>
+          </a:prstGeom>
+          <a:noFill/>
+        </p:spPr>
+        <p:txBody>
+          <a:bodyPr wrap="none">
+            <a:spAutoFit/>
+          </a:bodyPr>
+          <a:lstStyle/>
+          <a:p>
+            <a:pPr algn="l">
+              <a:spcAft>
+                <a:spcPts val="600"/>
+              </a:spcAft>
+            </a:pPr>
+            <a:r>
+              <a:rPr sz="3000" b="1">
+                <a:solidFill>
+                  <a:srgbClr val="E8EAF2"/>
+                </a:solidFill>
+                <a:latin typeface="Helvetica Neue"/>
+              </a:rPr>
+              <a:t>Watch the token meter drop</a:t>
+            </a:r>
+          </a:p>
+        </p:txBody>
+      </p:sp>
+      <p:sp>
+        <p:nvSpPr>
+          <p:cNvPr id="7" name="TextBox 6"/>
+          <p:cNvSpPr txBox="1"/>
+          <p:nvPr/>
+        </p:nvSpPr>
+        <p:spPr>
+          <a:xfrm>
+            <a:off x="548640" y="1828800"/>
+            <a:ext cx="11064240" cy="3291840"/>
+          </a:xfrm>
+          <a:prstGeom prst="rect">
+            <a:avLst/>
+          </a:prstGeom>
+          <a:noFill/>
+        </p:spPr>
+        <p:txBody>
+          <a:bodyPr wrap="none">
+            <a:spAutoFit/>
+          </a:bodyPr>
+          <a:lstStyle/>
+          <a:p>
+            <a:pPr algn="l">
+              <a:spcAft>
+                <a:spcPts val="1600"/>
+              </a:spcAft>
+            </a:pPr>
+            <a:r>
+              <a:rPr sz="2000" b="1">
+                <a:solidFill>
+                  <a:srgbClr val="FF7849"/>
+                </a:solidFill>
+                <a:latin typeface="Helvetica Neue"/>
+              </a:rPr>
+              <a:t>1.  </a:t>
+            </a:r>
+            <a:r>
+              <a:rPr sz="1800">
+                <a:solidFill>
+                  <a:srgbClr val="E8EAF2"/>
+                </a:solidFill>
+              </a:rPr>
+              <a:t>Ask a codebase question the normal way → Claude Code explores files (big token count).</a:t>
+            </a:r>
+          </a:p>
+          <a:p>
+            <a:pPr algn="l">
+              <a:spcAft>
+                <a:spcPts val="1600"/>
+              </a:spcAft>
+            </a:pPr>
+            <a:r>
+              <a:rPr sz="2000" b="1">
+                <a:solidFill>
+                  <a:srgbClr val="2DD4A7"/>
+                </a:solidFill>
+                <a:latin typeface="Helvetica Neue"/>
+              </a:rPr>
+              <a:t>2.  </a:t>
+            </a:r>
+            <a:r>
+              <a:rPr sz="1800">
+                <a:solidFill>
+                  <a:srgbClr val="E8EAF2"/>
+                </a:solidFill>
+              </a:rPr>
+              <a:t>Run  `autopilot index`  → open .autopilot/SKILL.md + ARCHITECTURE.md (the DAG).</a:t>
+            </a:r>
+          </a:p>
+          <a:p>
+            <a:pPr algn="l">
+              <a:spcAft>
+                <a:spcPts val="1600"/>
+              </a:spcAft>
+            </a:pPr>
+            <a:r>
+              <a:rPr sz="2000" b="1">
+                <a:solidFill>
+                  <a:srgbClr val="4AA8FF"/>
+                </a:solidFill>
+                <a:latin typeface="Helvetica Neue"/>
+              </a:rPr>
+              <a:t>3.  </a:t>
+            </a:r>
+            <a:r>
+              <a:rPr sz="1800">
+                <a:solidFill>
+                  <a:srgbClr val="E8EAF2"/>
+                </a:solidFill>
+              </a:rPr>
+              <a:t>Ask again with that saved context → answer from the right slice (tiny token count).</a:t>
+            </a:r>
+          </a:p>
+          <a:p>
+            <a:pPr algn="l">
+              <a:spcAft>
+                <a:spcPts val="1600"/>
+              </a:spcAft>
+            </a:pPr>
+            <a:r>
+              <a:rPr sz="2000" b="1">
+                <a:solidFill>
+                  <a:srgbClr val="A78BFA"/>
+                </a:solidFill>
+                <a:latin typeface="Helvetica Neue"/>
+              </a:rPr>
+              <a:t>4.  </a:t>
+            </a:r>
+            <a:r>
+              <a:rPr sz="1800">
+                <a:solidFill>
+                  <a:srgbClr val="E8EAF2"/>
+                </a:solidFill>
+              </a:rPr>
+              <a:t>Compare:  `autopilot eval`  → 11,947 → 299 tokens, −98.7%, tests still pass.</a:t>
+            </a:r>
+          </a:p>
+        </p:txBody>
+      </p:sp>
+    </p:spTree>
+  </p:cSld>
+  <p:clrMapOvr>
+    <a:masterClrMapping/>
+  </p:clrMapOvr>
+</p:sld>
+</file>
+
+<file path=ppt/slides/slide6.xml><?xml version="1.0" encoding="utf-8"?>
+<p:sld xmlns:a="http://schemas.openxmlformats.org/drawingml/2006/main" xmlns:p="http://schemas.openxmlformats.org/presentationml/2006/main" xmlns:r="http://schemas.openxmlformats.org/officeDocument/2006/relationships">
+  <p:cSld>
+    <p:spTree>
+      <p:nvGrpSpPr>
+        <p:cNvPr id="1" name=""/>
+        <p:cNvGrpSpPr/>
+        <p:nvPr/>
+      </p:nvGrpSpPr>
+      <p:grpSpPr/>
+      <p:sp>
+        <p:nvSpPr>
+          <p:cNvPr id="2" name="Rectangle 1"/>
           <p:cNvSpPr/>
           <p:nvPr/>
         </p:nvSpPr>
         <p:spPr>
           <a:xfrm>
-            <a:off x="9052560" y="1920240"/>
-            <a:ext cx="2606040" cy="1737360"/>
-          </a:xfrm>
-          <a:prstGeom prst="roundRect">
+            <a:off x="0" y="0"/>
+            <a:ext cx="12191695" cy="6858000"/>
+          </a:xfrm>
+          <a:prstGeom prst="rect">
             <a:avLst/>
           </a:prstGeom>
           <a:solidFill>
-            <a:srgbClr val="10131E"/>
+            <a:srgbClr val="0A0C14"/>
           </a:solidFill>
-          <a:ln w="19050">
-            <a:solidFill>
-              <a:srgbClr val="FF7849"/>
-            </a:solidFill>
+          <a:ln>
+            <a:noFill/>
           </a:ln>
           <a:effectLst/>
         </p:spPr>
@@ -4281,6 +4843,215 @@
           <a:bodyPr rtlCol="0" anchor="ctr"/>
           <a:lstStyle/>
           <a:p>
+            <a:pPr algn="ctr"/>
+          </a:p>
+        </p:txBody>
+      </p:sp>
+      <p:sp>
+        <p:nvSpPr>
+          <p:cNvPr id="3" name="Rectangle 2"/>
+          <p:cNvSpPr/>
+          <p:nvPr/>
+        </p:nvSpPr>
+        <p:spPr>
+          <a:xfrm>
+            <a:off x="0" y="0"/>
+            <a:ext cx="128016" cy="6858000"/>
+          </a:xfrm>
+          <a:prstGeom prst="rect">
+            <a:avLst/>
+          </a:prstGeom>
+          <a:solidFill>
+            <a:srgbClr val="2DD4A7"/>
+          </a:solidFill>
+          <a:ln>
+            <a:noFill/>
+          </a:ln>
+          <a:effectLst/>
+        </p:spPr>
+        <p:style>
+          <a:lnRef idx="1">
+            <a:schemeClr val="accent1"/>
+          </a:lnRef>
+          <a:fillRef idx="3">
+            <a:schemeClr val="accent1"/>
+          </a:fillRef>
+          <a:effectRef idx="2">
+            <a:schemeClr val="accent1"/>
+          </a:effectRef>
+          <a:fontRef idx="minor">
+            <a:schemeClr val="lt1"/>
+          </a:fontRef>
+        </p:style>
+        <p:txBody>
+          <a:bodyPr rtlCol="0" anchor="ctr"/>
+          <a:lstStyle/>
+          <a:p>
+            <a:pPr algn="ctr"/>
+          </a:p>
+        </p:txBody>
+      </p:sp>
+      <p:sp>
+        <p:nvSpPr>
+          <p:cNvPr id="4" name="TextBox 3"/>
+          <p:cNvSpPr txBox="1"/>
+          <p:nvPr/>
+        </p:nvSpPr>
+        <p:spPr>
+          <a:xfrm>
+            <a:off x="548640" y="6400800"/>
+            <a:ext cx="11155680" cy="365760"/>
+          </a:xfrm>
+          <a:prstGeom prst="rect">
+            <a:avLst/>
+          </a:prstGeom>
+          <a:noFill/>
+        </p:spPr>
+        <p:txBody>
+          <a:bodyPr wrap="none">
+            <a:spAutoFit/>
+          </a:bodyPr>
+          <a:lstStyle/>
+          <a:p>
+            <a:r>
+              <a:rPr sz="1000">
+                <a:solidFill>
+                  <a:srgbClr val="9AA0B6"/>
+                </a:solidFill>
+              </a:rPr>
+              <a:t>EverMind + Butterbase: LIVE  ·  app_b197i2548pk2  ·  build0530</a:t>
+            </a:r>
+            <a:r>
+              <a:rPr sz="1000">
+                <a:solidFill>
+                  <a:srgbClr val="9AA0B6"/>
+                </a:solidFill>
+              </a:rPr>
+              <a:t>        6/6</a:t>
+            </a:r>
+          </a:p>
+        </p:txBody>
+      </p:sp>
+      <p:sp>
+        <p:nvSpPr>
+          <p:cNvPr id="5" name="TextBox 4"/>
+          <p:cNvSpPr txBox="1"/>
+          <p:nvPr/>
+        </p:nvSpPr>
+        <p:spPr>
+          <a:xfrm>
+            <a:off x="548640" y="502920"/>
+            <a:ext cx="10972800" cy="457200"/>
+          </a:xfrm>
+          <a:prstGeom prst="rect">
+            <a:avLst/>
+          </a:prstGeom>
+          <a:noFill/>
+        </p:spPr>
+        <p:txBody>
+          <a:bodyPr wrap="none">
+            <a:spAutoFit/>
+          </a:bodyPr>
+          <a:lstStyle/>
+          <a:p>
+            <a:pPr algn="l">
+              <a:spcAft>
+                <a:spcPts val="600"/>
+              </a:spcAft>
+            </a:pPr>
+            <a:r>
+              <a:rPr sz="1500" b="1">
+                <a:solidFill>
+                  <a:srgbClr val="2DD4A7"/>
+                </a:solidFill>
+                <a:latin typeface="Helvetica Neue"/>
+              </a:rPr>
+              <a:t>PROOF  ·  autopilot eval (measured)</a:t>
+            </a:r>
+          </a:p>
+        </p:txBody>
+      </p:sp>
+      <p:sp>
+        <p:nvSpPr>
+          <p:cNvPr id="6" name="TextBox 5"/>
+          <p:cNvSpPr txBox="1"/>
+          <p:nvPr/>
+        </p:nvSpPr>
+        <p:spPr>
+          <a:xfrm>
+            <a:off x="548640" y="914400"/>
+            <a:ext cx="10972800" cy="731520"/>
+          </a:xfrm>
+          <a:prstGeom prst="rect">
+            <a:avLst/>
+          </a:prstGeom>
+          <a:noFill/>
+        </p:spPr>
+        <p:txBody>
+          <a:bodyPr wrap="none">
+            <a:spAutoFit/>
+          </a:bodyPr>
+          <a:lstStyle/>
+          <a:p>
+            <a:pPr algn="l">
+              <a:spcAft>
+                <a:spcPts val="600"/>
+              </a:spcAft>
+            </a:pPr>
+            <a:r>
+              <a:rPr sz="2800" b="1">
+                <a:solidFill>
+                  <a:srgbClr val="E8EAF2"/>
+                </a:solidFill>
+                <a:latin typeface="Helvetica Neue"/>
+              </a:rPr>
+              <a:t>Same task. Same result. 98.7% fewer tokens.</a:t>
+            </a:r>
+          </a:p>
+        </p:txBody>
+      </p:sp>
+      <p:sp>
+        <p:nvSpPr>
+          <p:cNvPr id="7" name="Rounded Rectangle 6"/>
+          <p:cNvSpPr/>
+          <p:nvPr/>
+        </p:nvSpPr>
+        <p:spPr>
+          <a:xfrm>
+            <a:off x="548640" y="1920240"/>
+            <a:ext cx="2697480" cy="1737360"/>
+          </a:xfrm>
+          <a:prstGeom prst="roundRect">
+            <a:avLst/>
+          </a:prstGeom>
+          <a:solidFill>
+            <a:srgbClr val="10131E"/>
+          </a:solidFill>
+          <a:ln w="15875">
+            <a:solidFill>
+              <a:srgbClr val="2DD4A7"/>
+            </a:solidFill>
+          </a:ln>
+          <a:effectLst/>
+        </p:spPr>
+        <p:style>
+          <a:lnRef idx="1">
+            <a:schemeClr val="accent1"/>
+          </a:lnRef>
+          <a:fillRef idx="3">
+            <a:schemeClr val="accent1"/>
+          </a:fillRef>
+          <a:effectRef idx="2">
+            <a:schemeClr val="accent1"/>
+          </a:effectRef>
+          <a:fontRef idx="minor">
+            <a:schemeClr val="lt1"/>
+          </a:fontRef>
+        </p:style>
+        <p:txBody>
+          <a:bodyPr rtlCol="0" anchor="ctr"/>
+          <a:lstStyle/>
+          <a:p>
             <a:pPr algn="ctr">
               <a:spcAft>
                 <a:spcPts val="200"/>
@@ -4289,11 +5060,11 @@
             <a:r>
               <a:rPr sz="4000" b="1">
                 <a:solidFill>
-                  <a:srgbClr val="FF7849"/>
+                  <a:srgbClr val="2DD4A7"/>
                 </a:solidFill>
                 <a:latin typeface="Helvetica Neue"/>
               </a:rPr>
-              <a:t>+0.32</a:t>
+              <a:t>−98.7%</a:t>
             </a:r>
           </a:p>
           <a:p>
@@ -4309,6 +5080,231 @@
                 </a:solidFill>
                 <a:latin typeface="Helvetica Neue"/>
               </a:rPr>
+              <a:t>tokens</a:t>
+            </a:r>
+          </a:p>
+        </p:txBody>
+      </p:sp>
+      <p:sp>
+        <p:nvSpPr>
+          <p:cNvPr id="8" name="Rounded Rectangle 7"/>
+          <p:cNvSpPr/>
+          <p:nvPr/>
+        </p:nvSpPr>
+        <p:spPr>
+          <a:xfrm>
+            <a:off x="3383280" y="1920240"/>
+            <a:ext cx="2697480" cy="1737360"/>
+          </a:xfrm>
+          <a:prstGeom prst="roundRect">
+            <a:avLst/>
+          </a:prstGeom>
+          <a:solidFill>
+            <a:srgbClr val="10131E"/>
+          </a:solidFill>
+          <a:ln w="15875">
+            <a:solidFill>
+              <a:srgbClr val="4AA8FF"/>
+            </a:solidFill>
+          </a:ln>
+          <a:effectLst/>
+        </p:spPr>
+        <p:style>
+          <a:lnRef idx="1">
+            <a:schemeClr val="accent1"/>
+          </a:lnRef>
+          <a:fillRef idx="3">
+            <a:schemeClr val="accent1"/>
+          </a:fillRef>
+          <a:effectRef idx="2">
+            <a:schemeClr val="accent1"/>
+          </a:effectRef>
+          <a:fontRef idx="minor">
+            <a:schemeClr val="lt1"/>
+          </a:fontRef>
+        </p:style>
+        <p:txBody>
+          <a:bodyPr rtlCol="0" anchor="ctr"/>
+          <a:lstStyle/>
+          <a:p>
+            <a:pPr algn="ctr">
+              <a:spcAft>
+                <a:spcPts val="200"/>
+              </a:spcAft>
+            </a:pPr>
+            <a:r>
+              <a:rPr sz="4000" b="1">
+                <a:solidFill>
+                  <a:srgbClr val="4AA8FF"/>
+                </a:solidFill>
+                <a:latin typeface="Helvetica Neue"/>
+              </a:rPr>
+              <a:t>−98%</a:t>
+            </a:r>
+          </a:p>
+          <a:p>
+            <a:pPr algn="ctr">
+              <a:spcAft>
+                <a:spcPts val="600"/>
+              </a:spcAft>
+            </a:pPr>
+            <a:r>
+              <a:rPr sz="1600" b="0">
+                <a:solidFill>
+                  <a:srgbClr val="9AA0B6"/>
+                </a:solidFill>
+                <a:latin typeface="Helvetica Neue"/>
+              </a:rPr>
+              <a:t>time</a:t>
+            </a:r>
+          </a:p>
+        </p:txBody>
+      </p:sp>
+      <p:sp>
+        <p:nvSpPr>
+          <p:cNvPr id="9" name="Rounded Rectangle 8"/>
+          <p:cNvSpPr/>
+          <p:nvPr/>
+        </p:nvSpPr>
+        <p:spPr>
+          <a:xfrm>
+            <a:off x="6217920" y="1920240"/>
+            <a:ext cx="2697480" cy="1737360"/>
+          </a:xfrm>
+          <a:prstGeom prst="roundRect">
+            <a:avLst/>
+          </a:prstGeom>
+          <a:solidFill>
+            <a:srgbClr val="10131E"/>
+          </a:solidFill>
+          <a:ln w="15875">
+            <a:solidFill>
+              <a:srgbClr val="A78BFA"/>
+            </a:solidFill>
+          </a:ln>
+          <a:effectLst/>
+        </p:spPr>
+        <p:style>
+          <a:lnRef idx="1">
+            <a:schemeClr val="accent1"/>
+          </a:lnRef>
+          <a:fillRef idx="3">
+            <a:schemeClr val="accent1"/>
+          </a:fillRef>
+          <a:effectRef idx="2">
+            <a:schemeClr val="accent1"/>
+          </a:effectRef>
+          <a:fontRef idx="minor">
+            <a:schemeClr val="lt1"/>
+          </a:fontRef>
+        </p:style>
+        <p:txBody>
+          <a:bodyPr rtlCol="0" anchor="ctr"/>
+          <a:lstStyle/>
+          <a:p>
+            <a:pPr algn="ctr">
+              <a:spcAft>
+                <a:spcPts val="200"/>
+              </a:spcAft>
+            </a:pPr>
+            <a:r>
+              <a:rPr sz="4000" b="1">
+                <a:solidFill>
+                  <a:srgbClr val="A78BFA"/>
+                </a:solidFill>
+                <a:latin typeface="Helvetica Neue"/>
+              </a:rPr>
+              <a:t>−94%</a:t>
+            </a:r>
+          </a:p>
+          <a:p>
+            <a:pPr algn="ctr">
+              <a:spcAft>
+                <a:spcPts val="600"/>
+              </a:spcAft>
+            </a:pPr>
+            <a:r>
+              <a:rPr sz="1600" b="0">
+                <a:solidFill>
+                  <a:srgbClr val="9AA0B6"/>
+                </a:solidFill>
+                <a:latin typeface="Helvetica Neue"/>
+              </a:rPr>
+              <a:t>cost</a:t>
+            </a:r>
+          </a:p>
+        </p:txBody>
+      </p:sp>
+      <p:sp>
+        <p:nvSpPr>
+          <p:cNvPr id="10" name="Rounded Rectangle 9"/>
+          <p:cNvSpPr/>
+          <p:nvPr/>
+        </p:nvSpPr>
+        <p:spPr>
+          <a:xfrm>
+            <a:off x="9052560" y="1920240"/>
+            <a:ext cx="2697480" cy="1737360"/>
+          </a:xfrm>
+          <a:prstGeom prst="roundRect">
+            <a:avLst/>
+          </a:prstGeom>
+          <a:solidFill>
+            <a:srgbClr val="10131E"/>
+          </a:solidFill>
+          <a:ln w="15875">
+            <a:solidFill>
+              <a:srgbClr val="FF7849"/>
+            </a:solidFill>
+          </a:ln>
+          <a:effectLst/>
+        </p:spPr>
+        <p:style>
+          <a:lnRef idx="1">
+            <a:schemeClr val="accent1"/>
+          </a:lnRef>
+          <a:fillRef idx="3">
+            <a:schemeClr val="accent1"/>
+          </a:fillRef>
+          <a:effectRef idx="2">
+            <a:schemeClr val="accent1"/>
+          </a:effectRef>
+          <a:fontRef idx="minor">
+            <a:schemeClr val="lt1"/>
+          </a:fontRef>
+        </p:style>
+        <p:txBody>
+          <a:bodyPr rtlCol="0" anchor="ctr"/>
+          <a:lstStyle/>
+          <a:p>
+            <a:pPr algn="ctr">
+              <a:spcAft>
+                <a:spcPts val="200"/>
+              </a:spcAft>
+            </a:pPr>
+            <a:r>
+              <a:rPr sz="4000" b="1">
+                <a:solidFill>
+                  <a:srgbClr val="FF7849"/>
+                </a:solidFill>
+                <a:latin typeface="Helvetica Neue"/>
+              </a:rPr>
+              <a:t>+0.32</a:t>
+            </a:r>
+          </a:p>
+          <a:p>
+            <a:pPr algn="ctr">
+              <a:spcAft>
+                <a:spcPts val="600"/>
+              </a:spcAft>
+            </a:pPr>
+            <a:r>
+              <a:rPr sz="1600" b="0">
+                <a:solidFill>
+                  <a:srgbClr val="9AA0B6"/>
+                </a:solidFill>
+                <a:latin typeface="Helvetica Neue"/>
+              </a:rPr>
               <a:t>retrieval F1</a:t>
             </a:r>
           </a:p>
@@ -4316,14 +5312,14 @@
       </p:sp>
       <p:sp>
         <p:nvSpPr>
-          <p:cNvPr id="8" name="TextBox 7"/>
+          <p:cNvPr id="11" name="TextBox 10"/>
           <p:cNvSpPr txBox="1"/>
           <p:nvPr/>
         </p:nvSpPr>
         <p:spPr>
           <a:xfrm>
-            <a:off x="822960" y="4023360"/>
-            <a:ext cx="10515600" cy="2011680"/>
+            <a:off x="548640" y="4023360"/>
+            <a:ext cx="11064240" cy="2011680"/>
           </a:xfrm>
           <a:prstGeom prst="rect">
             <a:avLst/>
@@ -4342,13 +5338,13 @@
               </a:spcAft>
             </a:pPr>
             <a:r>
-              <a:rPr sz="1900" b="1">
+              <a:rPr sz="1800" b="1">
                 <a:solidFill>
                   <a:srgbClr val="E8EAF2"/>
                 </a:solidFill>
                 <a:latin typeface="Helvetica Neue"/>
               </a:rPr>
-              <a:t>1 frontier call avoided  ·  task success preserved (tests pass)  ·  retrieval recall 1.0</a:t>
+              <a:t>11,947 → 299 tokens · 1 frontier call avoided · task success preserved (tests pass)</a:t>
             </a:r>
           </a:p>
           <a:p>
@@ -4358,13 +5354,13 @@
               </a:spcAft>
             </a:pPr>
             <a:r>
-              <a:rPr sz="1700" b="0">
+              <a:rPr sz="1600" b="0">
                 <a:solidFill>
                   <a:srgbClr val="9AA0B6"/>
                 </a:solidFill>
                 <a:latin typeface="Helvetica Neue"/>
               </a:rPr>
-              <a:t>Baseline dumps the whole 11,947-token repo; local-first sends ~150 tokens of the right context.</a:t>
+              <a:t>Live now: Butterbase app app_b197i2548pk2 (real rows) · EverMind memory written · 27/27 tests.</a:t>
             </a:r>
           </a:p>
           <a:p>
@@ -4374,13 +5370,13 @@
               </a:spcAft>
             </a:pPr>
             <a:r>
-              <a:rPr sz="1700" b="0">
-                <a:solidFill>
-                  <a:srgbClr val="9AA0B6"/>
+              <a:rPr sz="1600" b="1">
+                <a:solidFill>
+                  <a:srgbClr val="2DD4A7"/>
                 </a:solidFill>
                 <a:latin typeface="Helvetica Neue"/>
               </a:rPr>
-              <a:t>Live: EverMind memory written (real API). $0 local index builds in ~300ms. 27/27 tests pass.</a:t>
+              <a:t>Reproduce on stage:  autopilot index  ·  autopilot eval  ·  bash demo/run_demo.sh</a:t>
             </a:r>
           </a:p>
         </p:txBody>

</xml_diff>

<commit_message>
Deck: add slide 7 with embedded demo video (plays in PowerPoint)
Co-Authored-By: Claude Opus 4.8 <noreply@anthropic.com>
</commit_message>
<xml_diff>
--- a/demo/autopilot-slides.pptx
+++ b/demo/autopilot-slides.pptx
@@ -11,6 +11,7 @@
     <p:sldId id="259" r:id="rId10"/>
     <p:sldId id="260" r:id="rId11"/>
     <p:sldId id="261" r:id="rId12"/>
+    <p:sldId id="262" r:id="rId13"/>
   </p:sldIdLst>
   <p:sldSz cx="12191695" cy="6858000" type="screen4x3"/>
   <p:notesSz cx="6858000" cy="9144000"/>
@@ -3472,7 +3473,7 @@
                   <a:srgbClr val="9AA0B6"/>
                 </a:solidFill>
               </a:rPr>
-              <a:t>        2/6</a:t>
+              <a:t>        2/7</a:t>
             </a:r>
           </a:p>
         </p:txBody>
@@ -3927,7 +3928,7 @@
                   <a:srgbClr val="9AA0B6"/>
                 </a:solidFill>
               </a:rPr>
-              <a:t>        3/6</a:t>
+              <a:t>        3/7</a:t>
             </a:r>
           </a:p>
         </p:txBody>
@@ -4239,7 +4240,7 @@
                   <a:srgbClr val="9AA0B6"/>
                 </a:solidFill>
               </a:rPr>
-              <a:t>        4/6</a:t>
+              <a:t>        4/7</a:t>
             </a:r>
           </a:p>
         </p:txBody>
@@ -4583,7 +4584,7 @@
                   <a:srgbClr val="9AA0B6"/>
                 </a:solidFill>
               </a:rPr>
-              <a:t>        5/6</a:t>
+              <a:t>        5/7</a:t>
             </a:r>
           </a:p>
         </p:txBody>
@@ -4927,7 +4928,7 @@
                   <a:srgbClr val="9AA0B6"/>
                 </a:solidFill>
               </a:rPr>
-              <a:t>        6/6</a:t>
+              <a:t>        6/7</a:t>
             </a:r>
           </a:p>
         </p:txBody>
@@ -5386,6 +5387,286 @@
   <p:clrMapOvr>
     <a:masterClrMapping/>
   </p:clrMapOvr>
+</p:sld>
+</file>
+
+<file path=ppt/slides/slide7.xml><?xml version="1.0" encoding="utf-8"?>
+<p:sld xmlns:a="http://schemas.openxmlformats.org/drawingml/2006/main" xmlns:p="http://schemas.openxmlformats.org/presentationml/2006/main" xmlns:r="http://schemas.openxmlformats.org/officeDocument/2006/relationships">
+  <p:cSld>
+    <p:spTree>
+      <p:nvGrpSpPr>
+        <p:cNvPr id="1" name=""/>
+        <p:cNvGrpSpPr/>
+        <p:nvPr/>
+      </p:nvGrpSpPr>
+      <p:grpSpPr/>
+      <p:sp>
+        <p:nvSpPr>
+          <p:cNvPr id="2" name="Rectangle 1"/>
+          <p:cNvSpPr/>
+          <p:nvPr/>
+        </p:nvSpPr>
+        <p:spPr>
+          <a:xfrm>
+            <a:off x="0" y="0"/>
+            <a:ext cx="12191695" cy="6858000"/>
+          </a:xfrm>
+          <a:prstGeom prst="rect">
+            <a:avLst/>
+          </a:prstGeom>
+          <a:solidFill>
+            <a:srgbClr val="0A0C14"/>
+          </a:solidFill>
+          <a:ln>
+            <a:noFill/>
+          </a:ln>
+          <a:effectLst/>
+        </p:spPr>
+        <p:style>
+          <a:lnRef idx="1">
+            <a:schemeClr val="accent1"/>
+          </a:lnRef>
+          <a:fillRef idx="3">
+            <a:schemeClr val="accent1"/>
+          </a:fillRef>
+          <a:effectRef idx="2">
+            <a:schemeClr val="accent1"/>
+          </a:effectRef>
+          <a:fontRef idx="minor">
+            <a:schemeClr val="lt1"/>
+          </a:fontRef>
+        </p:style>
+        <p:txBody>
+          <a:bodyPr rtlCol="0" anchor="ctr"/>
+          <a:lstStyle/>
+          <a:p>
+            <a:pPr algn="ctr"/>
+          </a:p>
+        </p:txBody>
+      </p:sp>
+      <p:sp>
+        <p:nvSpPr>
+          <p:cNvPr id="3" name="Rectangle 2"/>
+          <p:cNvSpPr/>
+          <p:nvPr/>
+        </p:nvSpPr>
+        <p:spPr>
+          <a:xfrm>
+            <a:off x="0" y="0"/>
+            <a:ext cx="128016" cy="6858000"/>
+          </a:xfrm>
+          <a:prstGeom prst="rect">
+            <a:avLst/>
+          </a:prstGeom>
+          <a:solidFill>
+            <a:srgbClr val="2DD4A7"/>
+          </a:solidFill>
+          <a:ln>
+            <a:noFill/>
+          </a:ln>
+          <a:effectLst/>
+        </p:spPr>
+        <p:style>
+          <a:lnRef idx="1">
+            <a:schemeClr val="accent1"/>
+          </a:lnRef>
+          <a:fillRef idx="3">
+            <a:schemeClr val="accent1"/>
+          </a:fillRef>
+          <a:effectRef idx="2">
+            <a:schemeClr val="accent1"/>
+          </a:effectRef>
+          <a:fontRef idx="minor">
+            <a:schemeClr val="lt1"/>
+          </a:fontRef>
+        </p:style>
+        <p:txBody>
+          <a:bodyPr rtlCol="0" anchor="ctr"/>
+          <a:lstStyle/>
+          <a:p>
+            <a:pPr algn="ctr"/>
+          </a:p>
+        </p:txBody>
+      </p:sp>
+      <p:sp>
+        <p:nvSpPr>
+          <p:cNvPr id="4" name="TextBox 3"/>
+          <p:cNvSpPr txBox="1"/>
+          <p:nvPr/>
+        </p:nvSpPr>
+        <p:spPr>
+          <a:xfrm>
+            <a:off x="548640" y="6400800"/>
+            <a:ext cx="11155680" cy="365760"/>
+          </a:xfrm>
+          <a:prstGeom prst="rect">
+            <a:avLst/>
+          </a:prstGeom>
+          <a:noFill/>
+        </p:spPr>
+        <p:txBody>
+          <a:bodyPr wrap="none">
+            <a:spAutoFit/>
+          </a:bodyPr>
+          <a:lstStyle/>
+          <a:p>
+            <a:r>
+              <a:rPr sz="1000">
+                <a:solidFill>
+                  <a:srgbClr val="9AA0B6"/>
+                </a:solidFill>
+              </a:rPr>
+              <a:t>EverMind + Butterbase: LIVE  ·  app_b197i2548pk2  ·  build0530</a:t>
+            </a:r>
+            <a:r>
+              <a:rPr sz="1000">
+                <a:solidFill>
+                  <a:srgbClr val="9AA0B6"/>
+                </a:solidFill>
+              </a:rPr>
+              <a:t>        7/7</a:t>
+            </a:r>
+          </a:p>
+        </p:txBody>
+      </p:sp>
+      <p:sp>
+        <p:nvSpPr>
+          <p:cNvPr id="5" name="TextBox 4"/>
+          <p:cNvSpPr txBox="1"/>
+          <p:nvPr/>
+        </p:nvSpPr>
+        <p:spPr>
+          <a:xfrm>
+            <a:off x="548640" y="502920"/>
+            <a:ext cx="10972800" cy="457200"/>
+          </a:xfrm>
+          <a:prstGeom prst="rect">
+            <a:avLst/>
+          </a:prstGeom>
+          <a:noFill/>
+        </p:spPr>
+        <p:txBody>
+          <a:bodyPr wrap="none">
+            <a:spAutoFit/>
+          </a:bodyPr>
+          <a:lstStyle/>
+          <a:p>
+            <a:pPr algn="l">
+              <a:spcAft>
+                <a:spcPts val="600"/>
+              </a:spcAft>
+            </a:pPr>
+            <a:r>
+              <a:rPr sz="1500" b="1">
+                <a:solidFill>
+                  <a:srgbClr val="2DD4A7"/>
+                </a:solidFill>
+                <a:latin typeface="Helvetica Neue"/>
+              </a:rPr>
+              <a:t>DEMO  ·  the token drop in 30s</a:t>
+            </a:r>
+          </a:p>
+        </p:txBody>
+      </p:sp>
+      <p:sp>
+        <p:nvSpPr>
+          <p:cNvPr id="6" name="TextBox 5"/>
+          <p:cNvSpPr txBox="1"/>
+          <p:nvPr/>
+        </p:nvSpPr>
+        <p:spPr>
+          <a:xfrm>
+            <a:off x="548640" y="914400"/>
+            <a:ext cx="10972800" cy="731520"/>
+          </a:xfrm>
+          <a:prstGeom prst="rect">
+            <a:avLst/>
+          </a:prstGeom>
+          <a:noFill/>
+        </p:spPr>
+        <p:txBody>
+          <a:bodyPr wrap="none">
+            <a:spAutoFit/>
+          </a:bodyPr>
+          <a:lstStyle/>
+          <a:p>
+            <a:pPr algn="l">
+              <a:spcAft>
+                <a:spcPts val="600"/>
+              </a:spcAft>
+            </a:pPr>
+            <a:r>
+              <a:rPr sz="2600" b="1">
+                <a:solidFill>
+                  <a:srgbClr val="E8EAF2"/>
+                </a:solidFill>
+                <a:latin typeface="Helvetica Neue"/>
+              </a:rPr>
+              <a:t>Same task, two ways — watch tokens go 11,947 → 299</a:t>
+            </a:r>
+          </a:p>
+        </p:txBody>
+      </p:sp>
+      <p:pic>
+        <p:nvPicPr>
+          <p:cNvPr id="7" name="autopilot-demo.mp4">
+            <a:hlinkClick r:id="" action="ppaction://media"/>
+          </p:cNvPr>
+          <p:cNvPicPr>
+            <a:picLocks noChangeAspect="1"/>
+          </p:cNvPicPr>
+          <p:nvPr>
+            <a:videoFile r:link="rId3"/>
+            <p:extLst>
+              <p:ext uri="{DAA4B4D4-6D71-4841-9C94-3DE7FCFB9230}">
+                <p14:media xmlns:p14="http://schemas.microsoft.com/office/powerpoint/2010/main" r:embed="rId2"/>
+              </p:ext>
+            </p:extLst>
+          </p:nvPr>
+        </p:nvPicPr>
+        <p:blipFill>
+          <a:blip r:embed="rId4"/>
+          <a:stretch>
+            <a:fillRect/>
+          </a:stretch>
+        </p:blipFill>
+        <p:spPr>
+          <a:xfrm>
+            <a:off x="1706727" y="1600200"/>
+            <a:ext cx="8778240" cy="4937760"/>
+          </a:xfrm>
+          <a:prstGeom prst="rect">
+            <a:avLst/>
+          </a:prstGeom>
+        </p:spPr>
+      </p:pic>
+    </p:spTree>
+  </p:cSld>
+  <p:clrMapOvr>
+    <a:masterClrMapping/>
+  </p:clrMapOvr>
+  <p:timing>
+    <p:tnLst>
+      <p:par>
+        <p:cTn id="1" dur="indefinite" restart="never" nodeType="tmRoot">
+          <p:childTnLst>
+            <p:video>
+              <p:cMediaNode vol="80000">
+                <p:cTn id="2" fill="hold" display="0">
+                  <p:stCondLst>
+                    <p:cond delay="indefinite"/>
+                  </p:stCondLst>
+                </p:cTn>
+                <p:tgtEl>
+                  <p:spTgt spid="7"/>
+                </p:tgtEl>
+              </p:cMediaNode>
+            </p:video>
+          </p:childTnLst>
+        </p:cTn>
+      </p:par>
+    </p:tnLst>
+  </p:timing>
 </p:sld>
 </file>
 

</xml_diff>

<commit_message>
Slides 1-2: identity, problem/solution, and the full SFT/RL/MLX architecture
Co-Authored-By: Claude Opus 4.8 <noreply@anthropic.com>
</commit_message>
<xml_diff>
--- a/demo/autopilot-slides.pptx
+++ b/demo/autopilot-slides.pptx
@@ -3190,8 +3190,8 @@
         </p:nvSpPr>
         <p:spPr>
           <a:xfrm>
-            <a:off x="822960" y="914400"/>
-            <a:ext cx="10058400" cy="457200"/>
+            <a:off x="822960" y="502920"/>
+            <a:ext cx="10607040" cy="457200"/>
           </a:xfrm>
           <a:prstGeom prst="rect">
             <a:avLst/>
@@ -3229,8 +3229,8 @@
         </p:nvSpPr>
         <p:spPr>
           <a:xfrm>
-            <a:off x="822960" y="2103120"/>
-            <a:ext cx="10698480" cy="2377440"/>
+            <a:off x="822960" y="1097280"/>
+            <a:ext cx="10607040" cy="1371600"/>
           </a:xfrm>
           <a:prstGeom prst="rect">
             <a:avLst/>
@@ -3249,13 +3249,13 @@
               </a:spcAft>
             </a:pPr>
             <a:r>
-              <a:rPr sz="4400" b="1">
+              <a:rPr sz="3800" b="1">
                 <a:solidFill>
                   <a:srgbClr val="E8EAF2"/>
                 </a:solidFill>
                 <a:latin typeface="Helvetica Neue"/>
               </a:rPr>
-              <a:t>Stop paying Claude to re-read your repo</a:t>
+              <a:t>Personal Coding Model Autopilot</a:t>
             </a:r>
           </a:p>
           <a:p>
@@ -3265,15 +3265,38 @@
               </a:spcAft>
             </a:pPr>
             <a:r>
-              <a:rPr sz="2100" b="0">
-                <a:solidFill>
-                  <a:srgbClr val="9AA0B6"/>
+              <a:rPr sz="1700" b="1">
+                <a:solidFill>
+                  <a:srgbClr val="2DD4A7"/>
                 </a:solidFill>
                 <a:latin typeface="Helvetica Neue"/>
               </a:rPr>
-              <a:t>A $0 local model keeps a live map of your codebase (SKILL.md + DAG) so Claude Code</a:t>
-            </a:r>
-          </a:p>
+              <a:t>William Chen · Touchdown Labs — vendor-neutral inference-optimization research</a:t>
+            </a:r>
+          </a:p>
+        </p:txBody>
+      </p:sp>
+      <p:sp>
+        <p:nvSpPr>
+          <p:cNvPr id="6" name="TextBox 5"/>
+          <p:cNvSpPr txBox="1"/>
+          <p:nvPr/>
+        </p:nvSpPr>
+        <p:spPr>
+          <a:xfrm>
+            <a:off x="822960" y="2514600"/>
+            <a:ext cx="10607040" cy="822960"/>
+          </a:xfrm>
+          <a:prstGeom prst="rect">
+            <a:avLst/>
+          </a:prstGeom>
+          <a:noFill/>
+        </p:spPr>
+        <p:txBody>
+          <a:bodyPr wrap="none">
+            <a:spAutoFit/>
+          </a:bodyPr>
+          <a:lstStyle/>
           <a:p>
             <a:pPr algn="l">
               <a:spcAft>
@@ -3281,37 +3304,57 @@
               </a:spcAft>
             </a:pPr>
             <a:r>
-              <a:rPr sz="2100" b="0">
-                <a:solidFill>
-                  <a:srgbClr val="9AA0B6"/>
+              <a:rPr sz="1600" b="0">
+                <a:solidFill>
+                  <a:srgbClr val="E8EAF2"/>
                 </a:solidFill>
                 <a:latin typeface="Helvetica Neue"/>
               </a:rPr>
-              <a:t>reads the saved context instead of re-exploring — ~99% fewer tokens, same result.</a:t>
-            </a:r>
-          </a:p>
-        </p:txBody>
-      </p:sp>
-      <p:sp>
-        <p:nvSpPr>
-          <p:cNvPr id="6" name="TextBox 5"/>
-          <p:cNvSpPr txBox="1"/>
+              <a:t>What I'm building: a local-first coding-agent stack — a $0 model that already knows your repo, plus a personal coding model distilled to your codebase and style.</a:t>
+            </a:r>
+          </a:p>
+        </p:txBody>
+      </p:sp>
+      <p:sp>
+        <p:nvSpPr>
+          <p:cNvPr id="7" name="Rounded Rectangle 6"/>
+          <p:cNvSpPr/>
           <p:nvPr/>
         </p:nvSpPr>
         <p:spPr>
           <a:xfrm>
-            <a:off x="822960" y="4846320"/>
-            <a:ext cx="10698480" cy="914400"/>
-          </a:xfrm>
-          <a:prstGeom prst="rect">
+            <a:off x="822960" y="3520440"/>
+            <a:ext cx="5212080" cy="2194560"/>
+          </a:xfrm>
+          <a:prstGeom prst="roundRect">
             <a:avLst/>
           </a:prstGeom>
-          <a:noFill/>
-        </p:spPr>
-        <p:txBody>
-          <a:bodyPr wrap="none">
-            <a:spAutoFit/>
-          </a:bodyPr>
+          <a:solidFill>
+            <a:srgbClr val="10131E"/>
+          </a:solidFill>
+          <a:ln w="15875">
+            <a:solidFill>
+              <a:srgbClr val="FF7849"/>
+            </a:solidFill>
+          </a:ln>
+          <a:effectLst/>
+        </p:spPr>
+        <p:style>
+          <a:lnRef idx="1">
+            <a:schemeClr val="accent1"/>
+          </a:lnRef>
+          <a:fillRef idx="3">
+            <a:schemeClr val="accent1"/>
+          </a:fillRef>
+          <a:effectRef idx="2">
+            <a:schemeClr val="accent1"/>
+          </a:effectRef>
+          <a:fontRef idx="minor">
+            <a:schemeClr val="lt1"/>
+          </a:fontRef>
+        </p:style>
+        <p:txBody>
+          <a:bodyPr rtlCol="0" anchor="t" wrap="square" lIns="256032" tIns="201168" rIns="182880"/>
           <a:lstStyle/>
           <a:p>
             <a:pPr algn="l">
@@ -3320,13 +3363,143 @@
               </a:spcAft>
             </a:pPr>
             <a:r>
-              <a:rPr sz="1600" b="1">
+              <a:rPr sz="1800" b="1">
+                <a:solidFill>
+                  <a:srgbClr val="FF7849"/>
+                </a:solidFill>
+                <a:latin typeface="Helvetica Neue"/>
+              </a:rPr>
+              <a:t>The problem</a:t>
+            </a:r>
+          </a:p>
+          <a:p>
+            <a:pPr algn="l">
+              <a:spcAft>
+                <a:spcPts val="600"/>
+              </a:spcAft>
+            </a:pPr>
+            <a:r>
+              <a:rPr sz="1500" b="0">
+                <a:solidFill>
+                  <a:srgbClr val="E8EAF2"/>
+                </a:solidFill>
+                <a:latin typeface="Helvetica Neue"/>
+              </a:rPr>
+              <a:t>Claude Code re-reads your repo every session — you pay frontier prices to rediscover structure you already have (≈90K tokens to reload a 359 KB repo, every time).</a:t>
+            </a:r>
+          </a:p>
+        </p:txBody>
+      </p:sp>
+      <p:sp>
+        <p:nvSpPr>
+          <p:cNvPr id="8" name="Rounded Rectangle 7"/>
+          <p:cNvSpPr/>
+          <p:nvPr/>
+        </p:nvSpPr>
+        <p:spPr>
+          <a:xfrm>
+            <a:off x="6400800" y="3520440"/>
+            <a:ext cx="5212080" cy="2194560"/>
+          </a:xfrm>
+          <a:prstGeom prst="roundRect">
+            <a:avLst/>
+          </a:prstGeom>
+          <a:solidFill>
+            <a:srgbClr val="10131E"/>
+          </a:solidFill>
+          <a:ln w="15875">
+            <a:solidFill>
+              <a:srgbClr val="2DD4A7"/>
+            </a:solidFill>
+          </a:ln>
+          <a:effectLst/>
+        </p:spPr>
+        <p:style>
+          <a:lnRef idx="1">
+            <a:schemeClr val="accent1"/>
+          </a:lnRef>
+          <a:fillRef idx="3">
+            <a:schemeClr val="accent1"/>
+          </a:fillRef>
+          <a:effectRef idx="2">
+            <a:schemeClr val="accent1"/>
+          </a:effectRef>
+          <a:fontRef idx="minor">
+            <a:schemeClr val="lt1"/>
+          </a:fontRef>
+        </p:style>
+        <p:txBody>
+          <a:bodyPr rtlCol="0" anchor="t" wrap="square" lIns="256032" tIns="201168" rIns="182880"/>
+          <a:lstStyle/>
+          <a:p>
+            <a:pPr algn="l">
+              <a:spcAft>
+                <a:spcPts val="600"/>
+              </a:spcAft>
+            </a:pPr>
+            <a:r>
+              <a:rPr sz="1800" b="1">
                 <a:solidFill>
                   <a:srgbClr val="2DD4A7"/>
                 </a:solidFill>
                 <a:latin typeface="Helvetica Neue"/>
               </a:rPr>
-              <a:t>Touchdown Labs  ·  github.com/OCWC22/personal-coding-autopilot</a:t>
+              <a:t>The solution</a:t>
+            </a:r>
+          </a:p>
+          <a:p>
+            <a:pPr algn="l">
+              <a:spcAft>
+                <a:spcPts val="600"/>
+              </a:spcAft>
+            </a:pPr>
+            <a:r>
+              <a:rPr sz="1500" b="0">
+                <a:solidFill>
+                  <a:srgbClr val="E8EAF2"/>
+                </a:solidFill>
+                <a:latin typeface="Helvetica Neue"/>
+              </a:rPr>
+              <a:t>Keep a live local map (SKILL.md + DAG) and a small MLX model for the cheap work; escalate to the frontier only for the hard step — ~99% fewer tokens, same result.</a:t>
+            </a:r>
+          </a:p>
+        </p:txBody>
+      </p:sp>
+      <p:sp>
+        <p:nvSpPr>
+          <p:cNvPr id="9" name="TextBox 8"/>
+          <p:cNvSpPr txBox="1"/>
+          <p:nvPr/>
+        </p:nvSpPr>
+        <p:spPr>
+          <a:xfrm>
+            <a:off x="822960" y="5943600"/>
+            <a:ext cx="10607040" cy="457200"/>
+          </a:xfrm>
+          <a:prstGeom prst="rect">
+            <a:avLst/>
+          </a:prstGeom>
+          <a:noFill/>
+        </p:spPr>
+        <p:txBody>
+          <a:bodyPr wrap="none">
+            <a:spAutoFit/>
+          </a:bodyPr>
+          <a:lstStyle/>
+          <a:p>
+            <a:pPr algn="l">
+              <a:spcAft>
+                <a:spcPts val="600"/>
+              </a:spcAft>
+            </a:pPr>
+            <a:r>
+              <a:rPr sz="1500" b="1">
+                <a:solidFill>
+                  <a:srgbClr val="9AA0B6"/>
+                </a:solidFill>
+                <a:latin typeface="Helvetica Neue"/>
+              </a:rPr>
+              <a:t>github.com/OCWC22/personal-coding-autopilot</a:t>
             </a:r>
           </a:p>
         </p:txBody>
@@ -3512,7 +3685,7 @@
                 </a:solidFill>
                 <a:latin typeface="Helvetica Neue"/>
               </a:rPr>
-              <a:t>THE PAIN</a:t>
+              <a:t>THE FULL SYSTEM</a:t>
             </a:r>
           </a:p>
         </p:txBody>
@@ -3525,8 +3698,8 @@
         </p:nvSpPr>
         <p:spPr>
           <a:xfrm>
-            <a:off x="548640" y="914400"/>
-            <a:ext cx="10972800" cy="914400"/>
+            <a:off x="548640" y="868680"/>
+            <a:ext cx="11155680" cy="640080"/>
           </a:xfrm>
           <a:prstGeom prst="rect">
             <a:avLst/>
@@ -3545,27 +3718,447 @@
               </a:spcAft>
             </a:pPr>
             <a:r>
-              <a:rPr sz="3200" b="1">
+              <a:rPr sz="2700" b="1">
                 <a:solidFill>
                   <a:srgbClr val="E8EAF2"/>
                 </a:solidFill>
                 <a:latin typeface="Helvetica Neue"/>
               </a:rPr>
-              <a:t>Every session, Claude Code rediscovers your repo</a:t>
-            </a:r>
-          </a:p>
-        </p:txBody>
-      </p:sp>
-      <p:sp>
-        <p:nvSpPr>
-          <p:cNvPr id="7" name="Rounded Rectangle 6"/>
+              <a:t>How SFT, RL, local AI &amp; MLX fit together</a:t>
+            </a:r>
+          </a:p>
+        </p:txBody>
+      </p:sp>
+      <p:sp>
+        <p:nvSpPr>
+          <p:cNvPr id="7" name="TextBox 6"/>
+          <p:cNvSpPr txBox="1"/>
+          <p:nvPr/>
+        </p:nvSpPr>
+        <p:spPr>
+          <a:xfrm>
+            <a:off x="548640" y="1481328"/>
+            <a:ext cx="11155680" cy="548640"/>
+          </a:xfrm>
+          <a:prstGeom prst="rect">
+            <a:avLst/>
+          </a:prstGeom>
+          <a:noFill/>
+        </p:spPr>
+        <p:txBody>
+          <a:bodyPr wrap="none">
+            <a:spAutoFit/>
+          </a:bodyPr>
+          <a:lstStyle/>
+          <a:p>
+            <a:pPr algn="l">
+              <a:spcAft>
+                <a:spcPts val="600"/>
+              </a:spcAft>
+            </a:pPr>
+            <a:r>
+              <a:rPr sz="1400" b="0">
+                <a:solidFill>
+                  <a:srgbClr val="9AA0B6"/>
+                </a:solidFill>
+                <a:latin typeface="Helvetica Neue"/>
+              </a:rPr>
+              <a:t>Goal: cut frontier-model calls &amp; cost while preserving task success — a coding model that learns your repo and style from your own traces.</a:t>
+            </a:r>
+          </a:p>
+        </p:txBody>
+      </p:sp>
+      <p:sp>
+        <p:nvSpPr>
+          <p:cNvPr id="8" name="TextBox 7"/>
+          <p:cNvSpPr txBox="1"/>
+          <p:nvPr/>
+        </p:nvSpPr>
+        <p:spPr>
+          <a:xfrm>
+            <a:off x="548640" y="2194560"/>
+            <a:ext cx="10972800" cy="365760"/>
+          </a:xfrm>
+          <a:prstGeom prst="rect">
+            <a:avLst/>
+          </a:prstGeom>
+          <a:noFill/>
+        </p:spPr>
+        <p:txBody>
+          <a:bodyPr wrap="none">
+            <a:spAutoFit/>
+          </a:bodyPr>
+          <a:lstStyle/>
+          <a:p>
+            <a:pPr algn="l">
+              <a:spcAft>
+                <a:spcPts val="600"/>
+              </a:spcAft>
+            </a:pPr>
+            <a:r>
+              <a:rPr sz="1300" b="1">
+                <a:solidFill>
+                  <a:srgbClr val="2DD4A7"/>
+                </a:solidFill>
+                <a:latin typeface="Helvetica Neue"/>
+              </a:rPr>
+              <a:t>OFFLINE — build your personal model (cheap, on-device)</a:t>
+            </a:r>
+          </a:p>
+        </p:txBody>
+      </p:sp>
+      <p:sp>
+        <p:nvSpPr>
+          <p:cNvPr id="9" name="Rounded Rectangle 8"/>
           <p:cNvSpPr/>
           <p:nvPr/>
         </p:nvSpPr>
         <p:spPr>
           <a:xfrm>
-            <a:off x="548640" y="2011680"/>
-            <a:ext cx="5394960" cy="3383280"/>
+            <a:off x="548640" y="2606040"/>
+            <a:ext cx="2457450" cy="1188720"/>
+          </a:xfrm>
+          <a:prstGeom prst="roundRect">
+            <a:avLst/>
+          </a:prstGeom>
+          <a:solidFill>
+            <a:srgbClr val="10131E"/>
+          </a:solidFill>
+          <a:ln w="15875">
+            <a:solidFill>
+              <a:srgbClr val="2DD4A7"/>
+            </a:solidFill>
+          </a:ln>
+          <a:effectLst/>
+        </p:spPr>
+        <p:style>
+          <a:lnRef idx="1">
+            <a:schemeClr val="accent1"/>
+          </a:lnRef>
+          <a:fillRef idx="3">
+            <a:schemeClr val="accent1"/>
+          </a:fillRef>
+          <a:effectRef idx="2">
+            <a:schemeClr val="accent1"/>
+          </a:effectRef>
+          <a:fontRef idx="minor">
+            <a:schemeClr val="lt1"/>
+          </a:fontRef>
+        </p:style>
+        <p:txBody>
+          <a:bodyPr rtlCol="0" anchor="ctr" wrap="square"/>
+          <a:lstStyle/>
+          <a:p>
+            <a:pPr algn="ctr">
+              <a:spcAft>
+                <a:spcPts val="200"/>
+              </a:spcAft>
+            </a:pPr>
+            <a:r>
+              <a:rPr sz="1300" b="1">
+                <a:solidFill>
+                  <a:srgbClr val="2DD4A7"/>
+                </a:solidFill>
+                <a:latin typeface="Helvetica Neue"/>
+              </a:rPr>
+              <a:t>Your traces + repo</a:t>
+            </a:r>
+          </a:p>
+          <a:p>
+            <a:pPr algn="ctr">
+              <a:spcAft>
+                <a:spcPts val="0"/>
+              </a:spcAft>
+            </a:pPr>
+            <a:r>
+              <a:rPr sz="1050" b="0">
+                <a:solidFill>
+                  <a:srgbClr val="E8EAF2"/>
+                </a:solidFill>
+                <a:latin typeface="Helvetica Neue"/>
+              </a:rPr>
+              <a:t>Claude Code / Codex sessions, accepted diffs</a:t>
+            </a:r>
+          </a:p>
+        </p:txBody>
+      </p:sp>
+      <p:sp>
+        <p:nvSpPr>
+          <p:cNvPr id="10" name="TextBox 9"/>
+          <p:cNvSpPr txBox="1"/>
+          <p:nvPr/>
+        </p:nvSpPr>
+        <p:spPr>
+          <a:xfrm>
+            <a:off x="3028950" y="3017520"/>
+            <a:ext cx="365760" cy="365760"/>
+          </a:xfrm>
+          <a:prstGeom prst="rect">
+            <a:avLst/>
+          </a:prstGeom>
+          <a:noFill/>
+        </p:spPr>
+        <p:txBody>
+          <a:bodyPr wrap="none">
+            <a:spAutoFit/>
+          </a:bodyPr>
+          <a:lstStyle/>
+          <a:p>
+            <a:pPr algn="ctr">
+              <a:spcAft>
+                <a:spcPts val="600"/>
+              </a:spcAft>
+            </a:pPr>
+            <a:r>
+              <a:rPr sz="2000" b="1">
+                <a:solidFill>
+                  <a:srgbClr val="9AA0B6"/>
+                </a:solidFill>
+                <a:latin typeface="Helvetica Neue"/>
+              </a:rPr>
+              <a:t>→</a:t>
+            </a:r>
+          </a:p>
+        </p:txBody>
+      </p:sp>
+      <p:sp>
+        <p:nvSpPr>
+          <p:cNvPr id="11" name="Rounded Rectangle 10"/>
+          <p:cNvSpPr/>
+          <p:nvPr/>
+        </p:nvSpPr>
+        <p:spPr>
+          <a:xfrm>
+            <a:off x="3417570" y="2606040"/>
+            <a:ext cx="2457450" cy="1188720"/>
+          </a:xfrm>
+          <a:prstGeom prst="roundRect">
+            <a:avLst/>
+          </a:prstGeom>
+          <a:solidFill>
+            <a:srgbClr val="10131E"/>
+          </a:solidFill>
+          <a:ln w="15875">
+            <a:solidFill>
+              <a:srgbClr val="4AA8FF"/>
+            </a:solidFill>
+          </a:ln>
+          <a:effectLst/>
+        </p:spPr>
+        <p:style>
+          <a:lnRef idx="1">
+            <a:schemeClr val="accent1"/>
+          </a:lnRef>
+          <a:fillRef idx="3">
+            <a:schemeClr val="accent1"/>
+          </a:fillRef>
+          <a:effectRef idx="2">
+            <a:schemeClr val="accent1"/>
+          </a:effectRef>
+          <a:fontRef idx="minor">
+            <a:schemeClr val="lt1"/>
+          </a:fontRef>
+        </p:style>
+        <p:txBody>
+          <a:bodyPr rtlCol="0" anchor="ctr" wrap="square"/>
+          <a:lstStyle/>
+          <a:p>
+            <a:pPr algn="ctr">
+              <a:spcAft>
+                <a:spcPts val="200"/>
+              </a:spcAft>
+            </a:pPr>
+            <a:r>
+              <a:rPr sz="1300" b="1">
+                <a:solidFill>
+                  <a:srgbClr val="4AA8FF"/>
+                </a:solidFill>
+                <a:latin typeface="Helvetica Neue"/>
+              </a:rPr>
+              <a:t>SFT</a:t>
+            </a:r>
+          </a:p>
+          <a:p>
+            <a:pPr algn="ctr">
+              <a:spcAft>
+                <a:spcPts val="0"/>
+              </a:spcAft>
+            </a:pPr>
+            <a:r>
+              <a:rPr sz="1050" b="0">
+                <a:solidFill>
+                  <a:srgbClr val="E8EAF2"/>
+                </a:solidFill>
+                <a:latin typeface="Helvetica Neue"/>
+              </a:rPr>
+              <a:t>distill GLM-5.1 (teacher) → student</a:t>
+            </a:r>
+          </a:p>
+        </p:txBody>
+      </p:sp>
+      <p:sp>
+        <p:nvSpPr>
+          <p:cNvPr id="12" name="TextBox 11"/>
+          <p:cNvSpPr txBox="1"/>
+          <p:nvPr/>
+        </p:nvSpPr>
+        <p:spPr>
+          <a:xfrm>
+            <a:off x="5897880" y="3017520"/>
+            <a:ext cx="365760" cy="365760"/>
+          </a:xfrm>
+          <a:prstGeom prst="rect">
+            <a:avLst/>
+          </a:prstGeom>
+          <a:noFill/>
+        </p:spPr>
+        <p:txBody>
+          <a:bodyPr wrap="none">
+            <a:spAutoFit/>
+          </a:bodyPr>
+          <a:lstStyle/>
+          <a:p>
+            <a:pPr algn="ctr">
+              <a:spcAft>
+                <a:spcPts val="600"/>
+              </a:spcAft>
+            </a:pPr>
+            <a:r>
+              <a:rPr sz="2000" b="1">
+                <a:solidFill>
+                  <a:srgbClr val="9AA0B6"/>
+                </a:solidFill>
+                <a:latin typeface="Helvetica Neue"/>
+              </a:rPr>
+              <a:t>→</a:t>
+            </a:r>
+          </a:p>
+        </p:txBody>
+      </p:sp>
+      <p:sp>
+        <p:nvSpPr>
+          <p:cNvPr id="13" name="Rounded Rectangle 12"/>
+          <p:cNvSpPr/>
+          <p:nvPr/>
+        </p:nvSpPr>
+        <p:spPr>
+          <a:xfrm>
+            <a:off x="6286500" y="2606040"/>
+            <a:ext cx="2457450" cy="1188720"/>
+          </a:xfrm>
+          <a:prstGeom prst="roundRect">
+            <a:avLst/>
+          </a:prstGeom>
+          <a:solidFill>
+            <a:srgbClr val="10131E"/>
+          </a:solidFill>
+          <a:ln w="15875">
+            <a:solidFill>
+              <a:srgbClr val="A78BFA"/>
+            </a:solidFill>
+          </a:ln>
+          <a:effectLst/>
+        </p:spPr>
+        <p:style>
+          <a:lnRef idx="1">
+            <a:schemeClr val="accent1"/>
+          </a:lnRef>
+          <a:fillRef idx="3">
+            <a:schemeClr val="accent1"/>
+          </a:fillRef>
+          <a:effectRef idx="2">
+            <a:schemeClr val="accent1"/>
+          </a:effectRef>
+          <a:fontRef idx="minor">
+            <a:schemeClr val="lt1"/>
+          </a:fontRef>
+        </p:style>
+        <p:txBody>
+          <a:bodyPr rtlCol="0" anchor="ctr" wrap="square"/>
+          <a:lstStyle/>
+          <a:p>
+            <a:pPr algn="ctr">
+              <a:spcAft>
+                <a:spcPts val="200"/>
+              </a:spcAft>
+            </a:pPr>
+            <a:r>
+              <a:rPr sz="1300" b="1">
+                <a:solidFill>
+                  <a:srgbClr val="A78BFA"/>
+                </a:solidFill>
+                <a:latin typeface="Helvetica Neue"/>
+              </a:rPr>
+              <a:t>RL</a:t>
+            </a:r>
+          </a:p>
+          <a:p>
+            <a:pPr algn="ctr">
+              <a:spcAft>
+                <a:spcPts val="0"/>
+              </a:spcAft>
+            </a:pPr>
+            <a:r>
+              <a:rPr sz="1050" b="0">
+                <a:solidFill>
+                  <a:srgbClr val="E8EAF2"/>
+                </a:solidFill>
+                <a:latin typeface="Helvetica Neue"/>
+              </a:rPr>
+              <a:t>verifiable rewards (GRPO): tests pass</a:t>
+            </a:r>
+          </a:p>
+        </p:txBody>
+      </p:sp>
+      <p:sp>
+        <p:nvSpPr>
+          <p:cNvPr id="14" name="TextBox 13"/>
+          <p:cNvSpPr txBox="1"/>
+          <p:nvPr/>
+        </p:nvSpPr>
+        <p:spPr>
+          <a:xfrm>
+            <a:off x="8766810" y="3017520"/>
+            <a:ext cx="365760" cy="365760"/>
+          </a:xfrm>
+          <a:prstGeom prst="rect">
+            <a:avLst/>
+          </a:prstGeom>
+          <a:noFill/>
+        </p:spPr>
+        <p:txBody>
+          <a:bodyPr wrap="none">
+            <a:spAutoFit/>
+          </a:bodyPr>
+          <a:lstStyle/>
+          <a:p>
+            <a:pPr algn="ctr">
+              <a:spcAft>
+                <a:spcPts val="600"/>
+              </a:spcAft>
+            </a:pPr>
+            <a:r>
+              <a:rPr sz="2000" b="1">
+                <a:solidFill>
+                  <a:srgbClr val="9AA0B6"/>
+                </a:solidFill>
+                <a:latin typeface="Helvetica Neue"/>
+              </a:rPr>
+              <a:t>→</a:t>
+            </a:r>
+          </a:p>
+        </p:txBody>
+      </p:sp>
+      <p:sp>
+        <p:nvSpPr>
+          <p:cNvPr id="15" name="Rounded Rectangle 14"/>
+          <p:cNvSpPr/>
+          <p:nvPr/>
+        </p:nvSpPr>
+        <p:spPr>
+          <a:xfrm>
+            <a:off x="9155430" y="2606040"/>
+            <a:ext cx="2457450" cy="1188720"/>
           </a:xfrm>
           <a:prstGeom prst="roundRect">
             <a:avLst/>
@@ -3595,7 +4188,62 @@
           </a:fontRef>
         </p:style>
         <p:txBody>
-          <a:bodyPr rtlCol="0" anchor="t" wrap="square" lIns="274320" tIns="228600"/>
+          <a:bodyPr rtlCol="0" anchor="ctr" wrap="square"/>
+          <a:lstStyle/>
+          <a:p>
+            <a:pPr algn="ctr">
+              <a:spcAft>
+                <a:spcPts val="200"/>
+              </a:spcAft>
+            </a:pPr>
+            <a:r>
+              <a:rPr sz="1300" b="1">
+                <a:solidFill>
+                  <a:srgbClr val="FF7849"/>
+                </a:solidFill>
+                <a:latin typeface="Helvetica Neue"/>
+              </a:rPr>
+              <a:t>MLX model</a:t>
+            </a:r>
+          </a:p>
+          <a:p>
+            <a:pPr algn="ctr">
+              <a:spcAft>
+                <a:spcPts val="0"/>
+              </a:spcAft>
+            </a:pPr>
+            <a:r>
+              <a:rPr sz="1050" b="0">
+                <a:solidFill>
+                  <a:srgbClr val="E8EAF2"/>
+                </a:solidFill>
+                <a:latin typeface="Helvetica Neue"/>
+              </a:rPr>
+              <a:t>personal coder · 16 GB Mac · $0</a:t>
+            </a:r>
+          </a:p>
+        </p:txBody>
+      </p:sp>
+      <p:sp>
+        <p:nvSpPr>
+          <p:cNvPr id="16" name="TextBox 15"/>
+          <p:cNvSpPr txBox="1"/>
+          <p:nvPr/>
+        </p:nvSpPr>
+        <p:spPr>
+          <a:xfrm>
+            <a:off x="548640" y="4114800"/>
+            <a:ext cx="10972800" cy="365760"/>
+          </a:xfrm>
+          <a:prstGeom prst="rect">
+            <a:avLst/>
+          </a:prstGeom>
+          <a:noFill/>
+        </p:spPr>
+        <p:txBody>
+          <a:bodyPr wrap="none">
+            <a:spAutoFit/>
+          </a:bodyPr>
           <a:lstStyle/>
           <a:p>
             <a:pPr algn="l">
@@ -3604,91 +4252,27 @@
               </a:spcAft>
             </a:pPr>
             <a:r>
-              <a:rPr sz="1900" b="1">
-                <a:solidFill>
-                  <a:srgbClr val="FF7849"/>
+              <a:rPr sz="1300" b="1">
+                <a:solidFill>
+                  <a:srgbClr val="2DD4A7"/>
                 </a:solidFill>
                 <a:latin typeface="Helvetica Neue"/>
               </a:rPr>
-              <a:t>Normal Claude Code</a:t>
-            </a:r>
-          </a:p>
-          <a:p>
-            <a:pPr algn="l">
-              <a:spcAft>
-                <a:spcPts val="1200"/>
-              </a:spcAft>
-            </a:pPr>
-            <a:r>
-              <a:rPr sz="1600" b="0">
-                <a:solidFill>
-                  <a:srgbClr val="E8EAF2"/>
-                </a:solidFill>
-                <a:latin typeface="Helvetica Neue"/>
-              </a:rPr>
-              <a:t>•  grep → read → read → read to relearn structure</a:t>
-            </a:r>
-          </a:p>
-          <a:p>
-            <a:pPr algn="l">
-              <a:spcAft>
-                <a:spcPts val="1200"/>
-              </a:spcAft>
-            </a:pPr>
-            <a:r>
-              <a:rPr sz="1600" b="0">
-                <a:solidFill>
-                  <a:srgbClr val="E8EAF2"/>
-                </a:solidFill>
-                <a:latin typeface="Helvetica Neue"/>
-              </a:rPr>
-              <a:t>•  a 359 KB repo ≈ 90,000 tokens to reload</a:t>
-            </a:r>
-          </a:p>
-          <a:p>
-            <a:pPr algn="l">
-              <a:spcAft>
-                <a:spcPts val="1200"/>
-              </a:spcAft>
-            </a:pPr>
-            <a:r>
-              <a:rPr sz="1600" b="0">
-                <a:solidFill>
-                  <a:srgbClr val="E8EAF2"/>
-                </a:solidFill>
-                <a:latin typeface="Helvetica Neue"/>
-              </a:rPr>
-              <a:t>•  repeated every session, every task</a:t>
-            </a:r>
-          </a:p>
-          <a:p>
-            <a:pPr algn="l">
-              <a:spcAft>
-                <a:spcPts val="1200"/>
-              </a:spcAft>
-            </a:pPr>
-            <a:r>
-              <a:rPr sz="1600" b="0">
-                <a:solidFill>
-                  <a:srgbClr val="E8EAF2"/>
-                </a:solidFill>
-                <a:latin typeface="Helvetica Neue"/>
-              </a:rPr>
-              <a:t>•  metered/agent billing → frontier prices for repo discovery</a:t>
-            </a:r>
-          </a:p>
-        </p:txBody>
-      </p:sp>
-      <p:sp>
-        <p:nvSpPr>
-          <p:cNvPr id="8" name="Rounded Rectangle 7"/>
+              <a:t>ONLINE — every task</a:t>
+            </a:r>
+          </a:p>
+        </p:txBody>
+      </p:sp>
+      <p:sp>
+        <p:nvSpPr>
+          <p:cNvPr id="17" name="Rounded Rectangle 16"/>
           <p:cNvSpPr/>
           <p:nvPr/>
         </p:nvSpPr>
         <p:spPr>
           <a:xfrm>
-            <a:off x="6217920" y="2011680"/>
-            <a:ext cx="5394960" cy="3383280"/>
+            <a:off x="548640" y="4526280"/>
+            <a:ext cx="3413759" cy="1188720"/>
           </a:xfrm>
           <a:prstGeom prst="roundRect">
             <a:avLst/>
@@ -3718,7 +4302,290 @@
           </a:fontRef>
         </p:style>
         <p:txBody>
-          <a:bodyPr rtlCol="0" anchor="t" wrap="square" lIns="274320" tIns="228600"/>
+          <a:bodyPr rtlCol="0" anchor="ctr" wrap="square"/>
+          <a:lstStyle/>
+          <a:p>
+            <a:pPr algn="ctr">
+              <a:spcAft>
+                <a:spcPts val="200"/>
+              </a:spcAft>
+            </a:pPr>
+            <a:r>
+              <a:rPr sz="1300" b="1">
+                <a:solidFill>
+                  <a:srgbClr val="2DD4A7"/>
+                </a:solidFill>
+                <a:latin typeface="Helvetica Neue"/>
+              </a:rPr>
+              <a:t>Coding task</a:t>
+            </a:r>
+          </a:p>
+          <a:p>
+            <a:pPr algn="ctr">
+              <a:spcAft>
+                <a:spcPts val="0"/>
+              </a:spcAft>
+            </a:pPr>
+            <a:r>
+              <a:rPr sz="1050" b="0">
+                <a:solidFill>
+                  <a:srgbClr val="E8EAF2"/>
+                </a:solidFill>
+                <a:latin typeface="Helvetica Neue"/>
+              </a:rPr>
+              <a:t>question / fix / refactor</a:t>
+            </a:r>
+          </a:p>
+        </p:txBody>
+      </p:sp>
+      <p:sp>
+        <p:nvSpPr>
+          <p:cNvPr id="18" name="TextBox 17"/>
+          <p:cNvSpPr txBox="1"/>
+          <p:nvPr/>
+        </p:nvSpPr>
+        <p:spPr>
+          <a:xfrm>
+            <a:off x="3985260" y="4937760"/>
+            <a:ext cx="365760" cy="365760"/>
+          </a:xfrm>
+          <a:prstGeom prst="rect">
+            <a:avLst/>
+          </a:prstGeom>
+          <a:noFill/>
+        </p:spPr>
+        <p:txBody>
+          <a:bodyPr wrap="none">
+            <a:spAutoFit/>
+          </a:bodyPr>
+          <a:lstStyle/>
+          <a:p>
+            <a:pPr algn="ctr">
+              <a:spcAft>
+                <a:spcPts val="600"/>
+              </a:spcAft>
+            </a:pPr>
+            <a:r>
+              <a:rPr sz="2000" b="1">
+                <a:solidFill>
+                  <a:srgbClr val="9AA0B6"/>
+                </a:solidFill>
+                <a:latin typeface="Helvetica Neue"/>
+              </a:rPr>
+              <a:t>→</a:t>
+            </a:r>
+          </a:p>
+        </p:txBody>
+      </p:sp>
+      <p:sp>
+        <p:nvSpPr>
+          <p:cNvPr id="19" name="Rounded Rectangle 18"/>
+          <p:cNvSpPr/>
+          <p:nvPr/>
+        </p:nvSpPr>
+        <p:spPr>
+          <a:xfrm>
+            <a:off x="4373879" y="4526280"/>
+            <a:ext cx="3413759" cy="1188720"/>
+          </a:xfrm>
+          <a:prstGeom prst="roundRect">
+            <a:avLst/>
+          </a:prstGeom>
+          <a:solidFill>
+            <a:srgbClr val="10131E"/>
+          </a:solidFill>
+          <a:ln w="15875">
+            <a:solidFill>
+              <a:srgbClr val="4AA8FF"/>
+            </a:solidFill>
+          </a:ln>
+          <a:effectLst/>
+        </p:spPr>
+        <p:style>
+          <a:lnRef idx="1">
+            <a:schemeClr val="accent1"/>
+          </a:lnRef>
+          <a:fillRef idx="3">
+            <a:schemeClr val="accent1"/>
+          </a:fillRef>
+          <a:effectRef idx="2">
+            <a:schemeClr val="accent1"/>
+          </a:effectRef>
+          <a:fontRef idx="minor">
+            <a:schemeClr val="lt1"/>
+          </a:fontRef>
+        </p:style>
+        <p:txBody>
+          <a:bodyPr rtlCol="0" anchor="ctr" wrap="square"/>
+          <a:lstStyle/>
+          <a:p>
+            <a:pPr algn="ctr">
+              <a:spcAft>
+                <a:spcPts val="200"/>
+              </a:spcAft>
+            </a:pPr>
+            <a:r>
+              <a:rPr sz="1300" b="1">
+                <a:solidFill>
+                  <a:srgbClr val="4AA8FF"/>
+                </a:solidFill>
+                <a:latin typeface="Helvetica Neue"/>
+              </a:rPr>
+              <a:t>Local context + subagents</a:t>
+            </a:r>
+          </a:p>
+          <a:p>
+            <a:pPr algn="ctr">
+              <a:spcAft>
+                <a:spcPts val="0"/>
+              </a:spcAft>
+            </a:pPr>
+            <a:r>
+              <a:rPr sz="1050" b="0">
+                <a:solidFill>
+                  <a:srgbClr val="E8EAF2"/>
+                </a:solidFill>
+                <a:latin typeface="Helvetica Neue"/>
+              </a:rPr>
+              <a:t>$0 DAG / SKILL.md + RLM — runs local</a:t>
+            </a:r>
+          </a:p>
+        </p:txBody>
+      </p:sp>
+      <p:sp>
+        <p:nvSpPr>
+          <p:cNvPr id="20" name="TextBox 19"/>
+          <p:cNvSpPr txBox="1"/>
+          <p:nvPr/>
+        </p:nvSpPr>
+        <p:spPr>
+          <a:xfrm>
+            <a:off x="7810499" y="4937760"/>
+            <a:ext cx="365760" cy="365760"/>
+          </a:xfrm>
+          <a:prstGeom prst="rect">
+            <a:avLst/>
+          </a:prstGeom>
+          <a:noFill/>
+        </p:spPr>
+        <p:txBody>
+          <a:bodyPr wrap="none">
+            <a:spAutoFit/>
+          </a:bodyPr>
+          <a:lstStyle/>
+          <a:p>
+            <a:pPr algn="ctr">
+              <a:spcAft>
+                <a:spcPts val="600"/>
+              </a:spcAft>
+            </a:pPr>
+            <a:r>
+              <a:rPr sz="2000" b="1">
+                <a:solidFill>
+                  <a:srgbClr val="9AA0B6"/>
+                </a:solidFill>
+                <a:latin typeface="Helvetica Neue"/>
+              </a:rPr>
+              <a:t>→</a:t>
+            </a:r>
+          </a:p>
+        </p:txBody>
+      </p:sp>
+      <p:sp>
+        <p:nvSpPr>
+          <p:cNvPr id="21" name="Rounded Rectangle 20"/>
+          <p:cNvSpPr/>
+          <p:nvPr/>
+        </p:nvSpPr>
+        <p:spPr>
+          <a:xfrm>
+            <a:off x="8199119" y="4526280"/>
+            <a:ext cx="3413759" cy="1188720"/>
+          </a:xfrm>
+          <a:prstGeom prst="roundRect">
+            <a:avLst/>
+          </a:prstGeom>
+          <a:solidFill>
+            <a:srgbClr val="10131E"/>
+          </a:solidFill>
+          <a:ln w="15875">
+            <a:solidFill>
+              <a:srgbClr val="A78BFA"/>
+            </a:solidFill>
+          </a:ln>
+          <a:effectLst/>
+        </p:spPr>
+        <p:style>
+          <a:lnRef idx="1">
+            <a:schemeClr val="accent1"/>
+          </a:lnRef>
+          <a:fillRef idx="3">
+            <a:schemeClr val="accent1"/>
+          </a:fillRef>
+          <a:effectRef idx="2">
+            <a:schemeClr val="accent1"/>
+          </a:effectRef>
+          <a:fontRef idx="minor">
+            <a:schemeClr val="lt1"/>
+          </a:fontRef>
+        </p:style>
+        <p:txBody>
+          <a:bodyPr rtlCol="0" anchor="ctr" wrap="square"/>
+          <a:lstStyle/>
+          <a:p>
+            <a:pPr algn="ctr">
+              <a:spcAft>
+                <a:spcPts val="200"/>
+              </a:spcAft>
+            </a:pPr>
+            <a:r>
+              <a:rPr sz="1300" b="1">
+                <a:solidFill>
+                  <a:srgbClr val="A78BFA"/>
+                </a:solidFill>
+                <a:latin typeface="Helvetica Neue"/>
+              </a:rPr>
+              <a:t>Frontier only when hard</a:t>
+            </a:r>
+          </a:p>
+          <a:p>
+            <a:pPr algn="ctr">
+              <a:spcAft>
+                <a:spcPts val="0"/>
+              </a:spcAft>
+            </a:pPr>
+            <a:r>
+              <a:rPr sz="1050" b="0">
+                <a:solidFill>
+                  <a:srgbClr val="E8EAF2"/>
+                </a:solidFill>
+                <a:latin typeface="Helvetica Neue"/>
+              </a:rPr>
+              <a:t>escalate to Claude / Codex</a:t>
+            </a:r>
+          </a:p>
+        </p:txBody>
+      </p:sp>
+      <p:sp>
+        <p:nvSpPr>
+          <p:cNvPr id="22" name="TextBox 21"/>
+          <p:cNvSpPr txBox="1"/>
+          <p:nvPr/>
+        </p:nvSpPr>
+        <p:spPr>
+          <a:xfrm>
+            <a:off x="548640" y="5806440"/>
+            <a:ext cx="11155680" cy="457200"/>
+          </a:xfrm>
+          <a:prstGeom prst="rect">
+            <a:avLst/>
+          </a:prstGeom>
+          <a:noFill/>
+        </p:spPr>
+        <p:txBody>
+          <a:bodyPr wrap="none">
+            <a:spAutoFit/>
+          </a:bodyPr>
           <a:lstStyle/>
           <a:p>
             <a:pPr algn="l">
@@ -3727,61 +4594,13 @@
               </a:spcAft>
             </a:pPr>
             <a:r>
-              <a:rPr sz="1900" b="1">
-                <a:solidFill>
-                  <a:srgbClr val="2DD4A7"/>
+              <a:rPr sz="1400" b="1">
+                <a:solidFill>
+                  <a:srgbClr val="9AA0B6"/>
                 </a:solidFill>
                 <a:latin typeface="Helvetica Neue"/>
               </a:rPr>
-              <a:t>The waste</a:t>
-            </a:r>
-          </a:p>
-          <a:p>
-            <a:pPr algn="l">
-              <a:spcAft>
-                <a:spcPts val="1400"/>
-              </a:spcAft>
-            </a:pPr>
-            <a:r>
-              <a:rPr sz="1700" b="0">
-                <a:solidFill>
-                  <a:srgbClr val="E8EAF2"/>
-                </a:solidFill>
-                <a:latin typeface="Helvetica Neue"/>
-              </a:rPr>
-              <a:t>It's not the model — it's re-loading context you already have.</a:t>
-            </a:r>
-          </a:p>
-          <a:p>
-            <a:pPr algn="l">
-              <a:spcAft>
-                <a:spcPts val="1400"/>
-              </a:spcAft>
-            </a:pPr>
-            <a:r>
-              <a:rPr sz="1700" b="0">
-                <a:solidFill>
-                  <a:srgbClr val="E8EAF2"/>
-                </a:solidFill>
-                <a:latin typeface="Helvetica Neue"/>
-              </a:rPr>
-              <a:t>An inference-orchestration problem, not a code-model problem.</a:t>
-            </a:r>
-          </a:p>
-          <a:p>
-            <a:pPr algn="l">
-              <a:spcAft>
-                <a:spcPts val="600"/>
-              </a:spcAft>
-            </a:pPr>
-            <a:r>
-              <a:rPr sz="1400" b="0">
-                <a:solidFill>
-                  <a:srgbClr val="9AA0B6"/>
-                </a:solidFill>
-                <a:latin typeface="Helvetica Neue"/>
-              </a:rPr>
-              <a:t>Backed by Repoformer, GraphCoder, LLavaCode, ContextBench.</a:t>
+              <a:t>Substrate:  EverMind = long-term memory   ·   Butterbase = state / backend   ·   eval harness = the proof (−98.7% tokens)</a:t>
             </a:r>
           </a:p>
         </p:txBody>

</xml_diff>

<commit_message>
Reframe: modular reusable context for any local agent (Hermes/OpenClaw), not just code
Co-Authored-By: Claude Opus 4.8 <noreply@anthropic.com>
</commit_message>
<xml_diff>
--- a/demo/autopilot-slides.pptx
+++ b/demo/autopilot-slides.pptx
@@ -3310,7 +3310,7 @@
                 </a:solidFill>
                 <a:latin typeface="Helvetica Neue"/>
               </a:rPr>
-              <a:t>What I'm building: a local-first coding-agent stack — a $0 model that already knows your repo, plus a personal coding model distilled to your codebase and style.</a:t>
+              <a:t>What I'm building: a local-first context engine — index ANY folder (code, docs, notes, projects) into reusable structured memory that Hermes, OpenClaw, or any local agent loads instead of rediscovering it every task.</a:t>
             </a:r>
           </a:p>
         </p:txBody>
@@ -3385,7 +3385,7 @@
                 </a:solidFill>
                 <a:latin typeface="Helvetica Neue"/>
               </a:rPr>
-              <a:t>Claude Code re-reads your repo every session — you pay frontier prices to rediscover structure you already have (≈90K tokens to reload a 359 KB repo, every time).</a:t>
+              <a:t>Local agents (Hermes, OpenClaw, Claude Code) rediscover your project every task — code, docs, notes — burning tokens reloading what they already saw (≈90K to reload a 359 KB project).</a:t>
             </a:r>
           </a:p>
         </p:txBody>
@@ -3460,7 +3460,7 @@
                 </a:solidFill>
                 <a:latin typeface="Helvetica Neue"/>
               </a:rPr>
-              <a:t>Keep a live local map (SKILL.md + DAG) and a small MLX model for the cheap work; escalate to the frontier only for the hard step — ~99% fewer tokens, same result.</a:t>
+              <a:t>Index it once into a reusable SKILL.md + DAG map. Any local agent reuses it across tasks; a small MLX model does the cheap work, frontier only for the hard step — ~99% fewer tokens.</a:t>
             </a:r>
           </a:p>
         </p:txBody>
@@ -4786,7 +4786,7 @@
                 </a:solidFill>
                 <a:latin typeface="Helvetica Neue"/>
               </a:rPr>
-              <a:t>USE CASE</a:t>
+              <a:t>MODULAR — NOT JUST CODE</a:t>
             </a:r>
           </a:p>
         </p:txBody>
@@ -4800,7 +4800,7 @@
         <p:spPr>
           <a:xfrm>
             <a:off x="548640" y="914400"/>
-            <a:ext cx="10972800" cy="914400"/>
+            <a:ext cx="11155680" cy="731520"/>
           </a:xfrm>
           <a:prstGeom prst="rect">
             <a:avLst/>
@@ -4819,13 +4819,13 @@
               </a:spcAft>
             </a:pPr>
             <a:r>
-              <a:rPr sz="3200" b="1">
+              <a:rPr sz="3000" b="1">
                 <a:solidFill>
                   <a:srgbClr val="E8EAF2"/>
                 </a:solidFill>
                 <a:latin typeface="Helvetica Neue"/>
               </a:rPr>
-              <a:t>You, on a real repo, all day</a:t>
+              <a:t>Index anything on your computer</a:t>
             </a:r>
           </a:p>
         </p:txBody>
@@ -4838,8 +4838,8 @@
         </p:nvSpPr>
         <p:spPr>
           <a:xfrm>
-            <a:off x="548640" y="2011680"/>
-            <a:ext cx="10972800" cy="3200400"/>
+            <a:off x="548640" y="1572768"/>
+            <a:ext cx="11155680" cy="548640"/>
           </a:xfrm>
           <a:prstGeom prst="rect">
             <a:avLst/>
@@ -4854,65 +4854,410 @@
           <a:p>
             <a:pPr algn="l">
               <a:spcAft>
-                <a:spcPts val="1400"/>
+                <a:spcPts val="600"/>
               </a:spcAft>
             </a:pPr>
             <a:r>
-              <a:rPr sz="1900" b="0">
-                <a:solidFill>
-                  <a:srgbClr val="E8EAF2"/>
+              <a:rPr sz="1500" b="0">
+                <a:solidFill>
+                  <a:srgbClr val="9AA0B6"/>
                 </a:solidFill>
                 <a:latin typeface="Helvetica Neue"/>
               </a:rPr>
-              <a:t>•  Solo founder / small team living in Claude Code or Codex on one codebase.</a:t>
-            </a:r>
-          </a:p>
+              <a:t>One CLI turns any folder into reusable structured context (SKILL.md + index) — agents load it instead of re-reading from scratch.</a:t>
+            </a:r>
+          </a:p>
+        </p:txBody>
+      </p:sp>
+      <p:sp>
+        <p:nvSpPr>
+          <p:cNvPr id="8" name="Rounded Rectangle 7"/>
+          <p:cNvSpPr/>
+          <p:nvPr/>
+        </p:nvSpPr>
+        <p:spPr>
+          <a:xfrm>
+            <a:off x="548640" y="2286000"/>
+            <a:ext cx="3447288" cy="960120"/>
+          </a:xfrm>
+          <a:prstGeom prst="roundRect">
+            <a:avLst/>
+          </a:prstGeom>
+          <a:solidFill>
+            <a:srgbClr val="10131E"/>
+          </a:solidFill>
+          <a:ln w="15875">
+            <a:solidFill>
+              <a:srgbClr val="2DD4A7"/>
+            </a:solidFill>
+          </a:ln>
+          <a:effectLst/>
+        </p:spPr>
+        <p:style>
+          <a:lnRef idx="1">
+            <a:schemeClr val="accent1"/>
+          </a:lnRef>
+          <a:fillRef idx="3">
+            <a:schemeClr val="accent1"/>
+          </a:fillRef>
+          <a:effectRef idx="2">
+            <a:schemeClr val="accent1"/>
+          </a:effectRef>
+          <a:fontRef idx="minor">
+            <a:schemeClr val="lt1"/>
+          </a:fontRef>
+        </p:style>
+        <p:txBody>
+          <a:bodyPr rtlCol="0" anchor="ctr" wrap="square"/>
+          <a:lstStyle/>
+          <a:p>
+            <a:pPr algn="ctr">
+              <a:spcAft>
+                <a:spcPts val="600"/>
+              </a:spcAft>
+            </a:pPr>
+            <a:r>
+              <a:rPr sz="1600" b="1">
+                <a:solidFill>
+                  <a:srgbClr val="2DD4A7"/>
+                </a:solidFill>
+                <a:latin typeface="Helvetica Neue"/>
+              </a:rPr>
+              <a:t>Codebases</a:t>
+            </a:r>
+          </a:p>
+        </p:txBody>
+      </p:sp>
+      <p:sp>
+        <p:nvSpPr>
+          <p:cNvPr id="9" name="Rounded Rectangle 8"/>
+          <p:cNvSpPr/>
+          <p:nvPr/>
+        </p:nvSpPr>
+        <p:spPr>
+          <a:xfrm>
+            <a:off x="4361688" y="2286000"/>
+            <a:ext cx="3447288" cy="960120"/>
+          </a:xfrm>
+          <a:prstGeom prst="roundRect">
+            <a:avLst/>
+          </a:prstGeom>
+          <a:solidFill>
+            <a:srgbClr val="10131E"/>
+          </a:solidFill>
+          <a:ln w="15875">
+            <a:solidFill>
+              <a:srgbClr val="4AA8FF"/>
+            </a:solidFill>
+          </a:ln>
+          <a:effectLst/>
+        </p:spPr>
+        <p:style>
+          <a:lnRef idx="1">
+            <a:schemeClr val="accent1"/>
+          </a:lnRef>
+          <a:fillRef idx="3">
+            <a:schemeClr val="accent1"/>
+          </a:fillRef>
+          <a:effectRef idx="2">
+            <a:schemeClr val="accent1"/>
+          </a:effectRef>
+          <a:fontRef idx="minor">
+            <a:schemeClr val="lt1"/>
+          </a:fontRef>
+        </p:style>
+        <p:txBody>
+          <a:bodyPr rtlCol="0" anchor="ctr" wrap="square"/>
+          <a:lstStyle/>
+          <a:p>
+            <a:pPr algn="ctr">
+              <a:spcAft>
+                <a:spcPts val="600"/>
+              </a:spcAft>
+            </a:pPr>
+            <a:r>
+              <a:rPr sz="1600" b="1">
+                <a:solidFill>
+                  <a:srgbClr val="4AA8FF"/>
+                </a:solidFill>
+                <a:latin typeface="Helvetica Neue"/>
+              </a:rPr>
+              <a:t>Docs &amp; notes</a:t>
+            </a:r>
+          </a:p>
+        </p:txBody>
+      </p:sp>
+      <p:sp>
+        <p:nvSpPr>
+          <p:cNvPr id="10" name="Rounded Rectangle 9"/>
+          <p:cNvSpPr/>
+          <p:nvPr/>
+        </p:nvSpPr>
+        <p:spPr>
+          <a:xfrm>
+            <a:off x="8174736" y="2286000"/>
+            <a:ext cx="3447288" cy="960120"/>
+          </a:xfrm>
+          <a:prstGeom prst="roundRect">
+            <a:avLst/>
+          </a:prstGeom>
+          <a:solidFill>
+            <a:srgbClr val="10131E"/>
+          </a:solidFill>
+          <a:ln w="15875">
+            <a:solidFill>
+              <a:srgbClr val="A78BFA"/>
+            </a:solidFill>
+          </a:ln>
+          <a:effectLst/>
+        </p:spPr>
+        <p:style>
+          <a:lnRef idx="1">
+            <a:schemeClr val="accent1"/>
+          </a:lnRef>
+          <a:fillRef idx="3">
+            <a:schemeClr val="accent1"/>
+          </a:fillRef>
+          <a:effectRef idx="2">
+            <a:schemeClr val="accent1"/>
+          </a:effectRef>
+          <a:fontRef idx="minor">
+            <a:schemeClr val="lt1"/>
+          </a:fontRef>
+        </p:style>
+        <p:txBody>
+          <a:bodyPr rtlCol="0" anchor="ctr" wrap="square"/>
+          <a:lstStyle/>
+          <a:p>
+            <a:pPr algn="ctr">
+              <a:spcAft>
+                <a:spcPts val="600"/>
+              </a:spcAft>
+            </a:pPr>
+            <a:r>
+              <a:rPr sz="1600" b="1">
+                <a:solidFill>
+                  <a:srgbClr val="A78BFA"/>
+                </a:solidFill>
+                <a:latin typeface="Helvetica Neue"/>
+              </a:rPr>
+              <a:t>Sales materials</a:t>
+            </a:r>
+          </a:p>
+        </p:txBody>
+      </p:sp>
+      <p:sp>
+        <p:nvSpPr>
+          <p:cNvPr id="11" name="Rounded Rectangle 10"/>
+          <p:cNvSpPr/>
+          <p:nvPr/>
+        </p:nvSpPr>
+        <p:spPr>
+          <a:xfrm>
+            <a:off x="548640" y="3520440"/>
+            <a:ext cx="3447288" cy="960120"/>
+          </a:xfrm>
+          <a:prstGeom prst="roundRect">
+            <a:avLst/>
+          </a:prstGeom>
+          <a:solidFill>
+            <a:srgbClr val="10131E"/>
+          </a:solidFill>
+          <a:ln w="15875">
+            <a:solidFill>
+              <a:srgbClr val="FF7849"/>
+            </a:solidFill>
+          </a:ln>
+          <a:effectLst/>
+        </p:spPr>
+        <p:style>
+          <a:lnRef idx="1">
+            <a:schemeClr val="accent1"/>
+          </a:lnRef>
+          <a:fillRef idx="3">
+            <a:schemeClr val="accent1"/>
+          </a:fillRef>
+          <a:effectRef idx="2">
+            <a:schemeClr val="accent1"/>
+          </a:effectRef>
+          <a:fontRef idx="minor">
+            <a:schemeClr val="lt1"/>
+          </a:fontRef>
+        </p:style>
+        <p:txBody>
+          <a:bodyPr rtlCol="0" anchor="ctr" wrap="square"/>
+          <a:lstStyle/>
+          <a:p>
+            <a:pPr algn="ctr">
+              <a:spcAft>
+                <a:spcPts val="600"/>
+              </a:spcAft>
+            </a:pPr>
+            <a:r>
+              <a:rPr sz="1600" b="1">
+                <a:solidFill>
+                  <a:srgbClr val="FF7849"/>
+                </a:solidFill>
+                <a:latin typeface="Helvetica Neue"/>
+              </a:rPr>
+              <a:t>Marketing assets</a:t>
+            </a:r>
+          </a:p>
+        </p:txBody>
+      </p:sp>
+      <p:sp>
+        <p:nvSpPr>
+          <p:cNvPr id="12" name="Rounded Rectangle 11"/>
+          <p:cNvSpPr/>
+          <p:nvPr/>
+        </p:nvSpPr>
+        <p:spPr>
+          <a:xfrm>
+            <a:off x="4361688" y="3520440"/>
+            <a:ext cx="3447288" cy="960120"/>
+          </a:xfrm>
+          <a:prstGeom prst="roundRect">
+            <a:avLst/>
+          </a:prstGeom>
+          <a:solidFill>
+            <a:srgbClr val="10131E"/>
+          </a:solidFill>
+          <a:ln w="15875">
+            <a:solidFill>
+              <a:srgbClr val="2DD4A7"/>
+            </a:solidFill>
+          </a:ln>
+          <a:effectLst/>
+        </p:spPr>
+        <p:style>
+          <a:lnRef idx="1">
+            <a:schemeClr val="accent1"/>
+          </a:lnRef>
+          <a:fillRef idx="3">
+            <a:schemeClr val="accent1"/>
+          </a:fillRef>
+          <a:effectRef idx="2">
+            <a:schemeClr val="accent1"/>
+          </a:effectRef>
+          <a:fontRef idx="minor">
+            <a:schemeClr val="lt1"/>
+          </a:fontRef>
+        </p:style>
+        <p:txBody>
+          <a:bodyPr rtlCol="0" anchor="ctr" wrap="square"/>
+          <a:lstStyle/>
+          <a:p>
+            <a:pPr algn="ctr">
+              <a:spcAft>
+                <a:spcPts val="600"/>
+              </a:spcAft>
+            </a:pPr>
+            <a:r>
+              <a:rPr sz="1600" b="1">
+                <a:solidFill>
+                  <a:srgbClr val="2DD4A7"/>
+                </a:solidFill>
+                <a:latin typeface="Helvetica Neue"/>
+              </a:rPr>
+              <a:t>Customer research</a:t>
+            </a:r>
+          </a:p>
+        </p:txBody>
+      </p:sp>
+      <p:sp>
+        <p:nvSpPr>
+          <p:cNvPr id="13" name="Rounded Rectangle 12"/>
+          <p:cNvSpPr/>
+          <p:nvPr/>
+        </p:nvSpPr>
+        <p:spPr>
+          <a:xfrm>
+            <a:off x="8174736" y="3520440"/>
+            <a:ext cx="3447288" cy="960120"/>
+          </a:xfrm>
+          <a:prstGeom prst="roundRect">
+            <a:avLst/>
+          </a:prstGeom>
+          <a:solidFill>
+            <a:srgbClr val="10131E"/>
+          </a:solidFill>
+          <a:ln w="15875">
+            <a:solidFill>
+              <a:srgbClr val="4AA8FF"/>
+            </a:solidFill>
+          </a:ln>
+          <a:effectLst/>
+        </p:spPr>
+        <p:style>
+          <a:lnRef idx="1">
+            <a:schemeClr val="accent1"/>
+          </a:lnRef>
+          <a:fillRef idx="3">
+            <a:schemeClr val="accent1"/>
+          </a:fillRef>
+          <a:effectRef idx="2">
+            <a:schemeClr val="accent1"/>
+          </a:effectRef>
+          <a:fontRef idx="minor">
+            <a:schemeClr val="lt1"/>
+          </a:fontRef>
+        </p:style>
+        <p:txBody>
+          <a:bodyPr rtlCol="0" anchor="ctr" wrap="square"/>
+          <a:lstStyle/>
+          <a:p>
+            <a:pPr algn="ctr">
+              <a:spcAft>
+                <a:spcPts val="600"/>
+              </a:spcAft>
+            </a:pPr>
+            <a:r>
+              <a:rPr sz="1600" b="1">
+                <a:solidFill>
+                  <a:srgbClr val="4AA8FF"/>
+                </a:solidFill>
+                <a:latin typeface="Helvetica Neue"/>
+              </a:rPr>
+              <a:t>Project folders &amp; workflows</a:t>
+            </a:r>
+          </a:p>
+        </p:txBody>
+      </p:sp>
+      <p:sp>
+        <p:nvSpPr>
+          <p:cNvPr id="14" name="TextBox 13"/>
+          <p:cNvSpPr txBox="1"/>
+          <p:nvPr/>
+        </p:nvSpPr>
+        <p:spPr>
+          <a:xfrm>
+            <a:off x="548640" y="5029200"/>
+            <a:ext cx="11155680" cy="914400"/>
+          </a:xfrm>
+          <a:prstGeom prst="rect">
+            <a:avLst/>
+          </a:prstGeom>
+          <a:noFill/>
+        </p:spPr>
+        <p:txBody>
+          <a:bodyPr wrap="none">
+            <a:spAutoFit/>
+          </a:bodyPr>
+          <a:lstStyle/>
           <a:p>
             <a:pPr algn="l">
               <a:spcAft>
-                <a:spcPts val="1400"/>
+                <a:spcPts val="600"/>
               </a:spcAft>
             </a:pPr>
             <a:r>
-              <a:rPr sz="1900" b="0">
+              <a:rPr sz="1700" b="1">
                 <a:solidFill>
                   <a:srgbClr val="E8EAF2"/>
                 </a:solidFill>
                 <a:latin typeface="Helvetica Neue"/>
               </a:rPr>
-              <a:t>•  Asking codebase questions, fixing tests, scaffolding, refactoring — dozens of times a day.</a:t>
-            </a:r>
-          </a:p>
-          <a:p>
-            <a:pPr algn="l">
-              <a:spcAft>
-                <a:spcPts val="1400"/>
-              </a:spcAft>
-            </a:pPr>
-            <a:r>
-              <a:rPr sz="1900" b="0">
-                <a:solidFill>
-                  <a:srgbClr val="E8EAF2"/>
-                </a:solidFill>
-                <a:latin typeface="Helvetica Neue"/>
-              </a:rPr>
-              <a:t>•  Each ask re-pays for repo discovery. The bill compounds outside the model call.</a:t>
-            </a:r>
-          </a:p>
-          <a:p>
-            <a:pPr algn="l">
-              <a:spcAft>
-                <a:spcPts val="1400"/>
-              </a:spcAft>
-            </a:pPr>
-            <a:r>
-              <a:rPr sz="1900" b="0">
-                <a:solidFill>
-                  <a:srgbClr val="E8EAF2"/>
-                </a:solidFill>
-                <a:latin typeface="Helvetica Neue"/>
-              </a:rPr>
-              <a:t>•  You want the agent to already know your files, conventions, and prior decisions.</a:t>
+              <a:t>Hermes · OpenClaw · Claude Code · any local agent reuse the SAME structured context across tasks — instead of rediscovering everything from scratch every time.</a:t>
             </a:r>
           </a:p>
         </p:txBody>

</xml_diff>

<commit_message>
Rename to Context Autopilot (modular reusable context); repo -> context-autopilot
Co-Authored-By: Claude Opus 4.8 <noreply@anthropic.com>
</commit_message>
<xml_diff>
--- a/demo/autopilot-slides.pptx
+++ b/demo/autopilot-slides.pptx
@@ -12,6 +12,7 @@
     <p:sldId id="260" r:id="rId11"/>
     <p:sldId id="261" r:id="rId12"/>
     <p:sldId id="262" r:id="rId13"/>
+    <p:sldId id="263" r:id="rId14"/>
   </p:sldIdLst>
   <p:sldSz cx="12191695" cy="6858000" type="screen4x3"/>
   <p:notesSz cx="6858000" cy="9144000"/>
@@ -3255,7 +3256,7 @@
                 </a:solidFill>
                 <a:latin typeface="Helvetica Neue"/>
               </a:rPr>
-              <a:t>Personal Coding Model Autopilot</a:t>
+              <a:t>Context Autopilot</a:t>
             </a:r>
           </a:p>
           <a:p>
@@ -3499,7 +3500,7 @@
                 </a:solidFill>
                 <a:latin typeface="Helvetica Neue"/>
               </a:rPr>
-              <a:t>github.com/OCWC22/personal-coding-autopilot</a:t>
+              <a:t>github.com/OCWC22/context-autopilot</a:t>
             </a:r>
           </a:p>
         </p:txBody>
@@ -3646,7 +3647,7 @@
                   <a:srgbClr val="9AA0B6"/>
                 </a:solidFill>
               </a:rPr>
-              <a:t>        2/7</a:t>
+              <a:t>        2/8</a:t>
             </a:r>
           </a:p>
         </p:txBody>
@@ -4747,7 +4748,7 @@
                   <a:srgbClr val="9AA0B6"/>
                 </a:solidFill>
               </a:rPr>
-              <a:t>        3/7</a:t>
+              <a:t>        3/8</a:t>
             </a:r>
           </a:p>
         </p:txBody>
@@ -4782,11 +4783,11 @@
             <a:r>
               <a:rPr sz="1500" b="1">
                 <a:solidFill>
-                  <a:srgbClr val="2DD4A7"/>
-                </a:solidFill>
-                <a:latin typeface="Helvetica Neue"/>
-              </a:rPr>
-              <a:t>MODULAR — NOT JUST CODE</a:t>
+                  <a:srgbClr val="A78BFA"/>
+                </a:solidFill>
+                <a:latin typeface="Helvetica Neue"/>
+              </a:rPr>
+              <a:t>SPONSORS — HOW IT CONNECTS</a:t>
             </a:r>
           </a:p>
         </p:txBody>
@@ -4819,66 +4820,27 @@
               </a:spcAft>
             </a:pPr>
             <a:r>
-              <a:rPr sz="3000" b="1">
+              <a:rPr sz="2600" b="1">
                 <a:solidFill>
                   <a:srgbClr val="E8EAF2"/>
                 </a:solidFill>
                 <a:latin typeface="Helvetica Neue"/>
               </a:rPr>
-              <a:t>Index anything on your computer</a:t>
-            </a:r>
-          </a:p>
-        </p:txBody>
-      </p:sp>
-      <p:sp>
-        <p:nvSpPr>
-          <p:cNvPr id="7" name="TextBox 6"/>
-          <p:cNvSpPr txBox="1"/>
-          <p:nvPr/>
-        </p:nvSpPr>
-        <p:spPr>
-          <a:xfrm>
-            <a:off x="548640" y="1572768"/>
-            <a:ext cx="11155680" cy="548640"/>
-          </a:xfrm>
-          <a:prstGeom prst="rect">
-            <a:avLst/>
-          </a:prstGeom>
-          <a:noFill/>
-        </p:spPr>
-        <p:txBody>
-          <a:bodyPr wrap="none">
-            <a:spAutoFit/>
-          </a:bodyPr>
-          <a:lstStyle/>
-          <a:p>
-            <a:pPr algn="l">
-              <a:spcAft>
-                <a:spcPts val="600"/>
-              </a:spcAft>
-            </a:pPr>
-            <a:r>
-              <a:rPr sz="1500" b="0">
-                <a:solidFill>
-                  <a:srgbClr val="9AA0B6"/>
-                </a:solidFill>
-                <a:latin typeface="Helvetica Neue"/>
-              </a:rPr>
-              <a:t>One CLI turns any folder into reusable structured context (SKILL.md + index) — agents load it instead of re-reading from scratch.</a:t>
-            </a:r>
-          </a:p>
-        </p:txBody>
-      </p:sp>
-      <p:sp>
-        <p:nvSpPr>
-          <p:cNvPr id="8" name="Rounded Rectangle 7"/>
+              <a:t>Local source of truth × cloud memory × durable state</a:t>
+            </a:r>
+          </a:p>
+        </p:txBody>
+      </p:sp>
+      <p:sp>
+        <p:nvSpPr>
+          <p:cNvPr id="7" name="Rounded Rectangle 6"/>
           <p:cNvSpPr/>
           <p:nvPr/>
         </p:nvSpPr>
         <p:spPr>
           <a:xfrm>
-            <a:off x="548640" y="2286000"/>
-            <a:ext cx="3447288" cy="960120"/>
+            <a:off x="548640" y="1874519"/>
+            <a:ext cx="5440680" cy="3200400"/>
           </a:xfrm>
           <a:prstGeom prst="roundRect">
             <a:avLst/>
@@ -4888,7 +4850,7 @@
           </a:solidFill>
           <a:ln w="15875">
             <a:solidFill>
-              <a:srgbClr val="2DD4A7"/>
+              <a:srgbClr val="A78BFA"/>
             </a:solidFill>
           </a:ln>
           <a:effectLst/>
@@ -4908,36 +4870,68 @@
           </a:fontRef>
         </p:style>
         <p:txBody>
-          <a:bodyPr rtlCol="0" anchor="ctr" wrap="square"/>
-          <a:lstStyle/>
-          <a:p>
-            <a:pPr algn="ctr">
+          <a:bodyPr rtlCol="0" anchor="t" wrap="square" lIns="256032" tIns="201168" rIns="182880"/>
+          <a:lstStyle/>
+          <a:p>
+            <a:pPr algn="l">
               <a:spcAft>
                 <a:spcPts val="600"/>
               </a:spcAft>
             </a:pPr>
             <a:r>
-              <a:rPr sz="1600" b="1">
-                <a:solidFill>
-                  <a:srgbClr val="2DD4A7"/>
-                </a:solidFill>
-                <a:latin typeface="Helvetica Neue"/>
-              </a:rPr>
-              <a:t>Codebases</a:t>
-            </a:r>
-          </a:p>
-        </p:txBody>
-      </p:sp>
-      <p:sp>
-        <p:nvSpPr>
-          <p:cNvPr id="9" name="Rounded Rectangle 8"/>
+              <a:rPr sz="1800" b="1">
+                <a:solidFill>
+                  <a:srgbClr val="A78BFA"/>
+                </a:solidFill>
+                <a:latin typeface="Helvetica Neue"/>
+              </a:rPr>
+              <a:t>EverMind / EverOS — long-term memory</a:t>
+            </a:r>
+          </a:p>
+          <a:p>
+            <a:pPr algn="l">
+              <a:spcAft>
+                <a:spcPts val="1000"/>
+              </a:spcAft>
+            </a:pPr>
+            <a:r>
+              <a:rPr sz="1400" b="0">
+                <a:solidFill>
+                  <a:srgbClr val="E8EAF2"/>
+                </a:solidFill>
+                <a:latin typeface="Helvetica Neue"/>
+              </a:rPr>
+              <a:t>We EXTEND it with a LOCAL source of truth: the $0 index keeps your current files, structure &amp; decisions fresh and deterministic, on-device.</a:t>
+            </a:r>
+          </a:p>
+          <a:p>
+            <a:pPr algn="l">
+              <a:spcAft>
+                <a:spcPts val="600"/>
+              </a:spcAft>
+            </a:pPr>
+            <a:r>
+              <a:rPr sz="1400" b="0">
+                <a:solidFill>
+                  <a:srgbClr val="E8EAF2"/>
+                </a:solidFill>
+                <a:latin typeface="Helvetica Neue"/>
+              </a:rPr>
+              <a:t>Those traces flow into EverMind, so memory is both fresh (local) and persistent across sessions — long-context personal memory.</a:t>
+            </a:r>
+          </a:p>
+        </p:txBody>
+      </p:sp>
+      <p:sp>
+        <p:nvSpPr>
+          <p:cNvPr id="8" name="Rounded Rectangle 7"/>
           <p:cNvSpPr/>
           <p:nvPr/>
         </p:nvSpPr>
         <p:spPr>
           <a:xfrm>
-            <a:off x="4361688" y="2286000"/>
-            <a:ext cx="3447288" cy="960120"/>
+            <a:off x="6199632" y="1874519"/>
+            <a:ext cx="5440680" cy="3200400"/>
           </a:xfrm>
           <a:prstGeom prst="roundRect">
             <a:avLst/>
@@ -4967,272 +4961,68 @@
           </a:fontRef>
         </p:style>
         <p:txBody>
-          <a:bodyPr rtlCol="0" anchor="ctr" wrap="square"/>
-          <a:lstStyle/>
-          <a:p>
-            <a:pPr algn="ctr">
+          <a:bodyPr rtlCol="0" anchor="t" wrap="square" lIns="256032" tIns="201168" rIns="182880"/>
+          <a:lstStyle/>
+          <a:p>
+            <a:pPr algn="l">
               <a:spcAft>
                 <a:spcPts val="600"/>
               </a:spcAft>
             </a:pPr>
             <a:r>
-              <a:rPr sz="1600" b="1">
+              <a:rPr sz="1800" b="1">
                 <a:solidFill>
                   <a:srgbClr val="4AA8FF"/>
                 </a:solidFill>
                 <a:latin typeface="Helvetica Neue"/>
               </a:rPr>
-              <a:t>Docs &amp; notes</a:t>
-            </a:r>
-          </a:p>
-        </p:txBody>
-      </p:sp>
-      <p:sp>
-        <p:nvSpPr>
-          <p:cNvPr id="10" name="Rounded Rectangle 9"/>
-          <p:cNvSpPr/>
-          <p:nvPr/>
-        </p:nvSpPr>
-        <p:spPr>
-          <a:xfrm>
-            <a:off x="8174736" y="2286000"/>
-            <a:ext cx="3447288" cy="960120"/>
-          </a:xfrm>
-          <a:prstGeom prst="roundRect">
-            <a:avLst/>
-          </a:prstGeom>
-          <a:solidFill>
-            <a:srgbClr val="10131E"/>
-          </a:solidFill>
-          <a:ln w="15875">
-            <a:solidFill>
-              <a:srgbClr val="A78BFA"/>
-            </a:solidFill>
-          </a:ln>
-          <a:effectLst/>
-        </p:spPr>
-        <p:style>
-          <a:lnRef idx="1">
-            <a:schemeClr val="accent1"/>
-          </a:lnRef>
-          <a:fillRef idx="3">
-            <a:schemeClr val="accent1"/>
-          </a:fillRef>
-          <a:effectRef idx="2">
-            <a:schemeClr val="accent1"/>
-          </a:effectRef>
-          <a:fontRef idx="minor">
-            <a:schemeClr val="lt1"/>
-          </a:fontRef>
-        </p:style>
-        <p:txBody>
-          <a:bodyPr rtlCol="0" anchor="ctr" wrap="square"/>
-          <a:lstStyle/>
-          <a:p>
-            <a:pPr algn="ctr">
+              <a:t>Butterbase — state &amp; backend</a:t>
+            </a:r>
+          </a:p>
+          <a:p>
+            <a:pPr algn="l">
+              <a:spcAft>
+                <a:spcPts val="1000"/>
+              </a:spcAft>
+            </a:pPr>
+            <a:r>
+              <a:rPr sz="1400" b="0">
+                <a:solidFill>
+                  <a:srgbClr val="E8EAF2"/>
+                </a:solidFill>
+                <a:latin typeface="Helvetica Neue"/>
+              </a:rPr>
+              <a:t>We CONNECT via the Data API: projects, task state, tool-call traces, eval results &amp; artifacts persist as structured rows (Postgres + auth + storage).</a:t>
+            </a:r>
+          </a:p>
+          <a:p>
+            <a:pPr algn="l">
               <a:spcAft>
                 <a:spcPts val="600"/>
               </a:spcAft>
             </a:pPr>
             <a:r>
-              <a:rPr sz="1600" b="1">
-                <a:solidFill>
-                  <a:srgbClr val="A78BFA"/>
-                </a:solidFill>
-                <a:latin typeface="Helvetica Neue"/>
-              </a:rPr>
-              <a:t>Sales materials</a:t>
-            </a:r>
-          </a:p>
-        </p:txBody>
-      </p:sp>
-      <p:sp>
-        <p:nvSpPr>
-          <p:cNvPr id="11" name="Rounded Rectangle 10"/>
-          <p:cNvSpPr/>
-          <p:nvPr/>
-        </p:nvSpPr>
-        <p:spPr>
-          <a:xfrm>
-            <a:off x="548640" y="3520440"/>
-            <a:ext cx="3447288" cy="960120"/>
-          </a:xfrm>
-          <a:prstGeom prst="roundRect">
-            <a:avLst/>
-          </a:prstGeom>
-          <a:solidFill>
-            <a:srgbClr val="10131E"/>
-          </a:solidFill>
-          <a:ln w="15875">
-            <a:solidFill>
-              <a:srgbClr val="FF7849"/>
-            </a:solidFill>
-          </a:ln>
-          <a:effectLst/>
-        </p:spPr>
-        <p:style>
-          <a:lnRef idx="1">
-            <a:schemeClr val="accent1"/>
-          </a:lnRef>
-          <a:fillRef idx="3">
-            <a:schemeClr val="accent1"/>
-          </a:fillRef>
-          <a:effectRef idx="2">
-            <a:schemeClr val="accent1"/>
-          </a:effectRef>
-          <a:fontRef idx="minor">
-            <a:schemeClr val="lt1"/>
-          </a:fontRef>
-        </p:style>
-        <p:txBody>
-          <a:bodyPr rtlCol="0" anchor="ctr" wrap="square"/>
-          <a:lstStyle/>
-          <a:p>
-            <a:pPr algn="ctr">
-              <a:spcAft>
-                <a:spcPts val="600"/>
-              </a:spcAft>
-            </a:pPr>
-            <a:r>
-              <a:rPr sz="1600" b="1">
-                <a:solidFill>
-                  <a:srgbClr val="FF7849"/>
-                </a:solidFill>
-                <a:latin typeface="Helvetica Neue"/>
-              </a:rPr>
-              <a:t>Marketing assets</a:t>
-            </a:r>
-          </a:p>
-        </p:txBody>
-      </p:sp>
-      <p:sp>
-        <p:nvSpPr>
-          <p:cNvPr id="12" name="Rounded Rectangle 11"/>
-          <p:cNvSpPr/>
-          <p:nvPr/>
-        </p:nvSpPr>
-        <p:spPr>
-          <a:xfrm>
-            <a:off x="4361688" y="3520440"/>
-            <a:ext cx="3447288" cy="960120"/>
-          </a:xfrm>
-          <a:prstGeom prst="roundRect">
-            <a:avLst/>
-          </a:prstGeom>
-          <a:solidFill>
-            <a:srgbClr val="10131E"/>
-          </a:solidFill>
-          <a:ln w="15875">
-            <a:solidFill>
-              <a:srgbClr val="2DD4A7"/>
-            </a:solidFill>
-          </a:ln>
-          <a:effectLst/>
-        </p:spPr>
-        <p:style>
-          <a:lnRef idx="1">
-            <a:schemeClr val="accent1"/>
-          </a:lnRef>
-          <a:fillRef idx="3">
-            <a:schemeClr val="accent1"/>
-          </a:fillRef>
-          <a:effectRef idx="2">
-            <a:schemeClr val="accent1"/>
-          </a:effectRef>
-          <a:fontRef idx="minor">
-            <a:schemeClr val="lt1"/>
-          </a:fontRef>
-        </p:style>
-        <p:txBody>
-          <a:bodyPr rtlCol="0" anchor="ctr" wrap="square"/>
-          <a:lstStyle/>
-          <a:p>
-            <a:pPr algn="ctr">
-              <a:spcAft>
-                <a:spcPts val="600"/>
-              </a:spcAft>
-            </a:pPr>
-            <a:r>
-              <a:rPr sz="1600" b="1">
-                <a:solidFill>
-                  <a:srgbClr val="2DD4A7"/>
-                </a:solidFill>
-                <a:latin typeface="Helvetica Neue"/>
-              </a:rPr>
-              <a:t>Customer research</a:t>
-            </a:r>
-          </a:p>
-        </p:txBody>
-      </p:sp>
-      <p:sp>
-        <p:nvSpPr>
-          <p:cNvPr id="13" name="Rounded Rectangle 12"/>
-          <p:cNvSpPr/>
-          <p:nvPr/>
-        </p:nvSpPr>
-        <p:spPr>
-          <a:xfrm>
-            <a:off x="8174736" y="3520440"/>
-            <a:ext cx="3447288" cy="960120"/>
-          </a:xfrm>
-          <a:prstGeom prst="roundRect">
-            <a:avLst/>
-          </a:prstGeom>
-          <a:solidFill>
-            <a:srgbClr val="10131E"/>
-          </a:solidFill>
-          <a:ln w="15875">
-            <a:solidFill>
-              <a:srgbClr val="4AA8FF"/>
-            </a:solidFill>
-          </a:ln>
-          <a:effectLst/>
-        </p:spPr>
-        <p:style>
-          <a:lnRef idx="1">
-            <a:schemeClr val="accent1"/>
-          </a:lnRef>
-          <a:fillRef idx="3">
-            <a:schemeClr val="accent1"/>
-          </a:fillRef>
-          <a:effectRef idx="2">
-            <a:schemeClr val="accent1"/>
-          </a:effectRef>
-          <a:fontRef idx="minor">
-            <a:schemeClr val="lt1"/>
-          </a:fontRef>
-        </p:style>
-        <p:txBody>
-          <a:bodyPr rtlCol="0" anchor="ctr" wrap="square"/>
-          <a:lstStyle/>
-          <a:p>
-            <a:pPr algn="ctr">
-              <a:spcAft>
-                <a:spcPts val="600"/>
-              </a:spcAft>
-            </a:pPr>
-            <a:r>
-              <a:rPr sz="1600" b="1">
-                <a:solidFill>
-                  <a:srgbClr val="4AA8FF"/>
-                </a:solidFill>
-                <a:latin typeface="Helvetica Neue"/>
-              </a:rPr>
-              <a:t>Project folders &amp; workflows</a:t>
-            </a:r>
-          </a:p>
-        </p:txBody>
-      </p:sp>
-      <p:sp>
-        <p:nvSpPr>
-          <p:cNvPr id="14" name="TextBox 13"/>
+              <a:rPr sz="1400" b="0">
+                <a:solidFill>
+                  <a:srgbClr val="E8EAF2"/>
+                </a:solidFill>
+                <a:latin typeface="Helvetica Neue"/>
+              </a:rPr>
+              <a:t>Agents read/write durable state instead of holding it in context. Live: app app_b197i2548pk2.</a:t>
+            </a:r>
+          </a:p>
+        </p:txBody>
+      </p:sp>
+      <p:sp>
+        <p:nvSpPr>
+          <p:cNvPr id="9" name="TextBox 8"/>
           <p:cNvSpPr txBox="1"/>
           <p:nvPr/>
         </p:nvSpPr>
         <p:spPr>
           <a:xfrm>
-            <a:off x="548640" y="5029200"/>
-            <a:ext cx="11155680" cy="914400"/>
+            <a:off x="548640" y="5303520"/>
+            <a:ext cx="11155680" cy="640080"/>
           </a:xfrm>
           <a:prstGeom prst="rect">
             <a:avLst/>
@@ -5251,13 +5041,13 @@
               </a:spcAft>
             </a:pPr>
             <a:r>
-              <a:rPr sz="1700" b="1">
-                <a:solidFill>
-                  <a:srgbClr val="E8EAF2"/>
-                </a:solidFill>
-                <a:latin typeface="Helvetica Neue"/>
-              </a:rPr>
-              <a:t>Hermes · OpenClaw · Claude Code · any local agent reuse the SAME structured context across tasks — instead of rediscovering everything from scratch every time.</a:t>
+              <a:rPr sz="1600" b="1">
+                <a:solidFill>
+                  <a:srgbClr val="2DD4A7"/>
+                </a:solidFill>
+                <a:latin typeface="Helvetica Neue"/>
+              </a:rPr>
+              <a:t>Local = source of truth (now)   ·   EverMind = memory (over time)   ·   Butterbase = state (durable)</a:t>
             </a:r>
           </a:p>
         </p:txBody>
@@ -5404,7 +5194,7 @@
                   <a:srgbClr val="9AA0B6"/>
                 </a:solidFill>
               </a:rPr>
-              <a:t>        4/7</a:t>
+              <a:t>        4/8</a:t>
             </a:r>
           </a:p>
         </p:txBody>
@@ -5443,7 +5233,7 @@
                 </a:solidFill>
                 <a:latin typeface="Helvetica Neue"/>
               </a:rPr>
-              <a:t>THE FIX</a:t>
+              <a:t>MODULAR — NOT JUST CODE</a:t>
             </a:r>
           </a:p>
         </p:txBody>
@@ -5457,7 +5247,7 @@
         <p:spPr>
           <a:xfrm>
             <a:off x="548640" y="914400"/>
-            <a:ext cx="10972800" cy="822960"/>
+            <a:ext cx="11155680" cy="731520"/>
           </a:xfrm>
           <a:prstGeom prst="rect">
             <a:avLst/>
@@ -5476,13 +5266,13 @@
               </a:spcAft>
             </a:pPr>
             <a:r>
-              <a:rPr sz="2800" b="1">
+              <a:rPr sz="3000" b="1">
                 <a:solidFill>
                   <a:srgbClr val="E8EAF2"/>
                 </a:solidFill>
                 <a:latin typeface="Helvetica Neue"/>
               </a:rPr>
-              <a:t>A $0 local map Claude reads instead of the whole repo</a:t>
+              <a:t>Index anything on your computer</a:t>
             </a:r>
           </a:p>
         </p:txBody>
@@ -5495,8 +5285,8 @@
         </p:nvSpPr>
         <p:spPr>
           <a:xfrm>
-            <a:off x="548640" y="1874519"/>
-            <a:ext cx="11064240" cy="2926080"/>
+            <a:off x="548640" y="1572768"/>
+            <a:ext cx="11155680" cy="548640"/>
           </a:xfrm>
           <a:prstGeom prst="rect">
             <a:avLst/>
@@ -5511,97 +5301,410 @@
           <a:p>
             <a:pPr algn="l">
               <a:spcAft>
-                <a:spcPts val="1400"/>
-              </a:spcAft>
-            </a:pPr>
-            <a:r>
-              <a:rPr sz="1900" b="1">
+                <a:spcPts val="600"/>
+              </a:spcAft>
+            </a:pPr>
+            <a:r>
+              <a:rPr sz="1500" b="0">
+                <a:solidFill>
+                  <a:srgbClr val="9AA0B6"/>
+                </a:solidFill>
+                <a:latin typeface="Helvetica Neue"/>
+              </a:rPr>
+              <a:t>One CLI turns any folder into reusable structured context (SKILL.md + index) — agents load it instead of re-reading from scratch.</a:t>
+            </a:r>
+          </a:p>
+        </p:txBody>
+      </p:sp>
+      <p:sp>
+        <p:nvSpPr>
+          <p:cNvPr id="8" name="Rounded Rectangle 7"/>
+          <p:cNvSpPr/>
+          <p:nvPr/>
+        </p:nvSpPr>
+        <p:spPr>
+          <a:xfrm>
+            <a:off x="548640" y="2286000"/>
+            <a:ext cx="3447288" cy="960120"/>
+          </a:xfrm>
+          <a:prstGeom prst="roundRect">
+            <a:avLst/>
+          </a:prstGeom>
+          <a:solidFill>
+            <a:srgbClr val="10131E"/>
+          </a:solidFill>
+          <a:ln w="15875">
+            <a:solidFill>
+              <a:srgbClr val="2DD4A7"/>
+            </a:solidFill>
+          </a:ln>
+          <a:effectLst/>
+        </p:spPr>
+        <p:style>
+          <a:lnRef idx="1">
+            <a:schemeClr val="accent1"/>
+          </a:lnRef>
+          <a:fillRef idx="3">
+            <a:schemeClr val="accent1"/>
+          </a:fillRef>
+          <a:effectRef idx="2">
+            <a:schemeClr val="accent1"/>
+          </a:effectRef>
+          <a:fontRef idx="minor">
+            <a:schemeClr val="lt1"/>
+          </a:fontRef>
+        </p:style>
+        <p:txBody>
+          <a:bodyPr rtlCol="0" anchor="ctr" wrap="square"/>
+          <a:lstStyle/>
+          <a:p>
+            <a:pPr algn="ctr">
+              <a:spcAft>
+                <a:spcPts val="600"/>
+              </a:spcAft>
+            </a:pPr>
+            <a:r>
+              <a:rPr sz="1600" b="1">
                 <a:solidFill>
                   <a:srgbClr val="2DD4A7"/>
                 </a:solidFill>
                 <a:latin typeface="Helvetica Neue"/>
               </a:rPr>
-              <a:t>SKILL.md + DAG  —  </a:t>
-            </a:r>
-            <a:r>
-              <a:rPr sz="1700">
+              <a:t>Codebases</a:t>
+            </a:r>
+          </a:p>
+        </p:txBody>
+      </p:sp>
+      <p:sp>
+        <p:nvSpPr>
+          <p:cNvPr id="9" name="Rounded Rectangle 8"/>
+          <p:cNvSpPr/>
+          <p:nvPr/>
+        </p:nvSpPr>
+        <p:spPr>
+          <a:xfrm>
+            <a:off x="4361688" y="2286000"/>
+            <a:ext cx="3447288" cy="960120"/>
+          </a:xfrm>
+          <a:prstGeom prst="roundRect">
+            <a:avLst/>
+          </a:prstGeom>
+          <a:solidFill>
+            <a:srgbClr val="10131E"/>
+          </a:solidFill>
+          <a:ln w="15875">
+            <a:solidFill>
+              <a:srgbClr val="4AA8FF"/>
+            </a:solidFill>
+          </a:ln>
+          <a:effectLst/>
+        </p:spPr>
+        <p:style>
+          <a:lnRef idx="1">
+            <a:schemeClr val="accent1"/>
+          </a:lnRef>
+          <a:fillRef idx="3">
+            <a:schemeClr val="accent1"/>
+          </a:fillRef>
+          <a:effectRef idx="2">
+            <a:schemeClr val="accent1"/>
+          </a:effectRef>
+          <a:fontRef idx="minor">
+            <a:schemeClr val="lt1"/>
+          </a:fontRef>
+        </p:style>
+        <p:txBody>
+          <a:bodyPr rtlCol="0" anchor="ctr" wrap="square"/>
+          <a:lstStyle/>
+          <a:p>
+            <a:pPr algn="ctr">
+              <a:spcAft>
+                <a:spcPts val="600"/>
+              </a:spcAft>
+            </a:pPr>
+            <a:r>
+              <a:rPr sz="1600" b="1">
+                <a:solidFill>
+                  <a:srgbClr val="4AA8FF"/>
+                </a:solidFill>
+                <a:latin typeface="Helvetica Neue"/>
+              </a:rPr>
+              <a:t>Docs &amp; notes</a:t>
+            </a:r>
+          </a:p>
+        </p:txBody>
+      </p:sp>
+      <p:sp>
+        <p:nvSpPr>
+          <p:cNvPr id="10" name="Rounded Rectangle 9"/>
+          <p:cNvSpPr/>
+          <p:nvPr/>
+        </p:nvSpPr>
+        <p:spPr>
+          <a:xfrm>
+            <a:off x="8174736" y="2286000"/>
+            <a:ext cx="3447288" cy="960120"/>
+          </a:xfrm>
+          <a:prstGeom prst="roundRect">
+            <a:avLst/>
+          </a:prstGeom>
+          <a:solidFill>
+            <a:srgbClr val="10131E"/>
+          </a:solidFill>
+          <a:ln w="15875">
+            <a:solidFill>
+              <a:srgbClr val="A78BFA"/>
+            </a:solidFill>
+          </a:ln>
+          <a:effectLst/>
+        </p:spPr>
+        <p:style>
+          <a:lnRef idx="1">
+            <a:schemeClr val="accent1"/>
+          </a:lnRef>
+          <a:fillRef idx="3">
+            <a:schemeClr val="accent1"/>
+          </a:fillRef>
+          <a:effectRef idx="2">
+            <a:schemeClr val="accent1"/>
+          </a:effectRef>
+          <a:fontRef idx="minor">
+            <a:schemeClr val="lt1"/>
+          </a:fontRef>
+        </p:style>
+        <p:txBody>
+          <a:bodyPr rtlCol="0" anchor="ctr" wrap="square"/>
+          <a:lstStyle/>
+          <a:p>
+            <a:pPr algn="ctr">
+              <a:spcAft>
+                <a:spcPts val="600"/>
+              </a:spcAft>
+            </a:pPr>
+            <a:r>
+              <a:rPr sz="1600" b="1">
+                <a:solidFill>
+                  <a:srgbClr val="A78BFA"/>
+                </a:solidFill>
+                <a:latin typeface="Helvetica Neue"/>
+              </a:rPr>
+              <a:t>Sales materials</a:t>
+            </a:r>
+          </a:p>
+        </p:txBody>
+      </p:sp>
+      <p:sp>
+        <p:nvSpPr>
+          <p:cNvPr id="11" name="Rounded Rectangle 10"/>
+          <p:cNvSpPr/>
+          <p:nvPr/>
+        </p:nvSpPr>
+        <p:spPr>
+          <a:xfrm>
+            <a:off x="548640" y="3520440"/>
+            <a:ext cx="3447288" cy="960120"/>
+          </a:xfrm>
+          <a:prstGeom prst="roundRect">
+            <a:avLst/>
+          </a:prstGeom>
+          <a:solidFill>
+            <a:srgbClr val="10131E"/>
+          </a:solidFill>
+          <a:ln w="15875">
+            <a:solidFill>
+              <a:srgbClr val="FF7849"/>
+            </a:solidFill>
+          </a:ln>
+          <a:effectLst/>
+        </p:spPr>
+        <p:style>
+          <a:lnRef idx="1">
+            <a:schemeClr val="accent1"/>
+          </a:lnRef>
+          <a:fillRef idx="3">
+            <a:schemeClr val="accent1"/>
+          </a:fillRef>
+          <a:effectRef idx="2">
+            <a:schemeClr val="accent1"/>
+          </a:effectRef>
+          <a:fontRef idx="minor">
+            <a:schemeClr val="lt1"/>
+          </a:fontRef>
+        </p:style>
+        <p:txBody>
+          <a:bodyPr rtlCol="0" anchor="ctr" wrap="square"/>
+          <a:lstStyle/>
+          <a:p>
+            <a:pPr algn="ctr">
+              <a:spcAft>
+                <a:spcPts val="600"/>
+              </a:spcAft>
+            </a:pPr>
+            <a:r>
+              <a:rPr sz="1600" b="1">
+                <a:solidFill>
+                  <a:srgbClr val="FF7849"/>
+                </a:solidFill>
+                <a:latin typeface="Helvetica Neue"/>
+              </a:rPr>
+              <a:t>Marketing assets</a:t>
+            </a:r>
+          </a:p>
+        </p:txBody>
+      </p:sp>
+      <p:sp>
+        <p:nvSpPr>
+          <p:cNvPr id="12" name="Rounded Rectangle 11"/>
+          <p:cNvSpPr/>
+          <p:nvPr/>
+        </p:nvSpPr>
+        <p:spPr>
+          <a:xfrm>
+            <a:off x="4361688" y="3520440"/>
+            <a:ext cx="3447288" cy="960120"/>
+          </a:xfrm>
+          <a:prstGeom prst="roundRect">
+            <a:avLst/>
+          </a:prstGeom>
+          <a:solidFill>
+            <a:srgbClr val="10131E"/>
+          </a:solidFill>
+          <a:ln w="15875">
+            <a:solidFill>
+              <a:srgbClr val="2DD4A7"/>
+            </a:solidFill>
+          </a:ln>
+          <a:effectLst/>
+        </p:spPr>
+        <p:style>
+          <a:lnRef idx="1">
+            <a:schemeClr val="accent1"/>
+          </a:lnRef>
+          <a:fillRef idx="3">
+            <a:schemeClr val="accent1"/>
+          </a:fillRef>
+          <a:effectRef idx="2">
+            <a:schemeClr val="accent1"/>
+          </a:effectRef>
+          <a:fontRef idx="minor">
+            <a:schemeClr val="lt1"/>
+          </a:fontRef>
+        </p:style>
+        <p:txBody>
+          <a:bodyPr rtlCol="0" anchor="ctr" wrap="square"/>
+          <a:lstStyle/>
+          <a:p>
+            <a:pPr algn="ctr">
+              <a:spcAft>
+                <a:spcPts val="600"/>
+              </a:spcAft>
+            </a:pPr>
+            <a:r>
+              <a:rPr sz="1600" b="1">
+                <a:solidFill>
+                  <a:srgbClr val="2DD4A7"/>
+                </a:solidFill>
+                <a:latin typeface="Helvetica Neue"/>
+              </a:rPr>
+              <a:t>Customer research</a:t>
+            </a:r>
+          </a:p>
+        </p:txBody>
+      </p:sp>
+      <p:sp>
+        <p:nvSpPr>
+          <p:cNvPr id="13" name="Rounded Rectangle 12"/>
+          <p:cNvSpPr/>
+          <p:nvPr/>
+        </p:nvSpPr>
+        <p:spPr>
+          <a:xfrm>
+            <a:off x="8174736" y="3520440"/>
+            <a:ext cx="3447288" cy="960120"/>
+          </a:xfrm>
+          <a:prstGeom prst="roundRect">
+            <a:avLst/>
+          </a:prstGeom>
+          <a:solidFill>
+            <a:srgbClr val="10131E"/>
+          </a:solidFill>
+          <a:ln w="15875">
+            <a:solidFill>
+              <a:srgbClr val="4AA8FF"/>
+            </a:solidFill>
+          </a:ln>
+          <a:effectLst/>
+        </p:spPr>
+        <p:style>
+          <a:lnRef idx="1">
+            <a:schemeClr val="accent1"/>
+          </a:lnRef>
+          <a:fillRef idx="3">
+            <a:schemeClr val="accent1"/>
+          </a:fillRef>
+          <a:effectRef idx="2">
+            <a:schemeClr val="accent1"/>
+          </a:effectRef>
+          <a:fontRef idx="minor">
+            <a:schemeClr val="lt1"/>
+          </a:fontRef>
+        </p:style>
+        <p:txBody>
+          <a:bodyPr rtlCol="0" anchor="ctr" wrap="square"/>
+          <a:lstStyle/>
+          <a:p>
+            <a:pPr algn="ctr">
+              <a:spcAft>
+                <a:spcPts val="600"/>
+              </a:spcAft>
+            </a:pPr>
+            <a:r>
+              <a:rPr sz="1600" b="1">
+                <a:solidFill>
+                  <a:srgbClr val="4AA8FF"/>
+                </a:solidFill>
+                <a:latin typeface="Helvetica Neue"/>
+              </a:rPr>
+              <a:t>Project folders &amp; workflows</a:t>
+            </a:r>
+          </a:p>
+        </p:txBody>
+      </p:sp>
+      <p:sp>
+        <p:nvSpPr>
+          <p:cNvPr id="14" name="TextBox 13"/>
+          <p:cNvSpPr txBox="1"/>
+          <p:nvPr/>
+        </p:nvSpPr>
+        <p:spPr>
+          <a:xfrm>
+            <a:off x="548640" y="5029200"/>
+            <a:ext cx="11155680" cy="914400"/>
+          </a:xfrm>
+          <a:prstGeom prst="rect">
+            <a:avLst/>
+          </a:prstGeom>
+          <a:noFill/>
+        </p:spPr>
+        <p:txBody>
+          <a:bodyPr wrap="none">
+            <a:spAutoFit/>
+          </a:bodyPr>
+          <a:lstStyle/>
+          <a:p>
+            <a:pPr algn="l">
+              <a:spcAft>
+                <a:spcPts val="600"/>
+              </a:spcAft>
+            </a:pPr>
+            <a:r>
+              <a:rPr sz="1700" b="1">
                 <a:solidFill>
                   <a:srgbClr val="E8EAF2"/>
                 </a:solidFill>
-              </a:rPr>
-              <a:t>commit-versioned: every file, every function, the call graph — refreshed on each change</a:t>
-            </a:r>
-          </a:p>
-          <a:p>
-            <a:pPr algn="l">
-              <a:spcAft>
-                <a:spcPts val="1400"/>
-              </a:spcAft>
-            </a:pPr>
-            <a:r>
-              <a:rPr sz="1900" b="1">
-                <a:solidFill>
-                  <a:srgbClr val="4AA8FF"/>
-                </a:solidFill>
-                <a:latin typeface="Helvetica Neue"/>
-              </a:rPr>
-              <a:t>Selective retrieval  —  </a:t>
-            </a:r>
-            <a:r>
-              <a:rPr sz="1700">
-                <a:solidFill>
-                  <a:srgbClr val="E8EAF2"/>
-                </a:solidFill>
-              </a:rPr>
-              <a:t>send only the relevant slice, compressed (8.8× on a real query)</a:t>
-            </a:r>
-          </a:p>
-          <a:p>
-            <a:pPr algn="l">
-              <a:spcAft>
-                <a:spcPts val="1400"/>
-              </a:spcAft>
-            </a:pPr>
-            <a:r>
-              <a:rPr sz="1900" b="1">
-                <a:solidFill>
-                  <a:srgbClr val="A78BFA"/>
-                </a:solidFill>
-                <a:latin typeface="Helvetica Neue"/>
-              </a:rPr>
-              <a:t>$0 + local  —  </a:t>
-            </a:r>
-            <a:r>
-              <a:rPr sz="1700">
-                <a:solidFill>
-                  <a:srgbClr val="E8EAF2"/>
-                </a:solidFill>
-              </a:rPr>
-              <a:t>the index runs on your machine for nothing; frontier is used only for the hard step</a:t>
-            </a:r>
-          </a:p>
-          <a:p>
-            <a:pPr algn="l">
-              <a:spcAft>
-                <a:spcPts val="1400"/>
-              </a:spcAft>
-            </a:pPr>
-            <a:r>
-              <a:rPr sz="1900" b="1">
-                <a:solidFill>
-                  <a:srgbClr val="FF7849"/>
-                </a:solidFill>
-                <a:latin typeface="Helvetica Neue"/>
-              </a:rPr>
-              <a:t>Sponsors  —  </a:t>
-            </a:r>
-            <a:r>
-              <a:rPr sz="1700">
-                <a:solidFill>
-                  <a:srgbClr val="E8EAF2"/>
-                </a:solidFill>
-              </a:rPr>
-              <a:t>EverMind = long-term memory (prior decisions) · Butterbase = state/backend + judging</a:t>
+                <a:latin typeface="Helvetica Neue"/>
+              </a:rPr>
+              <a:t>Hermes · OpenClaw · Claude Code · any local agent reuse the SAME structured context across tasks — instead of rediscovering everything from scratch every time.</a:t>
             </a:r>
           </a:p>
         </p:txBody>
@@ -5748,7 +5851,7 @@
                   <a:srgbClr val="9AA0B6"/>
                 </a:solidFill>
               </a:rPr>
-              <a:t>        5/7</a:t>
+              <a:t>        5/8</a:t>
             </a:r>
           </a:p>
         </p:txBody>
@@ -5787,7 +5890,7 @@
                 </a:solidFill>
                 <a:latin typeface="Helvetica Neue"/>
               </a:rPr>
-              <a:t>DEMO FLOW  (what I'll show live)</a:t>
+              <a:t>THE FIX</a:t>
             </a:r>
           </a:p>
         </p:txBody>
@@ -5801,7 +5904,7 @@
         <p:spPr>
           <a:xfrm>
             <a:off x="548640" y="914400"/>
-            <a:ext cx="10972800" cy="731520"/>
+            <a:ext cx="10972800" cy="822960"/>
           </a:xfrm>
           <a:prstGeom prst="rect">
             <a:avLst/>
@@ -5820,13 +5923,13 @@
               </a:spcAft>
             </a:pPr>
             <a:r>
-              <a:rPr sz="3000" b="1">
+              <a:rPr sz="2800" b="1">
                 <a:solidFill>
                   <a:srgbClr val="E8EAF2"/>
                 </a:solidFill>
                 <a:latin typeface="Helvetica Neue"/>
               </a:rPr>
-              <a:t>Watch the token meter drop</a:t>
+              <a:t>A $0 local map Claude reads instead of the whole repo</a:t>
             </a:r>
           </a:p>
         </p:txBody>
@@ -5839,8 +5942,8 @@
         </p:nvSpPr>
         <p:spPr>
           <a:xfrm>
-            <a:off x="548640" y="1828800"/>
-            <a:ext cx="11064240" cy="3291840"/>
+            <a:off x="548640" y="1874519"/>
+            <a:ext cx="11064240" cy="2926080"/>
           </a:xfrm>
           <a:prstGeom prst="rect">
             <a:avLst/>
@@ -5855,97 +5958,97 @@
           <a:p>
             <a:pPr algn="l">
               <a:spcAft>
-                <a:spcPts val="1600"/>
-              </a:spcAft>
-            </a:pPr>
-            <a:r>
-              <a:rPr sz="2000" b="1">
+                <a:spcPts val="1400"/>
+              </a:spcAft>
+            </a:pPr>
+            <a:r>
+              <a:rPr sz="1900" b="1">
+                <a:solidFill>
+                  <a:srgbClr val="2DD4A7"/>
+                </a:solidFill>
+                <a:latin typeface="Helvetica Neue"/>
+              </a:rPr>
+              <a:t>SKILL.md + DAG  —  </a:t>
+            </a:r>
+            <a:r>
+              <a:rPr sz="1700">
+                <a:solidFill>
+                  <a:srgbClr val="E8EAF2"/>
+                </a:solidFill>
+              </a:rPr>
+              <a:t>commit-versioned: every file, every function, the call graph — refreshed on each change</a:t>
+            </a:r>
+          </a:p>
+          <a:p>
+            <a:pPr algn="l">
+              <a:spcAft>
+                <a:spcPts val="1400"/>
+              </a:spcAft>
+            </a:pPr>
+            <a:r>
+              <a:rPr sz="1900" b="1">
+                <a:solidFill>
+                  <a:srgbClr val="4AA8FF"/>
+                </a:solidFill>
+                <a:latin typeface="Helvetica Neue"/>
+              </a:rPr>
+              <a:t>Selective retrieval  —  </a:t>
+            </a:r>
+            <a:r>
+              <a:rPr sz="1700">
+                <a:solidFill>
+                  <a:srgbClr val="E8EAF2"/>
+                </a:solidFill>
+              </a:rPr>
+              <a:t>send only the relevant slice, compressed (8.8× on a real query)</a:t>
+            </a:r>
+          </a:p>
+          <a:p>
+            <a:pPr algn="l">
+              <a:spcAft>
+                <a:spcPts val="1400"/>
+              </a:spcAft>
+            </a:pPr>
+            <a:r>
+              <a:rPr sz="1900" b="1">
+                <a:solidFill>
+                  <a:srgbClr val="A78BFA"/>
+                </a:solidFill>
+                <a:latin typeface="Helvetica Neue"/>
+              </a:rPr>
+              <a:t>$0 + local  —  </a:t>
+            </a:r>
+            <a:r>
+              <a:rPr sz="1700">
+                <a:solidFill>
+                  <a:srgbClr val="E8EAF2"/>
+                </a:solidFill>
+              </a:rPr>
+              <a:t>the index runs on your machine for nothing; frontier is used only for the hard step</a:t>
+            </a:r>
+          </a:p>
+          <a:p>
+            <a:pPr algn="l">
+              <a:spcAft>
+                <a:spcPts val="1400"/>
+              </a:spcAft>
+            </a:pPr>
+            <a:r>
+              <a:rPr sz="1900" b="1">
                 <a:solidFill>
                   <a:srgbClr val="FF7849"/>
                 </a:solidFill>
                 <a:latin typeface="Helvetica Neue"/>
               </a:rPr>
-              <a:t>1.  </a:t>
-            </a:r>
-            <a:r>
-              <a:rPr sz="1800">
+              <a:t>Sponsors  —  </a:t>
+            </a:r>
+            <a:r>
+              <a:rPr sz="1700">
                 <a:solidFill>
                   <a:srgbClr val="E8EAF2"/>
                 </a:solidFill>
               </a:rPr>
-              <a:t>Ask a codebase question the normal way → Claude Code explores files (big token count).</a:t>
-            </a:r>
-          </a:p>
-          <a:p>
-            <a:pPr algn="l">
-              <a:spcAft>
-                <a:spcPts val="1600"/>
-              </a:spcAft>
-            </a:pPr>
-            <a:r>
-              <a:rPr sz="2000" b="1">
-                <a:solidFill>
-                  <a:srgbClr val="2DD4A7"/>
-                </a:solidFill>
-                <a:latin typeface="Helvetica Neue"/>
-              </a:rPr>
-              <a:t>2.  </a:t>
-            </a:r>
-            <a:r>
-              <a:rPr sz="1800">
-                <a:solidFill>
-                  <a:srgbClr val="E8EAF2"/>
-                </a:solidFill>
-              </a:rPr>
-              <a:t>Run  `autopilot index`  → open .autopilot/SKILL.md + ARCHITECTURE.md (the DAG).</a:t>
-            </a:r>
-          </a:p>
-          <a:p>
-            <a:pPr algn="l">
-              <a:spcAft>
-                <a:spcPts val="1600"/>
-              </a:spcAft>
-            </a:pPr>
-            <a:r>
-              <a:rPr sz="2000" b="1">
-                <a:solidFill>
-                  <a:srgbClr val="4AA8FF"/>
-                </a:solidFill>
-                <a:latin typeface="Helvetica Neue"/>
-              </a:rPr>
-              <a:t>3.  </a:t>
-            </a:r>
-            <a:r>
-              <a:rPr sz="1800">
-                <a:solidFill>
-                  <a:srgbClr val="E8EAF2"/>
-                </a:solidFill>
-              </a:rPr>
-              <a:t>Ask again with that saved context → answer from the right slice (tiny token count).</a:t>
-            </a:r>
-          </a:p>
-          <a:p>
-            <a:pPr algn="l">
-              <a:spcAft>
-                <a:spcPts val="1600"/>
-              </a:spcAft>
-            </a:pPr>
-            <a:r>
-              <a:rPr sz="2000" b="1">
-                <a:solidFill>
-                  <a:srgbClr val="A78BFA"/>
-                </a:solidFill>
-                <a:latin typeface="Helvetica Neue"/>
-              </a:rPr>
-              <a:t>4.  </a:t>
-            </a:r>
-            <a:r>
-              <a:rPr sz="1800">
-                <a:solidFill>
-                  <a:srgbClr val="E8EAF2"/>
-                </a:solidFill>
-              </a:rPr>
-              <a:t>Compare:  `autopilot eval`  → 11,947 → 299 tokens, −98.7%, tests still pass.</a:t>
+              <a:t>EverMind = long-term memory (prior decisions) · Butterbase = state/backend + judging</a:t>
             </a:r>
           </a:p>
         </p:txBody>
@@ -6092,7 +6195,7 @@
                   <a:srgbClr val="9AA0B6"/>
                 </a:solidFill>
               </a:rPr>
-              <a:t>        6/7</a:t>
+              <a:t>        6/8</a:t>
             </a:r>
           </a:p>
         </p:txBody>
@@ -6131,7 +6234,7 @@
                 </a:solidFill>
                 <a:latin typeface="Helvetica Neue"/>
               </a:rPr>
-              <a:t>PROOF  ·  autopilot eval (measured)</a:t>
+              <a:t>DEMO FLOW  (what I'll show live)</a:t>
             </a:r>
           </a:p>
         </p:txBody>
@@ -6164,327 +6267,27 @@
               </a:spcAft>
             </a:pPr>
             <a:r>
-              <a:rPr sz="2800" b="1">
+              <a:rPr sz="3000" b="1">
                 <a:solidFill>
                   <a:srgbClr val="E8EAF2"/>
                 </a:solidFill>
                 <a:latin typeface="Helvetica Neue"/>
               </a:rPr>
-              <a:t>Same task. Same result. 98.7% fewer tokens.</a:t>
-            </a:r>
-          </a:p>
-        </p:txBody>
-      </p:sp>
-      <p:sp>
-        <p:nvSpPr>
-          <p:cNvPr id="7" name="Rounded Rectangle 6"/>
-          <p:cNvSpPr/>
-          <p:nvPr/>
-        </p:nvSpPr>
-        <p:spPr>
-          <a:xfrm>
-            <a:off x="548640" y="1920240"/>
-            <a:ext cx="2697480" cy="1737360"/>
-          </a:xfrm>
-          <a:prstGeom prst="roundRect">
-            <a:avLst/>
-          </a:prstGeom>
-          <a:solidFill>
-            <a:srgbClr val="10131E"/>
-          </a:solidFill>
-          <a:ln w="15875">
-            <a:solidFill>
-              <a:srgbClr val="2DD4A7"/>
-            </a:solidFill>
-          </a:ln>
-          <a:effectLst/>
-        </p:spPr>
-        <p:style>
-          <a:lnRef idx="1">
-            <a:schemeClr val="accent1"/>
-          </a:lnRef>
-          <a:fillRef idx="3">
-            <a:schemeClr val="accent1"/>
-          </a:fillRef>
-          <a:effectRef idx="2">
-            <a:schemeClr val="accent1"/>
-          </a:effectRef>
-          <a:fontRef idx="minor">
-            <a:schemeClr val="lt1"/>
-          </a:fontRef>
-        </p:style>
-        <p:txBody>
-          <a:bodyPr rtlCol="0" anchor="ctr"/>
-          <a:lstStyle/>
-          <a:p>
-            <a:pPr algn="ctr">
-              <a:spcAft>
-                <a:spcPts val="200"/>
-              </a:spcAft>
-            </a:pPr>
-            <a:r>
-              <a:rPr sz="4000" b="1">
-                <a:solidFill>
-                  <a:srgbClr val="2DD4A7"/>
-                </a:solidFill>
-                <a:latin typeface="Helvetica Neue"/>
-              </a:rPr>
-              <a:t>−98.7%</a:t>
-            </a:r>
-          </a:p>
-          <a:p>
-            <a:pPr algn="ctr">
-              <a:spcAft>
-                <a:spcPts val="600"/>
-              </a:spcAft>
-            </a:pPr>
-            <a:r>
-              <a:rPr sz="1600" b="0">
-                <a:solidFill>
-                  <a:srgbClr val="9AA0B6"/>
-                </a:solidFill>
-                <a:latin typeface="Helvetica Neue"/>
-              </a:rPr>
-              <a:t>tokens</a:t>
-            </a:r>
-          </a:p>
-        </p:txBody>
-      </p:sp>
-      <p:sp>
-        <p:nvSpPr>
-          <p:cNvPr id="8" name="Rounded Rectangle 7"/>
-          <p:cNvSpPr/>
-          <p:nvPr/>
-        </p:nvSpPr>
-        <p:spPr>
-          <a:xfrm>
-            <a:off x="3383280" y="1920240"/>
-            <a:ext cx="2697480" cy="1737360"/>
-          </a:xfrm>
-          <a:prstGeom prst="roundRect">
-            <a:avLst/>
-          </a:prstGeom>
-          <a:solidFill>
-            <a:srgbClr val="10131E"/>
-          </a:solidFill>
-          <a:ln w="15875">
-            <a:solidFill>
-              <a:srgbClr val="4AA8FF"/>
-            </a:solidFill>
-          </a:ln>
-          <a:effectLst/>
-        </p:spPr>
-        <p:style>
-          <a:lnRef idx="1">
-            <a:schemeClr val="accent1"/>
-          </a:lnRef>
-          <a:fillRef idx="3">
-            <a:schemeClr val="accent1"/>
-          </a:fillRef>
-          <a:effectRef idx="2">
-            <a:schemeClr val="accent1"/>
-          </a:effectRef>
-          <a:fontRef idx="minor">
-            <a:schemeClr val="lt1"/>
-          </a:fontRef>
-        </p:style>
-        <p:txBody>
-          <a:bodyPr rtlCol="0" anchor="ctr"/>
-          <a:lstStyle/>
-          <a:p>
-            <a:pPr algn="ctr">
-              <a:spcAft>
-                <a:spcPts val="200"/>
-              </a:spcAft>
-            </a:pPr>
-            <a:r>
-              <a:rPr sz="4000" b="1">
-                <a:solidFill>
-                  <a:srgbClr val="4AA8FF"/>
-                </a:solidFill>
-                <a:latin typeface="Helvetica Neue"/>
-              </a:rPr>
-              <a:t>−98%</a:t>
-            </a:r>
-          </a:p>
-          <a:p>
-            <a:pPr algn="ctr">
-              <a:spcAft>
-                <a:spcPts val="600"/>
-              </a:spcAft>
-            </a:pPr>
-            <a:r>
-              <a:rPr sz="1600" b="0">
-                <a:solidFill>
-                  <a:srgbClr val="9AA0B6"/>
-                </a:solidFill>
-                <a:latin typeface="Helvetica Neue"/>
-              </a:rPr>
-              <a:t>time</a:t>
-            </a:r>
-          </a:p>
-        </p:txBody>
-      </p:sp>
-      <p:sp>
-        <p:nvSpPr>
-          <p:cNvPr id="9" name="Rounded Rectangle 8"/>
-          <p:cNvSpPr/>
-          <p:nvPr/>
-        </p:nvSpPr>
-        <p:spPr>
-          <a:xfrm>
-            <a:off x="6217920" y="1920240"/>
-            <a:ext cx="2697480" cy="1737360"/>
-          </a:xfrm>
-          <a:prstGeom prst="roundRect">
-            <a:avLst/>
-          </a:prstGeom>
-          <a:solidFill>
-            <a:srgbClr val="10131E"/>
-          </a:solidFill>
-          <a:ln w="15875">
-            <a:solidFill>
-              <a:srgbClr val="A78BFA"/>
-            </a:solidFill>
-          </a:ln>
-          <a:effectLst/>
-        </p:spPr>
-        <p:style>
-          <a:lnRef idx="1">
-            <a:schemeClr val="accent1"/>
-          </a:lnRef>
-          <a:fillRef idx="3">
-            <a:schemeClr val="accent1"/>
-          </a:fillRef>
-          <a:effectRef idx="2">
-            <a:schemeClr val="accent1"/>
-          </a:effectRef>
-          <a:fontRef idx="minor">
-            <a:schemeClr val="lt1"/>
-          </a:fontRef>
-        </p:style>
-        <p:txBody>
-          <a:bodyPr rtlCol="0" anchor="ctr"/>
-          <a:lstStyle/>
-          <a:p>
-            <a:pPr algn="ctr">
-              <a:spcAft>
-                <a:spcPts val="200"/>
-              </a:spcAft>
-            </a:pPr>
-            <a:r>
-              <a:rPr sz="4000" b="1">
-                <a:solidFill>
-                  <a:srgbClr val="A78BFA"/>
-                </a:solidFill>
-                <a:latin typeface="Helvetica Neue"/>
-              </a:rPr>
-              <a:t>−94%</a:t>
-            </a:r>
-          </a:p>
-          <a:p>
-            <a:pPr algn="ctr">
-              <a:spcAft>
-                <a:spcPts val="600"/>
-              </a:spcAft>
-            </a:pPr>
-            <a:r>
-              <a:rPr sz="1600" b="0">
-                <a:solidFill>
-                  <a:srgbClr val="9AA0B6"/>
-                </a:solidFill>
-                <a:latin typeface="Helvetica Neue"/>
-              </a:rPr>
-              <a:t>cost</a:t>
-            </a:r>
-          </a:p>
-        </p:txBody>
-      </p:sp>
-      <p:sp>
-        <p:nvSpPr>
-          <p:cNvPr id="10" name="Rounded Rectangle 9"/>
-          <p:cNvSpPr/>
-          <p:nvPr/>
-        </p:nvSpPr>
-        <p:spPr>
-          <a:xfrm>
-            <a:off x="9052560" y="1920240"/>
-            <a:ext cx="2697480" cy="1737360"/>
-          </a:xfrm>
-          <a:prstGeom prst="roundRect">
-            <a:avLst/>
-          </a:prstGeom>
-          <a:solidFill>
-            <a:srgbClr val="10131E"/>
-          </a:solidFill>
-          <a:ln w="15875">
-            <a:solidFill>
-              <a:srgbClr val="FF7849"/>
-            </a:solidFill>
-          </a:ln>
-          <a:effectLst/>
-        </p:spPr>
-        <p:style>
-          <a:lnRef idx="1">
-            <a:schemeClr val="accent1"/>
-          </a:lnRef>
-          <a:fillRef idx="3">
-            <a:schemeClr val="accent1"/>
-          </a:fillRef>
-          <a:effectRef idx="2">
-            <a:schemeClr val="accent1"/>
-          </a:effectRef>
-          <a:fontRef idx="minor">
-            <a:schemeClr val="lt1"/>
-          </a:fontRef>
-        </p:style>
-        <p:txBody>
-          <a:bodyPr rtlCol="0" anchor="ctr"/>
-          <a:lstStyle/>
-          <a:p>
-            <a:pPr algn="ctr">
-              <a:spcAft>
-                <a:spcPts val="200"/>
-              </a:spcAft>
-            </a:pPr>
-            <a:r>
-              <a:rPr sz="4000" b="1">
-                <a:solidFill>
-                  <a:srgbClr val="FF7849"/>
-                </a:solidFill>
-                <a:latin typeface="Helvetica Neue"/>
-              </a:rPr>
-              <a:t>+0.32</a:t>
-            </a:r>
-          </a:p>
-          <a:p>
-            <a:pPr algn="ctr">
-              <a:spcAft>
-                <a:spcPts val="600"/>
-              </a:spcAft>
-            </a:pPr>
-            <a:r>
-              <a:rPr sz="1600" b="0">
-                <a:solidFill>
-                  <a:srgbClr val="9AA0B6"/>
-                </a:solidFill>
-                <a:latin typeface="Helvetica Neue"/>
-              </a:rPr>
-              <a:t>retrieval F1</a:t>
-            </a:r>
-          </a:p>
-        </p:txBody>
-      </p:sp>
-      <p:sp>
-        <p:nvSpPr>
-          <p:cNvPr id="11" name="TextBox 10"/>
+              <a:t>Watch the token meter drop</a:t>
+            </a:r>
+          </a:p>
+        </p:txBody>
+      </p:sp>
+      <p:sp>
+        <p:nvSpPr>
+          <p:cNvPr id="7" name="TextBox 6"/>
           <p:cNvSpPr txBox="1"/>
           <p:nvPr/>
         </p:nvSpPr>
         <p:spPr>
           <a:xfrm>
-            <a:off x="548640" y="4023360"/>
-            <a:ext cx="11064240" cy="2011680"/>
+            <a:off x="548640" y="1828800"/>
+            <a:ext cx="11064240" cy="3291840"/>
           </a:xfrm>
           <a:prstGeom prst="rect">
             <a:avLst/>
@@ -6499,49 +6302,97 @@
           <a:p>
             <a:pPr algn="l">
               <a:spcAft>
-                <a:spcPts val="1200"/>
-              </a:spcAft>
-            </a:pPr>
-            <a:r>
-              <a:rPr sz="1800" b="1">
+                <a:spcPts val="1600"/>
+              </a:spcAft>
+            </a:pPr>
+            <a:r>
+              <a:rPr sz="2000" b="1">
+                <a:solidFill>
+                  <a:srgbClr val="FF7849"/>
+                </a:solidFill>
+                <a:latin typeface="Helvetica Neue"/>
+              </a:rPr>
+              <a:t>1.  </a:t>
+            </a:r>
+            <a:r>
+              <a:rPr sz="1800">
                 <a:solidFill>
                   <a:srgbClr val="E8EAF2"/>
                 </a:solidFill>
-                <a:latin typeface="Helvetica Neue"/>
-              </a:rPr>
-              <a:t>11,947 → 299 tokens · 1 frontier call avoided · task success preserved (tests pass)</a:t>
+              </a:rPr>
+              <a:t>Ask a codebase question the normal way → Claude Code explores files (big token count).</a:t>
             </a:r>
           </a:p>
           <a:p>
             <a:pPr algn="l">
               <a:spcAft>
-                <a:spcPts val="1200"/>
-              </a:spcAft>
-            </a:pPr>
-            <a:r>
-              <a:rPr sz="1600" b="0">
-                <a:solidFill>
-                  <a:srgbClr val="9AA0B6"/>
-                </a:solidFill>
-                <a:latin typeface="Helvetica Neue"/>
-              </a:rPr>
-              <a:t>Live now: Butterbase app app_b197i2548pk2 (real rows) · EverMind memory written · 27/27 tests.</a:t>
+                <a:spcPts val="1600"/>
+              </a:spcAft>
+            </a:pPr>
+            <a:r>
+              <a:rPr sz="2000" b="1">
+                <a:solidFill>
+                  <a:srgbClr val="2DD4A7"/>
+                </a:solidFill>
+                <a:latin typeface="Helvetica Neue"/>
+              </a:rPr>
+              <a:t>2.  </a:t>
+            </a:r>
+            <a:r>
+              <a:rPr sz="1800">
+                <a:solidFill>
+                  <a:srgbClr val="E8EAF2"/>
+                </a:solidFill>
+              </a:rPr>
+              <a:t>Run  `autopilot index`  → open .autopilot/SKILL.md + ARCHITECTURE.md (the DAG).</a:t>
             </a:r>
           </a:p>
           <a:p>
             <a:pPr algn="l">
               <a:spcAft>
-                <a:spcPts val="600"/>
-              </a:spcAft>
-            </a:pPr>
-            <a:r>
-              <a:rPr sz="1600" b="1">
-                <a:solidFill>
-                  <a:srgbClr val="2DD4A7"/>
-                </a:solidFill>
-                <a:latin typeface="Helvetica Neue"/>
-              </a:rPr>
-              <a:t>Reproduce on stage:  autopilot index  ·  autopilot eval  ·  bash demo/run_demo.sh</a:t>
+                <a:spcPts val="1600"/>
+              </a:spcAft>
+            </a:pPr>
+            <a:r>
+              <a:rPr sz="2000" b="1">
+                <a:solidFill>
+                  <a:srgbClr val="4AA8FF"/>
+                </a:solidFill>
+                <a:latin typeface="Helvetica Neue"/>
+              </a:rPr>
+              <a:t>3.  </a:t>
+            </a:r>
+            <a:r>
+              <a:rPr sz="1800">
+                <a:solidFill>
+                  <a:srgbClr val="E8EAF2"/>
+                </a:solidFill>
+              </a:rPr>
+              <a:t>Ask again with that saved context → answer from the right slice (tiny token count).</a:t>
+            </a:r>
+          </a:p>
+          <a:p>
+            <a:pPr algn="l">
+              <a:spcAft>
+                <a:spcPts val="1600"/>
+              </a:spcAft>
+            </a:pPr>
+            <a:r>
+              <a:rPr sz="2000" b="1">
+                <a:solidFill>
+                  <a:srgbClr val="A78BFA"/>
+                </a:solidFill>
+                <a:latin typeface="Helvetica Neue"/>
+              </a:rPr>
+              <a:t>4.  </a:t>
+            </a:r>
+            <a:r>
+              <a:rPr sz="1800">
+                <a:solidFill>
+                  <a:srgbClr val="E8EAF2"/>
+                </a:solidFill>
+              </a:rPr>
+              <a:t>Compare:  `autopilot eval`  → 11,947 → 299 tokens, −98.7%, tests still pass.</a:t>
             </a:r>
           </a:p>
         </p:txBody>
@@ -6688,7 +6539,603 @@
                   <a:srgbClr val="9AA0B6"/>
                 </a:solidFill>
               </a:rPr>
-              <a:t>        7/7</a:t>
+              <a:t>        7/8</a:t>
+            </a:r>
+          </a:p>
+        </p:txBody>
+      </p:sp>
+      <p:sp>
+        <p:nvSpPr>
+          <p:cNvPr id="5" name="TextBox 4"/>
+          <p:cNvSpPr txBox="1"/>
+          <p:nvPr/>
+        </p:nvSpPr>
+        <p:spPr>
+          <a:xfrm>
+            <a:off x="548640" y="502920"/>
+            <a:ext cx="10972800" cy="457200"/>
+          </a:xfrm>
+          <a:prstGeom prst="rect">
+            <a:avLst/>
+          </a:prstGeom>
+          <a:noFill/>
+        </p:spPr>
+        <p:txBody>
+          <a:bodyPr wrap="none">
+            <a:spAutoFit/>
+          </a:bodyPr>
+          <a:lstStyle/>
+          <a:p>
+            <a:pPr algn="l">
+              <a:spcAft>
+                <a:spcPts val="600"/>
+              </a:spcAft>
+            </a:pPr>
+            <a:r>
+              <a:rPr sz="1500" b="1">
+                <a:solidFill>
+                  <a:srgbClr val="2DD4A7"/>
+                </a:solidFill>
+                <a:latin typeface="Helvetica Neue"/>
+              </a:rPr>
+              <a:t>PROOF  ·  autopilot eval (measured)</a:t>
+            </a:r>
+          </a:p>
+        </p:txBody>
+      </p:sp>
+      <p:sp>
+        <p:nvSpPr>
+          <p:cNvPr id="6" name="TextBox 5"/>
+          <p:cNvSpPr txBox="1"/>
+          <p:nvPr/>
+        </p:nvSpPr>
+        <p:spPr>
+          <a:xfrm>
+            <a:off x="548640" y="914400"/>
+            <a:ext cx="10972800" cy="731520"/>
+          </a:xfrm>
+          <a:prstGeom prst="rect">
+            <a:avLst/>
+          </a:prstGeom>
+          <a:noFill/>
+        </p:spPr>
+        <p:txBody>
+          <a:bodyPr wrap="none">
+            <a:spAutoFit/>
+          </a:bodyPr>
+          <a:lstStyle/>
+          <a:p>
+            <a:pPr algn="l">
+              <a:spcAft>
+                <a:spcPts val="600"/>
+              </a:spcAft>
+            </a:pPr>
+            <a:r>
+              <a:rPr sz="2800" b="1">
+                <a:solidFill>
+                  <a:srgbClr val="E8EAF2"/>
+                </a:solidFill>
+                <a:latin typeface="Helvetica Neue"/>
+              </a:rPr>
+              <a:t>Same task. Same result. 98.7% fewer tokens.</a:t>
+            </a:r>
+          </a:p>
+        </p:txBody>
+      </p:sp>
+      <p:sp>
+        <p:nvSpPr>
+          <p:cNvPr id="7" name="Rounded Rectangle 6"/>
+          <p:cNvSpPr/>
+          <p:nvPr/>
+        </p:nvSpPr>
+        <p:spPr>
+          <a:xfrm>
+            <a:off x="548640" y="1920240"/>
+            <a:ext cx="2697480" cy="1737360"/>
+          </a:xfrm>
+          <a:prstGeom prst="roundRect">
+            <a:avLst/>
+          </a:prstGeom>
+          <a:solidFill>
+            <a:srgbClr val="10131E"/>
+          </a:solidFill>
+          <a:ln w="15875">
+            <a:solidFill>
+              <a:srgbClr val="2DD4A7"/>
+            </a:solidFill>
+          </a:ln>
+          <a:effectLst/>
+        </p:spPr>
+        <p:style>
+          <a:lnRef idx="1">
+            <a:schemeClr val="accent1"/>
+          </a:lnRef>
+          <a:fillRef idx="3">
+            <a:schemeClr val="accent1"/>
+          </a:fillRef>
+          <a:effectRef idx="2">
+            <a:schemeClr val="accent1"/>
+          </a:effectRef>
+          <a:fontRef idx="minor">
+            <a:schemeClr val="lt1"/>
+          </a:fontRef>
+        </p:style>
+        <p:txBody>
+          <a:bodyPr rtlCol="0" anchor="ctr"/>
+          <a:lstStyle/>
+          <a:p>
+            <a:pPr algn="ctr">
+              <a:spcAft>
+                <a:spcPts val="200"/>
+              </a:spcAft>
+            </a:pPr>
+            <a:r>
+              <a:rPr sz="4000" b="1">
+                <a:solidFill>
+                  <a:srgbClr val="2DD4A7"/>
+                </a:solidFill>
+                <a:latin typeface="Helvetica Neue"/>
+              </a:rPr>
+              <a:t>−98.7%</a:t>
+            </a:r>
+          </a:p>
+          <a:p>
+            <a:pPr algn="ctr">
+              <a:spcAft>
+                <a:spcPts val="600"/>
+              </a:spcAft>
+            </a:pPr>
+            <a:r>
+              <a:rPr sz="1600" b="0">
+                <a:solidFill>
+                  <a:srgbClr val="9AA0B6"/>
+                </a:solidFill>
+                <a:latin typeface="Helvetica Neue"/>
+              </a:rPr>
+              <a:t>tokens</a:t>
+            </a:r>
+          </a:p>
+        </p:txBody>
+      </p:sp>
+      <p:sp>
+        <p:nvSpPr>
+          <p:cNvPr id="8" name="Rounded Rectangle 7"/>
+          <p:cNvSpPr/>
+          <p:nvPr/>
+        </p:nvSpPr>
+        <p:spPr>
+          <a:xfrm>
+            <a:off x="3383280" y="1920240"/>
+            <a:ext cx="2697480" cy="1737360"/>
+          </a:xfrm>
+          <a:prstGeom prst="roundRect">
+            <a:avLst/>
+          </a:prstGeom>
+          <a:solidFill>
+            <a:srgbClr val="10131E"/>
+          </a:solidFill>
+          <a:ln w="15875">
+            <a:solidFill>
+              <a:srgbClr val="4AA8FF"/>
+            </a:solidFill>
+          </a:ln>
+          <a:effectLst/>
+        </p:spPr>
+        <p:style>
+          <a:lnRef idx="1">
+            <a:schemeClr val="accent1"/>
+          </a:lnRef>
+          <a:fillRef idx="3">
+            <a:schemeClr val="accent1"/>
+          </a:fillRef>
+          <a:effectRef idx="2">
+            <a:schemeClr val="accent1"/>
+          </a:effectRef>
+          <a:fontRef idx="minor">
+            <a:schemeClr val="lt1"/>
+          </a:fontRef>
+        </p:style>
+        <p:txBody>
+          <a:bodyPr rtlCol="0" anchor="ctr"/>
+          <a:lstStyle/>
+          <a:p>
+            <a:pPr algn="ctr">
+              <a:spcAft>
+                <a:spcPts val="200"/>
+              </a:spcAft>
+            </a:pPr>
+            <a:r>
+              <a:rPr sz="4000" b="1">
+                <a:solidFill>
+                  <a:srgbClr val="4AA8FF"/>
+                </a:solidFill>
+                <a:latin typeface="Helvetica Neue"/>
+              </a:rPr>
+              <a:t>−98%</a:t>
+            </a:r>
+          </a:p>
+          <a:p>
+            <a:pPr algn="ctr">
+              <a:spcAft>
+                <a:spcPts val="600"/>
+              </a:spcAft>
+            </a:pPr>
+            <a:r>
+              <a:rPr sz="1600" b="0">
+                <a:solidFill>
+                  <a:srgbClr val="9AA0B6"/>
+                </a:solidFill>
+                <a:latin typeface="Helvetica Neue"/>
+              </a:rPr>
+              <a:t>time</a:t>
+            </a:r>
+          </a:p>
+        </p:txBody>
+      </p:sp>
+      <p:sp>
+        <p:nvSpPr>
+          <p:cNvPr id="9" name="Rounded Rectangle 8"/>
+          <p:cNvSpPr/>
+          <p:nvPr/>
+        </p:nvSpPr>
+        <p:spPr>
+          <a:xfrm>
+            <a:off x="6217920" y="1920240"/>
+            <a:ext cx="2697480" cy="1737360"/>
+          </a:xfrm>
+          <a:prstGeom prst="roundRect">
+            <a:avLst/>
+          </a:prstGeom>
+          <a:solidFill>
+            <a:srgbClr val="10131E"/>
+          </a:solidFill>
+          <a:ln w="15875">
+            <a:solidFill>
+              <a:srgbClr val="A78BFA"/>
+            </a:solidFill>
+          </a:ln>
+          <a:effectLst/>
+        </p:spPr>
+        <p:style>
+          <a:lnRef idx="1">
+            <a:schemeClr val="accent1"/>
+          </a:lnRef>
+          <a:fillRef idx="3">
+            <a:schemeClr val="accent1"/>
+          </a:fillRef>
+          <a:effectRef idx="2">
+            <a:schemeClr val="accent1"/>
+          </a:effectRef>
+          <a:fontRef idx="minor">
+            <a:schemeClr val="lt1"/>
+          </a:fontRef>
+        </p:style>
+        <p:txBody>
+          <a:bodyPr rtlCol="0" anchor="ctr"/>
+          <a:lstStyle/>
+          <a:p>
+            <a:pPr algn="ctr">
+              <a:spcAft>
+                <a:spcPts val="200"/>
+              </a:spcAft>
+            </a:pPr>
+            <a:r>
+              <a:rPr sz="4000" b="1">
+                <a:solidFill>
+                  <a:srgbClr val="A78BFA"/>
+                </a:solidFill>
+                <a:latin typeface="Helvetica Neue"/>
+              </a:rPr>
+              <a:t>−94%</a:t>
+            </a:r>
+          </a:p>
+          <a:p>
+            <a:pPr algn="ctr">
+              <a:spcAft>
+                <a:spcPts val="600"/>
+              </a:spcAft>
+            </a:pPr>
+            <a:r>
+              <a:rPr sz="1600" b="0">
+                <a:solidFill>
+                  <a:srgbClr val="9AA0B6"/>
+                </a:solidFill>
+                <a:latin typeface="Helvetica Neue"/>
+              </a:rPr>
+              <a:t>cost</a:t>
+            </a:r>
+          </a:p>
+        </p:txBody>
+      </p:sp>
+      <p:sp>
+        <p:nvSpPr>
+          <p:cNvPr id="10" name="Rounded Rectangle 9"/>
+          <p:cNvSpPr/>
+          <p:nvPr/>
+        </p:nvSpPr>
+        <p:spPr>
+          <a:xfrm>
+            <a:off x="9052560" y="1920240"/>
+            <a:ext cx="2697480" cy="1737360"/>
+          </a:xfrm>
+          <a:prstGeom prst="roundRect">
+            <a:avLst/>
+          </a:prstGeom>
+          <a:solidFill>
+            <a:srgbClr val="10131E"/>
+          </a:solidFill>
+          <a:ln w="15875">
+            <a:solidFill>
+              <a:srgbClr val="FF7849"/>
+            </a:solidFill>
+          </a:ln>
+          <a:effectLst/>
+        </p:spPr>
+        <p:style>
+          <a:lnRef idx="1">
+            <a:schemeClr val="accent1"/>
+          </a:lnRef>
+          <a:fillRef idx="3">
+            <a:schemeClr val="accent1"/>
+          </a:fillRef>
+          <a:effectRef idx="2">
+            <a:schemeClr val="accent1"/>
+          </a:effectRef>
+          <a:fontRef idx="minor">
+            <a:schemeClr val="lt1"/>
+          </a:fontRef>
+        </p:style>
+        <p:txBody>
+          <a:bodyPr rtlCol="0" anchor="ctr"/>
+          <a:lstStyle/>
+          <a:p>
+            <a:pPr algn="ctr">
+              <a:spcAft>
+                <a:spcPts val="200"/>
+              </a:spcAft>
+            </a:pPr>
+            <a:r>
+              <a:rPr sz="4000" b="1">
+                <a:solidFill>
+                  <a:srgbClr val="FF7849"/>
+                </a:solidFill>
+                <a:latin typeface="Helvetica Neue"/>
+              </a:rPr>
+              <a:t>+0.32</a:t>
+            </a:r>
+          </a:p>
+          <a:p>
+            <a:pPr algn="ctr">
+              <a:spcAft>
+                <a:spcPts val="600"/>
+              </a:spcAft>
+            </a:pPr>
+            <a:r>
+              <a:rPr sz="1600" b="0">
+                <a:solidFill>
+                  <a:srgbClr val="9AA0B6"/>
+                </a:solidFill>
+                <a:latin typeface="Helvetica Neue"/>
+              </a:rPr>
+              <a:t>retrieval F1</a:t>
+            </a:r>
+          </a:p>
+        </p:txBody>
+      </p:sp>
+      <p:sp>
+        <p:nvSpPr>
+          <p:cNvPr id="11" name="TextBox 10"/>
+          <p:cNvSpPr txBox="1"/>
+          <p:nvPr/>
+        </p:nvSpPr>
+        <p:spPr>
+          <a:xfrm>
+            <a:off x="548640" y="4023360"/>
+            <a:ext cx="11064240" cy="2011680"/>
+          </a:xfrm>
+          <a:prstGeom prst="rect">
+            <a:avLst/>
+          </a:prstGeom>
+          <a:noFill/>
+        </p:spPr>
+        <p:txBody>
+          <a:bodyPr wrap="none">
+            <a:spAutoFit/>
+          </a:bodyPr>
+          <a:lstStyle/>
+          <a:p>
+            <a:pPr algn="l">
+              <a:spcAft>
+                <a:spcPts val="1200"/>
+              </a:spcAft>
+            </a:pPr>
+            <a:r>
+              <a:rPr sz="1800" b="1">
+                <a:solidFill>
+                  <a:srgbClr val="E8EAF2"/>
+                </a:solidFill>
+                <a:latin typeface="Helvetica Neue"/>
+              </a:rPr>
+              <a:t>11,947 → 299 tokens · 1 frontier call avoided · task success preserved (tests pass)</a:t>
+            </a:r>
+          </a:p>
+          <a:p>
+            <a:pPr algn="l">
+              <a:spcAft>
+                <a:spcPts val="1200"/>
+              </a:spcAft>
+            </a:pPr>
+            <a:r>
+              <a:rPr sz="1600" b="0">
+                <a:solidFill>
+                  <a:srgbClr val="9AA0B6"/>
+                </a:solidFill>
+                <a:latin typeface="Helvetica Neue"/>
+              </a:rPr>
+              <a:t>Live now: Butterbase app app_b197i2548pk2 (real rows) · EverMind memory written · 27/27 tests.</a:t>
+            </a:r>
+          </a:p>
+          <a:p>
+            <a:pPr algn="l">
+              <a:spcAft>
+                <a:spcPts val="600"/>
+              </a:spcAft>
+            </a:pPr>
+            <a:r>
+              <a:rPr sz="1600" b="1">
+                <a:solidFill>
+                  <a:srgbClr val="2DD4A7"/>
+                </a:solidFill>
+                <a:latin typeface="Helvetica Neue"/>
+              </a:rPr>
+              <a:t>Reproduce on stage:  autopilot index  ·  autopilot eval  ·  bash demo/run_demo.sh</a:t>
+            </a:r>
+          </a:p>
+        </p:txBody>
+      </p:sp>
+    </p:spTree>
+  </p:cSld>
+  <p:clrMapOvr>
+    <a:masterClrMapping/>
+  </p:clrMapOvr>
+</p:sld>
+</file>
+
+<file path=ppt/slides/slide8.xml><?xml version="1.0" encoding="utf-8"?>
+<p:sld xmlns:a="http://schemas.openxmlformats.org/drawingml/2006/main" xmlns:p="http://schemas.openxmlformats.org/presentationml/2006/main" xmlns:r="http://schemas.openxmlformats.org/officeDocument/2006/relationships">
+  <p:cSld>
+    <p:spTree>
+      <p:nvGrpSpPr>
+        <p:cNvPr id="1" name=""/>
+        <p:cNvGrpSpPr/>
+        <p:nvPr/>
+      </p:nvGrpSpPr>
+      <p:grpSpPr/>
+      <p:sp>
+        <p:nvSpPr>
+          <p:cNvPr id="2" name="Rectangle 1"/>
+          <p:cNvSpPr/>
+          <p:nvPr/>
+        </p:nvSpPr>
+        <p:spPr>
+          <a:xfrm>
+            <a:off x="0" y="0"/>
+            <a:ext cx="12191695" cy="6858000"/>
+          </a:xfrm>
+          <a:prstGeom prst="rect">
+            <a:avLst/>
+          </a:prstGeom>
+          <a:solidFill>
+            <a:srgbClr val="0A0C14"/>
+          </a:solidFill>
+          <a:ln>
+            <a:noFill/>
+          </a:ln>
+          <a:effectLst/>
+        </p:spPr>
+        <p:style>
+          <a:lnRef idx="1">
+            <a:schemeClr val="accent1"/>
+          </a:lnRef>
+          <a:fillRef idx="3">
+            <a:schemeClr val="accent1"/>
+          </a:fillRef>
+          <a:effectRef idx="2">
+            <a:schemeClr val="accent1"/>
+          </a:effectRef>
+          <a:fontRef idx="minor">
+            <a:schemeClr val="lt1"/>
+          </a:fontRef>
+        </p:style>
+        <p:txBody>
+          <a:bodyPr rtlCol="0" anchor="ctr"/>
+          <a:lstStyle/>
+          <a:p>
+            <a:pPr algn="ctr"/>
+          </a:p>
+        </p:txBody>
+      </p:sp>
+      <p:sp>
+        <p:nvSpPr>
+          <p:cNvPr id="3" name="Rectangle 2"/>
+          <p:cNvSpPr/>
+          <p:nvPr/>
+        </p:nvSpPr>
+        <p:spPr>
+          <a:xfrm>
+            <a:off x="0" y="0"/>
+            <a:ext cx="128016" cy="6858000"/>
+          </a:xfrm>
+          <a:prstGeom prst="rect">
+            <a:avLst/>
+          </a:prstGeom>
+          <a:solidFill>
+            <a:srgbClr val="2DD4A7"/>
+          </a:solidFill>
+          <a:ln>
+            <a:noFill/>
+          </a:ln>
+          <a:effectLst/>
+        </p:spPr>
+        <p:style>
+          <a:lnRef idx="1">
+            <a:schemeClr val="accent1"/>
+          </a:lnRef>
+          <a:fillRef idx="3">
+            <a:schemeClr val="accent1"/>
+          </a:fillRef>
+          <a:effectRef idx="2">
+            <a:schemeClr val="accent1"/>
+          </a:effectRef>
+          <a:fontRef idx="minor">
+            <a:schemeClr val="lt1"/>
+          </a:fontRef>
+        </p:style>
+        <p:txBody>
+          <a:bodyPr rtlCol="0" anchor="ctr"/>
+          <a:lstStyle/>
+          <a:p>
+            <a:pPr algn="ctr"/>
+          </a:p>
+        </p:txBody>
+      </p:sp>
+      <p:sp>
+        <p:nvSpPr>
+          <p:cNvPr id="4" name="TextBox 3"/>
+          <p:cNvSpPr txBox="1"/>
+          <p:nvPr/>
+        </p:nvSpPr>
+        <p:spPr>
+          <a:xfrm>
+            <a:off x="548640" y="6400800"/>
+            <a:ext cx="11155680" cy="365760"/>
+          </a:xfrm>
+          <a:prstGeom prst="rect">
+            <a:avLst/>
+          </a:prstGeom>
+          <a:noFill/>
+        </p:spPr>
+        <p:txBody>
+          <a:bodyPr wrap="none">
+            <a:spAutoFit/>
+          </a:bodyPr>
+          <a:lstStyle/>
+          <a:p>
+            <a:r>
+              <a:rPr sz="1000">
+                <a:solidFill>
+                  <a:srgbClr val="9AA0B6"/>
+                </a:solidFill>
+              </a:rPr>
+              <a:t>EverMind + Butterbase: LIVE  ·  app_b197i2548pk2  ·  build0530</a:t>
+            </a:r>
+            <a:r>
+              <a:rPr sz="1000">
+                <a:solidFill>
+                  <a:srgbClr val="9AA0B6"/>
+                </a:solidFill>
+              </a:rPr>
+              <a:t>        8/8</a:t>
             </a:r>
           </a:p>
         </p:txBody>

</xml_diff>

<commit_message>
Deck: add real psf/requests benchmark to Proof slide
</commit_message>
<xml_diff>
--- a/demo/autopilot-slides.pptx
+++ b/demo/autopilot-slides.pptx
@@ -6930,8 +6930,8 @@
         </p:nvSpPr>
         <p:spPr>
           <a:xfrm>
-            <a:off x="548640" y="4023360"/>
-            <a:ext cx="11064240" cy="2011680"/>
+            <a:off x="548640" y="3977639"/>
+            <a:ext cx="11064240" cy="2194560"/>
           </a:xfrm>
           <a:prstGeom prst="rect">
             <a:avLst/>
@@ -6946,11 +6946,11 @@
           <a:p>
             <a:pPr algn="l">
               <a:spcAft>
-                <a:spcPts val="1200"/>
-              </a:spcAft>
-            </a:pPr>
-            <a:r>
-              <a:rPr sz="1800" b="1">
+                <a:spcPts val="1000"/>
+              </a:spcAft>
+            </a:pPr>
+            <a:r>
+              <a:rPr sz="1700" b="1">
                 <a:solidFill>
                   <a:srgbClr val="E8EAF2"/>
                 </a:solidFill>
@@ -6962,11 +6962,27 @@
           <a:p>
             <a:pPr algn="l">
               <a:spcAft>
-                <a:spcPts val="1200"/>
-              </a:spcAft>
-            </a:pPr>
-            <a:r>
-              <a:rPr sz="1600" b="0">
+                <a:spcPts val="1000"/>
+              </a:spcAft>
+            </a:pPr>
+            <a:r>
+              <a:rPr sz="1700" b="1">
+                <a:solidFill>
+                  <a:srgbClr val="2DD4A7"/>
+                </a:solidFill>
+                <a:latin typeface="Helvetica Neue"/>
+              </a:rPr>
+              <a:t>Real public repo (psf/requests): whole repo ≈147,794 tokens → ~1,025 for the right answer — 57×, −99.3%.</a:t>
+            </a:r>
+          </a:p>
+          <a:p>
+            <a:pPr algn="l">
+              <a:spcAft>
+                <a:spcPts val="1000"/>
+              </a:spcAft>
+            </a:pPr>
+            <a:r>
+              <a:rPr sz="1500" b="0">
                 <a:solidFill>
                   <a:srgbClr val="9AA0B6"/>
                 </a:solidFill>
@@ -6982,7 +6998,7 @@
               </a:spcAft>
             </a:pPr>
             <a:r>
-              <a:rPr sz="1600" b="1">
+              <a:rPr sz="1500" b="1">
                 <a:solidFill>
                   <a:srgbClr val="2DD4A7"/>
                 </a:solidFill>

</xml_diff>

<commit_message>
Deck: compliant 3-slide hackathon format (Team / Product / Demo+video)
</commit_message>
<xml_diff>
--- a/demo/autopilot-slides.pptx
+++ b/demo/autopilot-slides.pptx
@@ -8,11 +8,6 @@
     <p:sldId id="256" r:id="rId7"/>
     <p:sldId id="257" r:id="rId8"/>
     <p:sldId id="258" r:id="rId9"/>
-    <p:sldId id="259" r:id="rId10"/>
-    <p:sldId id="260" r:id="rId11"/>
-    <p:sldId id="261" r:id="rId12"/>
-    <p:sldId id="262" r:id="rId13"/>
-    <p:sldId id="263" r:id="rId14"/>
   </p:sldIdLst>
   <p:sldSz cx="12191695" cy="6858000" type="screen4x3"/>
   <p:notesSz cx="6858000" cy="9144000"/>
@@ -3191,8 +3186,8 @@
         </p:nvSpPr>
         <p:spPr>
           <a:xfrm>
-            <a:off x="822960" y="502920"/>
-            <a:ext cx="10607040" cy="457200"/>
+            <a:off x="548640" y="6419088"/>
+            <a:ext cx="11247120" cy="365760"/>
           </a:xfrm>
           <a:prstGeom prst="rect">
             <a:avLst/>
@@ -3205,19 +3200,13 @@
           </a:bodyPr>
           <a:lstStyle/>
           <a:p>
-            <a:pPr algn="l">
-              <a:spcAft>
-                <a:spcPts val="600"/>
-              </a:spcAft>
-            </a:pPr>
-            <a:r>
-              <a:rPr sz="1400" b="1">
+            <a:r>
+              <a:rPr sz="1000">
                 <a:solidFill>
-                  <a:srgbClr val="A78BFA"/>
+                  <a:srgbClr val="9AA0B6"/>
                 </a:solidFill>
-                <a:latin typeface="Helvetica Neue"/>
               </a:rPr>
-              <a:t>BETA FUND × EVERMIND  ·  NEXT-GEN INFRASTRUCTURE &amp; CONTEXT</a:t>
+              <a:t>Context Autopilot · Touchdown Labs · Built on EverMind + Butterbase (LIVE) · github.com/OCWC22/context-autopilot</a:t>
             </a:r>
           </a:p>
         </p:txBody>
@@ -3230,8 +3219,8 @@
         </p:nvSpPr>
         <p:spPr>
           <a:xfrm>
-            <a:off x="822960" y="1097280"/>
-            <a:ext cx="10607040" cy="1371600"/>
+            <a:off x="548640" y="457200"/>
+            <a:ext cx="10972800" cy="457200"/>
           </a:xfrm>
           <a:prstGeom prst="rect">
             <a:avLst/>
@@ -3246,33 +3235,17 @@
           <a:p>
             <a:pPr algn="l">
               <a:spcAft>
-                <a:spcPts val="600"/>
+                <a:spcPts val="800"/>
               </a:spcAft>
             </a:pPr>
             <a:r>
-              <a:rPr sz="3800" b="1">
-                <a:solidFill>
-                  <a:srgbClr val="E8EAF2"/>
-                </a:solidFill>
-                <a:latin typeface="Helvetica Neue"/>
-              </a:rPr>
-              <a:t>Context Autopilot</a:t>
-            </a:r>
-          </a:p>
-          <a:p>
-            <a:pPr algn="l">
-              <a:spcAft>
-                <a:spcPts val="600"/>
-              </a:spcAft>
-            </a:pPr>
-            <a:r>
-              <a:rPr sz="1700" b="1">
+              <a:rPr sz="1500" b="1">
                 <a:solidFill>
                   <a:srgbClr val="2DD4A7"/>
                 </a:solidFill>
                 <a:latin typeface="Helvetica Neue"/>
               </a:rPr>
-              <a:t>William Chen · Touchdown Labs — vendor-neutral inference-optimization research</a:t>
+              <a:t>SLIDE 1 — TEAM</a:t>
             </a:r>
           </a:p>
         </p:txBody>
@@ -3285,8 +3258,8 @@
         </p:nvSpPr>
         <p:spPr>
           <a:xfrm>
-            <a:off x="822960" y="2514600"/>
-            <a:ext cx="10607040" cy="822960"/>
+            <a:off x="548640" y="1005840"/>
+            <a:ext cx="11064240" cy="1280160"/>
           </a:xfrm>
           <a:prstGeom prst="rect">
             <a:avLst/>
@@ -3301,92 +3274,104 @@
           <a:p>
             <a:pPr algn="l">
               <a:spcAft>
-                <a:spcPts val="600"/>
+                <a:spcPts val="800"/>
               </a:spcAft>
             </a:pPr>
             <a:r>
-              <a:rPr sz="1600" b="0">
+              <a:rPr sz="4200" b="1">
                 <a:solidFill>
                   <a:srgbClr val="E8EAF2"/>
                 </a:solidFill>
                 <a:latin typeface="Helvetica Neue"/>
               </a:rPr>
-              <a:t>What I'm building: a local-first context engine — index ANY folder (code, docs, notes, projects) into reusable structured memory that Hermes, OpenClaw, or any local agent loads instead of rediscovering it every task.</a:t>
-            </a:r>
-          </a:p>
-        </p:txBody>
-      </p:sp>
-      <p:sp>
-        <p:nvSpPr>
-          <p:cNvPr id="7" name="Rounded Rectangle 6"/>
-          <p:cNvSpPr/>
-          <p:nvPr/>
-        </p:nvSpPr>
-        <p:spPr>
-          <a:xfrm>
-            <a:off x="822960" y="3520440"/>
-            <a:ext cx="5212080" cy="2194560"/>
-          </a:xfrm>
-          <a:prstGeom prst="roundRect">
-            <a:avLst/>
-          </a:prstGeom>
-          <a:solidFill>
-            <a:srgbClr val="10131E"/>
-          </a:solidFill>
-          <a:ln w="15875">
-            <a:solidFill>
-              <a:srgbClr val="FF7849"/>
-            </a:solidFill>
-          </a:ln>
-          <a:effectLst/>
-        </p:spPr>
-        <p:style>
-          <a:lnRef idx="1">
-            <a:schemeClr val="accent1"/>
-          </a:lnRef>
-          <a:fillRef idx="3">
-            <a:schemeClr val="accent1"/>
-          </a:fillRef>
-          <a:effectRef idx="2">
-            <a:schemeClr val="accent1"/>
-          </a:effectRef>
-          <a:fontRef idx="minor">
-            <a:schemeClr val="lt1"/>
-          </a:fontRef>
-        </p:style>
-        <p:txBody>
-          <a:bodyPr rtlCol="0" anchor="t" wrap="square" lIns="256032" tIns="201168" rIns="182880"/>
-          <a:lstStyle/>
+              <a:t>William Chen</a:t>
+            </a:r>
+          </a:p>
           <a:p>
             <a:pPr algn="l">
               <a:spcAft>
-                <a:spcPts val="600"/>
+                <a:spcPts val="800"/>
               </a:spcAft>
             </a:pPr>
             <a:r>
-              <a:rPr sz="1800" b="1">
+              <a:rPr sz="1900" b="1">
                 <a:solidFill>
-                  <a:srgbClr val="FF7849"/>
+                  <a:srgbClr val="2DD4A7"/>
                 </a:solidFill>
                 <a:latin typeface="Helvetica Neue"/>
               </a:rPr>
-              <a:t>The problem</a:t>
-            </a:r>
-          </a:p>
+              <a:t>Founder &amp; CEO, Touchdown Labs — vendor-neutral inference-optimization research</a:t>
+            </a:r>
+          </a:p>
+        </p:txBody>
+      </p:sp>
+      <p:sp>
+        <p:nvSpPr>
+          <p:cNvPr id="7" name="TextBox 6"/>
+          <p:cNvSpPr txBox="1"/>
+          <p:nvPr/>
+        </p:nvSpPr>
+        <p:spPr>
+          <a:xfrm>
+            <a:off x="548640" y="2651760"/>
+            <a:ext cx="11064240" cy="1828800"/>
+          </a:xfrm>
+          <a:prstGeom prst="rect">
+            <a:avLst/>
+          </a:prstGeom>
+          <a:noFill/>
+        </p:spPr>
+        <p:txBody>
+          <a:bodyPr wrap="none">
+            <a:spAutoFit/>
+          </a:bodyPr>
+          <a:lstStyle/>
           <a:p>
             <a:pPr algn="l">
               <a:spcAft>
-                <a:spcPts val="600"/>
+                <a:spcPts val="1000"/>
               </a:spcAft>
             </a:pPr>
             <a:r>
-              <a:rPr sz="1500" b="0">
+              <a:rPr sz="1600" b="1">
+                <a:solidFill>
+                  <a:srgbClr val="A78BFA"/>
+                </a:solidFill>
+                <a:latin typeface="Helvetica Neue"/>
+              </a:rPr>
+              <a:t>Relevant experience</a:t>
+            </a:r>
+          </a:p>
+          <a:p>
+            <a:pPr algn="l">
+              <a:spcAft>
+                <a:spcPts val="1000"/>
+              </a:spcAft>
+            </a:pPr>
+            <a:r>
+              <a:rPr sz="1800" b="0">
                 <a:solidFill>
                   <a:srgbClr val="E8EAF2"/>
                 </a:solidFill>
                 <a:latin typeface="Helvetica Neue"/>
               </a:rPr>
-              <a:t>Local agents (Hermes, OpenClaw, Claude Code) rediscover your project every task — code, docs, notes — burning tokens reloading what they already saw (≈90K to reload a 359 KB project).</a:t>
+              <a:t>•  Built Edge AI and on-device / local AI before — shipping models that run close to the user.</a:t>
+            </a:r>
+          </a:p>
+          <a:p>
+            <a:pPr algn="l">
+              <a:spcAft>
+                <a:spcPts val="1000"/>
+              </a:spcAft>
+            </a:pPr>
+            <a:r>
+              <a:rPr sz="1800" b="0">
+                <a:solidFill>
+                  <a:srgbClr val="E8EAF2"/>
+                </a:solidFill>
+                <a:latin typeface="Helvetica Neue"/>
+              </a:rPr>
+              <a:t>•  Touchdown Labs: research + tooling for cutting AI inference cost without losing quality.</a:t>
             </a:r>
           </a:p>
         </p:txBody>
@@ -3399,8 +3384,8 @@
         </p:nvSpPr>
         <p:spPr>
           <a:xfrm>
-            <a:off x="6400800" y="3520440"/>
-            <a:ext cx="5212080" cy="2194560"/>
+            <a:off x="548640" y="4572000"/>
+            <a:ext cx="11064240" cy="1463040"/>
           </a:xfrm>
           <a:prstGeom prst="roundRect">
             <a:avLst/>
@@ -3430,77 +3415,38 @@
           </a:fontRef>
         </p:style>
         <p:txBody>
-          <a:bodyPr rtlCol="0" anchor="t" wrap="square" lIns="256032" tIns="201168" rIns="182880"/>
+          <a:bodyPr rtlCol="0" anchor="t" wrap="square" lIns="256032" tIns="201168" rIns="201168"/>
           <a:lstStyle/>
           <a:p>
             <a:pPr algn="l">
               <a:spcAft>
-                <a:spcPts val="600"/>
+                <a:spcPts val="800"/>
               </a:spcAft>
             </a:pPr>
             <a:r>
-              <a:rPr sz="1800" b="1">
+              <a:rPr sz="1600" b="1">
                 <a:solidFill>
                   <a:srgbClr val="2DD4A7"/>
                 </a:solidFill>
                 <a:latin typeface="Helvetica Neue"/>
               </a:rPr>
-              <a:t>The solution</a:t>
+              <a:t>Team ⟷ problem fit</a:t>
             </a:r>
           </a:p>
           <a:p>
             <a:pPr algn="l">
               <a:spcAft>
-                <a:spcPts val="600"/>
+                <a:spcPts val="800"/>
               </a:spcAft>
             </a:pPr>
             <a:r>
-              <a:rPr sz="1500" b="0">
+              <a:rPr sz="1600" b="0">
                 <a:solidFill>
                   <a:srgbClr val="E8EAF2"/>
                 </a:solidFill>
                 <a:latin typeface="Helvetica Neue"/>
               </a:rPr>
-              <a:t>Index it once into a reusable SKILL.md + DAG map. Any local agent reuses it across tasks; a small MLX model does the cheap work, frontier only for the hard step — ~99% fewer tokens.</a:t>
-            </a:r>
-          </a:p>
-        </p:txBody>
-      </p:sp>
-      <p:sp>
-        <p:nvSpPr>
-          <p:cNvPr id="9" name="TextBox 8"/>
-          <p:cNvSpPr txBox="1"/>
-          <p:nvPr/>
-        </p:nvSpPr>
-        <p:spPr>
-          <a:xfrm>
-            <a:off x="822960" y="5943600"/>
-            <a:ext cx="10607040" cy="457200"/>
-          </a:xfrm>
-          <a:prstGeom prst="rect">
-            <a:avLst/>
-          </a:prstGeom>
-          <a:noFill/>
-        </p:spPr>
-        <p:txBody>
-          <a:bodyPr wrap="none">
-            <a:spAutoFit/>
-          </a:bodyPr>
-          <a:lstStyle/>
-          <a:p>
-            <a:pPr algn="l">
-              <a:spcAft>
-                <a:spcPts val="600"/>
-              </a:spcAft>
-            </a:pPr>
-            <a:r>
-              <a:rPr sz="1500" b="1">
-                <a:solidFill>
-                  <a:srgbClr val="9AA0B6"/>
-                </a:solidFill>
-                <a:latin typeface="Helvetica Neue"/>
-              </a:rPr>
-              <a:t>github.com/OCWC22/context-autopilot</a:t>
+              <a:t>Local &amp; on-device AI is exactly my lane. This product makes local agents reuse structured context instead of re-paying the cloud to rediscover it — the on-device inference problem I already work on.</a:t>
             </a:r>
           </a:p>
         </p:txBody>
@@ -3619,8 +3565,8 @@
         </p:nvSpPr>
         <p:spPr>
           <a:xfrm>
-            <a:off x="548640" y="6400800"/>
-            <a:ext cx="11155680" cy="365760"/>
+            <a:off x="548640" y="6419088"/>
+            <a:ext cx="11247120" cy="365760"/>
           </a:xfrm>
           <a:prstGeom prst="rect">
             <a:avLst/>
@@ -3639,15 +3585,7 @@
                   <a:srgbClr val="9AA0B6"/>
                 </a:solidFill>
               </a:rPr>
-              <a:t>EverMind + Butterbase: LIVE  ·  app_b197i2548pk2  ·  build0530</a:t>
-            </a:r>
-            <a:r>
-              <a:rPr sz="1000">
-                <a:solidFill>
-                  <a:srgbClr val="9AA0B6"/>
-                </a:solidFill>
-              </a:rPr>
-              <a:t>        2/8</a:t>
+              <a:t>Context Autopilot · Touchdown Labs · Built on EverMind + Butterbase (LIVE) · github.com/OCWC22/context-autopilot</a:t>
             </a:r>
           </a:p>
         </p:txBody>
@@ -3660,7 +3598,7 @@
         </p:nvSpPr>
         <p:spPr>
           <a:xfrm>
-            <a:off x="548640" y="502920"/>
+            <a:off x="548640" y="457200"/>
             <a:ext cx="10972800" cy="457200"/>
           </a:xfrm>
           <a:prstGeom prst="rect">
@@ -3676,7 +3614,7 @@
           <a:p>
             <a:pPr algn="l">
               <a:spcAft>
-                <a:spcPts val="600"/>
+                <a:spcPts val="800"/>
               </a:spcAft>
             </a:pPr>
             <a:r>
@@ -3686,7 +3624,7 @@
                 </a:solidFill>
                 <a:latin typeface="Helvetica Neue"/>
               </a:rPr>
-              <a:t>THE FULL SYSTEM</a:t>
+              <a:t>SLIDE 2 — PRODUCT</a:t>
             </a:r>
           </a:p>
         </p:txBody>
@@ -3699,8 +3637,8 @@
         </p:nvSpPr>
         <p:spPr>
           <a:xfrm>
-            <a:off x="548640" y="868680"/>
-            <a:ext cx="11155680" cy="640080"/>
+            <a:off x="548640" y="960120"/>
+            <a:ext cx="11064240" cy="731520"/>
           </a:xfrm>
           <a:prstGeom prst="rect">
             <a:avLst/>
@@ -3715,17 +3653,17 @@
           <a:p>
             <a:pPr algn="l">
               <a:spcAft>
-                <a:spcPts val="600"/>
+                <a:spcPts val="800"/>
               </a:spcAft>
             </a:pPr>
             <a:r>
-              <a:rPr sz="2700" b="1">
+              <a:rPr sz="3600" b="1">
                 <a:solidFill>
                   <a:srgbClr val="E8EAF2"/>
                 </a:solidFill>
                 <a:latin typeface="Helvetica Neue"/>
               </a:rPr>
-              <a:t>How SFT, RL, local AI &amp; MLX fit together</a:t>
+              <a:t>Context Autopilot</a:t>
             </a:r>
           </a:p>
         </p:txBody>
@@ -3738,8 +3676,8 @@
         </p:nvSpPr>
         <p:spPr>
           <a:xfrm>
-            <a:off x="548640" y="1481328"/>
-            <a:ext cx="11155680" cy="548640"/>
+            <a:off x="548640" y="1645920"/>
+            <a:ext cx="11064240" cy="822960"/>
           </a:xfrm>
           <a:prstGeom prst="rect">
             <a:avLst/>
@@ -3754,56 +3692,92 @@
           <a:p>
             <a:pPr algn="l">
               <a:spcAft>
-                <a:spcPts val="600"/>
+                <a:spcPts val="800"/>
               </a:spcAft>
             </a:pPr>
             <a:r>
-              <a:rPr sz="1400" b="0">
+              <a:rPr sz="1700" b="0">
                 <a:solidFill>
                   <a:srgbClr val="9AA0B6"/>
                 </a:solidFill>
                 <a:latin typeface="Helvetica Neue"/>
               </a:rPr>
-              <a:t>Goal: cut frontier-model calls &amp; cost while preserving task success — a coding model that learns your repo and style from your own traces.</a:t>
-            </a:r>
-          </a:p>
-        </p:txBody>
-      </p:sp>
-      <p:sp>
-        <p:nvSpPr>
-          <p:cNvPr id="8" name="TextBox 7"/>
-          <p:cNvSpPr txBox="1"/>
+              <a:t>One line: a $0 local engine that indexes ANY folder (code, docs, notes, projects) into reusable structured context — so Hermes, OpenClaw, or any local agent loads it instead of rediscovering everything.</a:t>
+            </a:r>
+          </a:p>
+        </p:txBody>
+      </p:sp>
+      <p:sp>
+        <p:nvSpPr>
+          <p:cNvPr id="8" name="Rounded Rectangle 7"/>
+          <p:cNvSpPr/>
           <p:nvPr/>
         </p:nvSpPr>
         <p:spPr>
           <a:xfrm>
-            <a:off x="548640" y="2194560"/>
-            <a:ext cx="10972800" cy="365760"/>
+            <a:off x="548640" y="2743200"/>
+            <a:ext cx="5440680" cy="2286000"/>
           </a:xfrm>
-          <a:prstGeom prst="rect">
+          <a:prstGeom prst="roundRect">
             <a:avLst/>
           </a:prstGeom>
-          <a:noFill/>
+          <a:solidFill>
+            <a:srgbClr val="10131E"/>
+          </a:solidFill>
+          <a:ln w="15875">
+            <a:solidFill>
+              <a:srgbClr val="FF7849"/>
+            </a:solidFill>
+          </a:ln>
+          <a:effectLst/>
         </p:spPr>
-        <p:txBody>
-          <a:bodyPr wrap="none">
-            <a:spAutoFit/>
-          </a:bodyPr>
+        <p:style>
+          <a:lnRef idx="1">
+            <a:schemeClr val="accent1"/>
+          </a:lnRef>
+          <a:fillRef idx="3">
+            <a:schemeClr val="accent1"/>
+          </a:fillRef>
+          <a:effectRef idx="2">
+            <a:schemeClr val="accent1"/>
+          </a:effectRef>
+          <a:fontRef idx="minor">
+            <a:schemeClr val="lt1"/>
+          </a:fontRef>
+        </p:style>
+        <p:txBody>
+          <a:bodyPr rtlCol="0" anchor="t" wrap="square" lIns="256032" tIns="201168" rIns="201168"/>
           <a:lstStyle/>
           <a:p>
             <a:pPr algn="l">
               <a:spcAft>
-                <a:spcPts val="600"/>
+                <a:spcPts val="800"/>
               </a:spcAft>
             </a:pPr>
             <a:r>
-              <a:rPr sz="1300" b="1">
+              <a:rPr sz="1800" b="1">
                 <a:solidFill>
-                  <a:srgbClr val="2DD4A7"/>
+                  <a:srgbClr val="FF7849"/>
                 </a:solidFill>
                 <a:latin typeface="Helvetica Neue"/>
               </a:rPr>
-              <a:t>OFFLINE — build your personal model (cheap, on-device)</a:t>
+              <a:t>Problem</a:t>
+            </a:r>
+          </a:p>
+          <a:p>
+            <a:pPr algn="l">
+              <a:spcAft>
+                <a:spcPts val="800"/>
+              </a:spcAft>
+            </a:pPr>
+            <a:r>
+              <a:rPr sz="1500" b="0">
+                <a:solidFill>
+                  <a:srgbClr val="E8EAF2"/>
+                </a:solidFill>
+                <a:latin typeface="Helvetica Neue"/>
+              </a:rPr>
+              <a:t>Local agents (Hermes, OpenClaw, Claude Code) rediscover your project every task — code, docs, notes — burning tokens reloading what they already saw (~90K to reload a 359 KB project).</a:t>
             </a:r>
           </a:p>
         </p:txBody>
@@ -3816,8 +3790,8 @@
         </p:nvSpPr>
         <p:spPr>
           <a:xfrm>
-            <a:off x="548640" y="2606040"/>
-            <a:ext cx="2457450" cy="1188720"/>
+            <a:off x="6199632" y="2743200"/>
+            <a:ext cx="5440680" cy="2286000"/>
           </a:xfrm>
           <a:prstGeom prst="roundRect">
             <a:avLst/>
@@ -3847,38 +3821,38 @@
           </a:fontRef>
         </p:style>
         <p:txBody>
-          <a:bodyPr rtlCol="0" anchor="ctr" wrap="square"/>
-          <a:lstStyle/>
-          <a:p>
-            <a:pPr algn="ctr">
+          <a:bodyPr rtlCol="0" anchor="t" wrap="square" lIns="256032" tIns="201168" rIns="201168"/>
+          <a:lstStyle/>
+          <a:p>
+            <a:pPr algn="l">
               <a:spcAft>
-                <a:spcPts val="200"/>
+                <a:spcPts val="800"/>
               </a:spcAft>
             </a:pPr>
             <a:r>
-              <a:rPr sz="1300" b="1">
+              <a:rPr sz="1800" b="1">
                 <a:solidFill>
                   <a:srgbClr val="2DD4A7"/>
                 </a:solidFill>
                 <a:latin typeface="Helvetica Neue"/>
               </a:rPr>
-              <a:t>Your traces + repo</a:t>
-            </a:r>
-          </a:p>
-          <a:p>
-            <a:pPr algn="ctr">
+              <a:t>Solution</a:t>
+            </a:r>
+          </a:p>
+          <a:p>
+            <a:pPr algn="l">
               <a:spcAft>
-                <a:spcPts val="0"/>
+                <a:spcPts val="800"/>
               </a:spcAft>
             </a:pPr>
             <a:r>
-              <a:rPr sz="1050" b="0">
+              <a:rPr sz="1500" b="0">
                 <a:solidFill>
                   <a:srgbClr val="E8EAF2"/>
                 </a:solidFill>
                 <a:latin typeface="Helvetica Neue"/>
               </a:rPr>
-              <a:t>Claude Code / Codex sessions, accepted diffs</a:t>
+              <a:t>Index once into a reusable SKILL.md + DAG map; agents reuse it across tasks, frontier only for the hard step. EverMind = memory, Butterbase = state.</a:t>
             </a:r>
           </a:p>
         </p:txBody>
@@ -3891,8 +3865,8 @@
         </p:nvSpPr>
         <p:spPr>
           <a:xfrm>
-            <a:off x="3028950" y="3017520"/>
-            <a:ext cx="365760" cy="365760"/>
+            <a:off x="548640" y="5257800"/>
+            <a:ext cx="11064240" cy="914400"/>
           </a:xfrm>
           <a:prstGeom prst="rect">
             <a:avLst/>
@@ -3905,703 +3879,19 @@
           </a:bodyPr>
           <a:lstStyle/>
           <a:p>
-            <a:pPr algn="ctr">
+            <a:pPr algn="l">
               <a:spcAft>
-                <a:spcPts val="600"/>
+                <a:spcPts val="800"/>
               </a:spcAft>
             </a:pPr>
             <a:r>
-              <a:rPr sz="2000" b="1">
-                <a:solidFill>
-                  <a:srgbClr val="9AA0B6"/>
-                </a:solidFill>
-                <a:latin typeface="Helvetica Neue"/>
-              </a:rPr>
-              <a:t>→</a:t>
-            </a:r>
-          </a:p>
-        </p:txBody>
-      </p:sp>
-      <p:sp>
-        <p:nvSpPr>
-          <p:cNvPr id="11" name="Rounded Rectangle 10"/>
-          <p:cNvSpPr/>
-          <p:nvPr/>
-        </p:nvSpPr>
-        <p:spPr>
-          <a:xfrm>
-            <a:off x="3417570" y="2606040"/>
-            <a:ext cx="2457450" cy="1188720"/>
-          </a:xfrm>
-          <a:prstGeom prst="roundRect">
-            <a:avLst/>
-          </a:prstGeom>
-          <a:solidFill>
-            <a:srgbClr val="10131E"/>
-          </a:solidFill>
-          <a:ln w="15875">
-            <a:solidFill>
-              <a:srgbClr val="4AA8FF"/>
-            </a:solidFill>
-          </a:ln>
-          <a:effectLst/>
-        </p:spPr>
-        <p:style>
-          <a:lnRef idx="1">
-            <a:schemeClr val="accent1"/>
-          </a:lnRef>
-          <a:fillRef idx="3">
-            <a:schemeClr val="accent1"/>
-          </a:fillRef>
-          <a:effectRef idx="2">
-            <a:schemeClr val="accent1"/>
-          </a:effectRef>
-          <a:fontRef idx="minor">
-            <a:schemeClr val="lt1"/>
-          </a:fontRef>
-        </p:style>
-        <p:txBody>
-          <a:bodyPr rtlCol="0" anchor="ctr" wrap="square"/>
-          <a:lstStyle/>
-          <a:p>
-            <a:pPr algn="ctr">
-              <a:spcAft>
-                <a:spcPts val="200"/>
-              </a:spcAft>
-            </a:pPr>
-            <a:r>
-              <a:rPr sz="1300" b="1">
+              <a:rPr sz="1700" b="1">
                 <a:solidFill>
                   <a:srgbClr val="4AA8FF"/>
                 </a:solidFill>
                 <a:latin typeface="Helvetica Neue"/>
               </a:rPr>
-              <a:t>SFT</a:t>
-            </a:r>
-          </a:p>
-          <a:p>
-            <a:pPr algn="ctr">
-              <a:spcAft>
-                <a:spcPts val="0"/>
-              </a:spcAft>
-            </a:pPr>
-            <a:r>
-              <a:rPr sz="1050" b="0">
-                <a:solidFill>
-                  <a:srgbClr val="E8EAF2"/>
-                </a:solidFill>
-                <a:latin typeface="Helvetica Neue"/>
-              </a:rPr>
-              <a:t>distill GLM-5.1 (teacher) → student</a:t>
-            </a:r>
-          </a:p>
-        </p:txBody>
-      </p:sp>
-      <p:sp>
-        <p:nvSpPr>
-          <p:cNvPr id="12" name="TextBox 11"/>
-          <p:cNvSpPr txBox="1"/>
-          <p:nvPr/>
-        </p:nvSpPr>
-        <p:spPr>
-          <a:xfrm>
-            <a:off x="5897880" y="3017520"/>
-            <a:ext cx="365760" cy="365760"/>
-          </a:xfrm>
-          <a:prstGeom prst="rect">
-            <a:avLst/>
-          </a:prstGeom>
-          <a:noFill/>
-        </p:spPr>
-        <p:txBody>
-          <a:bodyPr wrap="none">
-            <a:spAutoFit/>
-          </a:bodyPr>
-          <a:lstStyle/>
-          <a:p>
-            <a:pPr algn="ctr">
-              <a:spcAft>
-                <a:spcPts val="600"/>
-              </a:spcAft>
-            </a:pPr>
-            <a:r>
-              <a:rPr sz="2000" b="1">
-                <a:solidFill>
-                  <a:srgbClr val="9AA0B6"/>
-                </a:solidFill>
-                <a:latin typeface="Helvetica Neue"/>
-              </a:rPr>
-              <a:t>→</a:t>
-            </a:r>
-          </a:p>
-        </p:txBody>
-      </p:sp>
-      <p:sp>
-        <p:nvSpPr>
-          <p:cNvPr id="13" name="Rounded Rectangle 12"/>
-          <p:cNvSpPr/>
-          <p:nvPr/>
-        </p:nvSpPr>
-        <p:spPr>
-          <a:xfrm>
-            <a:off x="6286500" y="2606040"/>
-            <a:ext cx="2457450" cy="1188720"/>
-          </a:xfrm>
-          <a:prstGeom prst="roundRect">
-            <a:avLst/>
-          </a:prstGeom>
-          <a:solidFill>
-            <a:srgbClr val="10131E"/>
-          </a:solidFill>
-          <a:ln w="15875">
-            <a:solidFill>
-              <a:srgbClr val="A78BFA"/>
-            </a:solidFill>
-          </a:ln>
-          <a:effectLst/>
-        </p:spPr>
-        <p:style>
-          <a:lnRef idx="1">
-            <a:schemeClr val="accent1"/>
-          </a:lnRef>
-          <a:fillRef idx="3">
-            <a:schemeClr val="accent1"/>
-          </a:fillRef>
-          <a:effectRef idx="2">
-            <a:schemeClr val="accent1"/>
-          </a:effectRef>
-          <a:fontRef idx="minor">
-            <a:schemeClr val="lt1"/>
-          </a:fontRef>
-        </p:style>
-        <p:txBody>
-          <a:bodyPr rtlCol="0" anchor="ctr" wrap="square"/>
-          <a:lstStyle/>
-          <a:p>
-            <a:pPr algn="ctr">
-              <a:spcAft>
-                <a:spcPts val="200"/>
-              </a:spcAft>
-            </a:pPr>
-            <a:r>
-              <a:rPr sz="1300" b="1">
-                <a:solidFill>
-                  <a:srgbClr val="A78BFA"/>
-                </a:solidFill>
-                <a:latin typeface="Helvetica Neue"/>
-              </a:rPr>
-              <a:t>RL</a:t>
-            </a:r>
-          </a:p>
-          <a:p>
-            <a:pPr algn="ctr">
-              <a:spcAft>
-                <a:spcPts val="0"/>
-              </a:spcAft>
-            </a:pPr>
-            <a:r>
-              <a:rPr sz="1050" b="0">
-                <a:solidFill>
-                  <a:srgbClr val="E8EAF2"/>
-                </a:solidFill>
-                <a:latin typeface="Helvetica Neue"/>
-              </a:rPr>
-              <a:t>verifiable rewards (GRPO): tests pass</a:t>
-            </a:r>
-          </a:p>
-        </p:txBody>
-      </p:sp>
-      <p:sp>
-        <p:nvSpPr>
-          <p:cNvPr id="14" name="TextBox 13"/>
-          <p:cNvSpPr txBox="1"/>
-          <p:nvPr/>
-        </p:nvSpPr>
-        <p:spPr>
-          <a:xfrm>
-            <a:off x="8766810" y="3017520"/>
-            <a:ext cx="365760" cy="365760"/>
-          </a:xfrm>
-          <a:prstGeom prst="rect">
-            <a:avLst/>
-          </a:prstGeom>
-          <a:noFill/>
-        </p:spPr>
-        <p:txBody>
-          <a:bodyPr wrap="none">
-            <a:spAutoFit/>
-          </a:bodyPr>
-          <a:lstStyle/>
-          <a:p>
-            <a:pPr algn="ctr">
-              <a:spcAft>
-                <a:spcPts val="600"/>
-              </a:spcAft>
-            </a:pPr>
-            <a:r>
-              <a:rPr sz="2000" b="1">
-                <a:solidFill>
-                  <a:srgbClr val="9AA0B6"/>
-                </a:solidFill>
-                <a:latin typeface="Helvetica Neue"/>
-              </a:rPr>
-              <a:t>→</a:t>
-            </a:r>
-          </a:p>
-        </p:txBody>
-      </p:sp>
-      <p:sp>
-        <p:nvSpPr>
-          <p:cNvPr id="15" name="Rounded Rectangle 14"/>
-          <p:cNvSpPr/>
-          <p:nvPr/>
-        </p:nvSpPr>
-        <p:spPr>
-          <a:xfrm>
-            <a:off x="9155430" y="2606040"/>
-            <a:ext cx="2457450" cy="1188720"/>
-          </a:xfrm>
-          <a:prstGeom prst="roundRect">
-            <a:avLst/>
-          </a:prstGeom>
-          <a:solidFill>
-            <a:srgbClr val="10131E"/>
-          </a:solidFill>
-          <a:ln w="15875">
-            <a:solidFill>
-              <a:srgbClr val="FF7849"/>
-            </a:solidFill>
-          </a:ln>
-          <a:effectLst/>
-        </p:spPr>
-        <p:style>
-          <a:lnRef idx="1">
-            <a:schemeClr val="accent1"/>
-          </a:lnRef>
-          <a:fillRef idx="3">
-            <a:schemeClr val="accent1"/>
-          </a:fillRef>
-          <a:effectRef idx="2">
-            <a:schemeClr val="accent1"/>
-          </a:effectRef>
-          <a:fontRef idx="minor">
-            <a:schemeClr val="lt1"/>
-          </a:fontRef>
-        </p:style>
-        <p:txBody>
-          <a:bodyPr rtlCol="0" anchor="ctr" wrap="square"/>
-          <a:lstStyle/>
-          <a:p>
-            <a:pPr algn="ctr">
-              <a:spcAft>
-                <a:spcPts val="200"/>
-              </a:spcAft>
-            </a:pPr>
-            <a:r>
-              <a:rPr sz="1300" b="1">
-                <a:solidFill>
-                  <a:srgbClr val="FF7849"/>
-                </a:solidFill>
-                <a:latin typeface="Helvetica Neue"/>
-              </a:rPr>
-              <a:t>MLX model</a:t>
-            </a:r>
-          </a:p>
-          <a:p>
-            <a:pPr algn="ctr">
-              <a:spcAft>
-                <a:spcPts val="0"/>
-              </a:spcAft>
-            </a:pPr>
-            <a:r>
-              <a:rPr sz="1050" b="0">
-                <a:solidFill>
-                  <a:srgbClr val="E8EAF2"/>
-                </a:solidFill>
-                <a:latin typeface="Helvetica Neue"/>
-              </a:rPr>
-              <a:t>personal coder · 16 GB Mac · $0</a:t>
-            </a:r>
-          </a:p>
-        </p:txBody>
-      </p:sp>
-      <p:sp>
-        <p:nvSpPr>
-          <p:cNvPr id="16" name="TextBox 15"/>
-          <p:cNvSpPr txBox="1"/>
-          <p:nvPr/>
-        </p:nvSpPr>
-        <p:spPr>
-          <a:xfrm>
-            <a:off x="548640" y="4114800"/>
-            <a:ext cx="10972800" cy="365760"/>
-          </a:xfrm>
-          <a:prstGeom prst="rect">
-            <a:avLst/>
-          </a:prstGeom>
-          <a:noFill/>
-        </p:spPr>
-        <p:txBody>
-          <a:bodyPr wrap="none">
-            <a:spAutoFit/>
-          </a:bodyPr>
-          <a:lstStyle/>
-          <a:p>
-            <a:pPr algn="l">
-              <a:spcAft>
-                <a:spcPts val="600"/>
-              </a:spcAft>
-            </a:pPr>
-            <a:r>
-              <a:rPr sz="1300" b="1">
-                <a:solidFill>
-                  <a:srgbClr val="2DD4A7"/>
-                </a:solidFill>
-                <a:latin typeface="Helvetica Neue"/>
-              </a:rPr>
-              <a:t>ONLINE — every task</a:t>
-            </a:r>
-          </a:p>
-        </p:txBody>
-      </p:sp>
-      <p:sp>
-        <p:nvSpPr>
-          <p:cNvPr id="17" name="Rounded Rectangle 16"/>
-          <p:cNvSpPr/>
-          <p:nvPr/>
-        </p:nvSpPr>
-        <p:spPr>
-          <a:xfrm>
-            <a:off x="548640" y="4526280"/>
-            <a:ext cx="3413759" cy="1188720"/>
-          </a:xfrm>
-          <a:prstGeom prst="roundRect">
-            <a:avLst/>
-          </a:prstGeom>
-          <a:solidFill>
-            <a:srgbClr val="10131E"/>
-          </a:solidFill>
-          <a:ln w="15875">
-            <a:solidFill>
-              <a:srgbClr val="2DD4A7"/>
-            </a:solidFill>
-          </a:ln>
-          <a:effectLst/>
-        </p:spPr>
-        <p:style>
-          <a:lnRef idx="1">
-            <a:schemeClr val="accent1"/>
-          </a:lnRef>
-          <a:fillRef idx="3">
-            <a:schemeClr val="accent1"/>
-          </a:fillRef>
-          <a:effectRef idx="2">
-            <a:schemeClr val="accent1"/>
-          </a:effectRef>
-          <a:fontRef idx="minor">
-            <a:schemeClr val="lt1"/>
-          </a:fontRef>
-        </p:style>
-        <p:txBody>
-          <a:bodyPr rtlCol="0" anchor="ctr" wrap="square"/>
-          <a:lstStyle/>
-          <a:p>
-            <a:pPr algn="ctr">
-              <a:spcAft>
-                <a:spcPts val="200"/>
-              </a:spcAft>
-            </a:pPr>
-            <a:r>
-              <a:rPr sz="1300" b="1">
-                <a:solidFill>
-                  <a:srgbClr val="2DD4A7"/>
-                </a:solidFill>
-                <a:latin typeface="Helvetica Neue"/>
-              </a:rPr>
-              <a:t>Coding task</a:t>
-            </a:r>
-          </a:p>
-          <a:p>
-            <a:pPr algn="ctr">
-              <a:spcAft>
-                <a:spcPts val="0"/>
-              </a:spcAft>
-            </a:pPr>
-            <a:r>
-              <a:rPr sz="1050" b="0">
-                <a:solidFill>
-                  <a:srgbClr val="E8EAF2"/>
-                </a:solidFill>
-                <a:latin typeface="Helvetica Neue"/>
-              </a:rPr>
-              <a:t>question / fix / refactor</a:t>
-            </a:r>
-          </a:p>
-        </p:txBody>
-      </p:sp>
-      <p:sp>
-        <p:nvSpPr>
-          <p:cNvPr id="18" name="TextBox 17"/>
-          <p:cNvSpPr txBox="1"/>
-          <p:nvPr/>
-        </p:nvSpPr>
-        <p:spPr>
-          <a:xfrm>
-            <a:off x="3985260" y="4937760"/>
-            <a:ext cx="365760" cy="365760"/>
-          </a:xfrm>
-          <a:prstGeom prst="rect">
-            <a:avLst/>
-          </a:prstGeom>
-          <a:noFill/>
-        </p:spPr>
-        <p:txBody>
-          <a:bodyPr wrap="none">
-            <a:spAutoFit/>
-          </a:bodyPr>
-          <a:lstStyle/>
-          <a:p>
-            <a:pPr algn="ctr">
-              <a:spcAft>
-                <a:spcPts val="600"/>
-              </a:spcAft>
-            </a:pPr>
-            <a:r>
-              <a:rPr sz="2000" b="1">
-                <a:solidFill>
-                  <a:srgbClr val="9AA0B6"/>
-                </a:solidFill>
-                <a:latin typeface="Helvetica Neue"/>
-              </a:rPr>
-              <a:t>→</a:t>
-            </a:r>
-          </a:p>
-        </p:txBody>
-      </p:sp>
-      <p:sp>
-        <p:nvSpPr>
-          <p:cNvPr id="19" name="Rounded Rectangle 18"/>
-          <p:cNvSpPr/>
-          <p:nvPr/>
-        </p:nvSpPr>
-        <p:spPr>
-          <a:xfrm>
-            <a:off x="4373879" y="4526280"/>
-            <a:ext cx="3413759" cy="1188720"/>
-          </a:xfrm>
-          <a:prstGeom prst="roundRect">
-            <a:avLst/>
-          </a:prstGeom>
-          <a:solidFill>
-            <a:srgbClr val="10131E"/>
-          </a:solidFill>
-          <a:ln w="15875">
-            <a:solidFill>
-              <a:srgbClr val="4AA8FF"/>
-            </a:solidFill>
-          </a:ln>
-          <a:effectLst/>
-        </p:spPr>
-        <p:style>
-          <a:lnRef idx="1">
-            <a:schemeClr val="accent1"/>
-          </a:lnRef>
-          <a:fillRef idx="3">
-            <a:schemeClr val="accent1"/>
-          </a:fillRef>
-          <a:effectRef idx="2">
-            <a:schemeClr val="accent1"/>
-          </a:effectRef>
-          <a:fontRef idx="minor">
-            <a:schemeClr val="lt1"/>
-          </a:fontRef>
-        </p:style>
-        <p:txBody>
-          <a:bodyPr rtlCol="0" anchor="ctr" wrap="square"/>
-          <a:lstStyle/>
-          <a:p>
-            <a:pPr algn="ctr">
-              <a:spcAft>
-                <a:spcPts val="200"/>
-              </a:spcAft>
-            </a:pPr>
-            <a:r>
-              <a:rPr sz="1300" b="1">
-                <a:solidFill>
-                  <a:srgbClr val="4AA8FF"/>
-                </a:solidFill>
-                <a:latin typeface="Helvetica Neue"/>
-              </a:rPr>
-              <a:t>Local context + subagents</a:t>
-            </a:r>
-          </a:p>
-          <a:p>
-            <a:pPr algn="ctr">
-              <a:spcAft>
-                <a:spcPts val="0"/>
-              </a:spcAft>
-            </a:pPr>
-            <a:r>
-              <a:rPr sz="1050" b="0">
-                <a:solidFill>
-                  <a:srgbClr val="E8EAF2"/>
-                </a:solidFill>
-                <a:latin typeface="Helvetica Neue"/>
-              </a:rPr>
-              <a:t>$0 DAG / SKILL.md + RLM — runs local</a:t>
-            </a:r>
-          </a:p>
-        </p:txBody>
-      </p:sp>
-      <p:sp>
-        <p:nvSpPr>
-          <p:cNvPr id="20" name="TextBox 19"/>
-          <p:cNvSpPr txBox="1"/>
-          <p:nvPr/>
-        </p:nvSpPr>
-        <p:spPr>
-          <a:xfrm>
-            <a:off x="7810499" y="4937760"/>
-            <a:ext cx="365760" cy="365760"/>
-          </a:xfrm>
-          <a:prstGeom prst="rect">
-            <a:avLst/>
-          </a:prstGeom>
-          <a:noFill/>
-        </p:spPr>
-        <p:txBody>
-          <a:bodyPr wrap="none">
-            <a:spAutoFit/>
-          </a:bodyPr>
-          <a:lstStyle/>
-          <a:p>
-            <a:pPr algn="ctr">
-              <a:spcAft>
-                <a:spcPts val="600"/>
-              </a:spcAft>
-            </a:pPr>
-            <a:r>
-              <a:rPr sz="2000" b="1">
-                <a:solidFill>
-                  <a:srgbClr val="9AA0B6"/>
-                </a:solidFill>
-                <a:latin typeface="Helvetica Neue"/>
-              </a:rPr>
-              <a:t>→</a:t>
-            </a:r>
-          </a:p>
-        </p:txBody>
-      </p:sp>
-      <p:sp>
-        <p:nvSpPr>
-          <p:cNvPr id="21" name="Rounded Rectangle 20"/>
-          <p:cNvSpPr/>
-          <p:nvPr/>
-        </p:nvSpPr>
-        <p:spPr>
-          <a:xfrm>
-            <a:off x="8199119" y="4526280"/>
-            <a:ext cx="3413759" cy="1188720"/>
-          </a:xfrm>
-          <a:prstGeom prst="roundRect">
-            <a:avLst/>
-          </a:prstGeom>
-          <a:solidFill>
-            <a:srgbClr val="10131E"/>
-          </a:solidFill>
-          <a:ln w="15875">
-            <a:solidFill>
-              <a:srgbClr val="A78BFA"/>
-            </a:solidFill>
-          </a:ln>
-          <a:effectLst/>
-        </p:spPr>
-        <p:style>
-          <a:lnRef idx="1">
-            <a:schemeClr val="accent1"/>
-          </a:lnRef>
-          <a:fillRef idx="3">
-            <a:schemeClr val="accent1"/>
-          </a:fillRef>
-          <a:effectRef idx="2">
-            <a:schemeClr val="accent1"/>
-          </a:effectRef>
-          <a:fontRef idx="minor">
-            <a:schemeClr val="lt1"/>
-          </a:fontRef>
-        </p:style>
-        <p:txBody>
-          <a:bodyPr rtlCol="0" anchor="ctr" wrap="square"/>
-          <a:lstStyle/>
-          <a:p>
-            <a:pPr algn="ctr">
-              <a:spcAft>
-                <a:spcPts val="200"/>
-              </a:spcAft>
-            </a:pPr>
-            <a:r>
-              <a:rPr sz="1300" b="1">
-                <a:solidFill>
-                  <a:srgbClr val="A78BFA"/>
-                </a:solidFill>
-                <a:latin typeface="Helvetica Neue"/>
-              </a:rPr>
-              <a:t>Frontier only when hard</a:t>
-            </a:r>
-          </a:p>
-          <a:p>
-            <a:pPr algn="ctr">
-              <a:spcAft>
-                <a:spcPts val="0"/>
-              </a:spcAft>
-            </a:pPr>
-            <a:r>
-              <a:rPr sz="1050" b="0">
-                <a:solidFill>
-                  <a:srgbClr val="E8EAF2"/>
-                </a:solidFill>
-                <a:latin typeface="Helvetica Neue"/>
-              </a:rPr>
-              <a:t>escalate to Claude / Codex</a:t>
-            </a:r>
-          </a:p>
-        </p:txBody>
-      </p:sp>
-      <p:sp>
-        <p:nvSpPr>
-          <p:cNvPr id="22" name="TextBox 21"/>
-          <p:cNvSpPr txBox="1"/>
-          <p:nvPr/>
-        </p:nvSpPr>
-        <p:spPr>
-          <a:xfrm>
-            <a:off x="548640" y="5806440"/>
-            <a:ext cx="11155680" cy="457200"/>
-          </a:xfrm>
-          <a:prstGeom prst="rect">
-            <a:avLst/>
-          </a:prstGeom>
-          <a:noFill/>
-        </p:spPr>
-        <p:txBody>
-          <a:bodyPr wrap="none">
-            <a:spAutoFit/>
-          </a:bodyPr>
-          <a:lstStyle/>
-          <a:p>
-            <a:pPr algn="l">
-              <a:spcAft>
-                <a:spcPts val="600"/>
-              </a:spcAft>
-            </a:pPr>
-            <a:r>
-              <a:rPr sz="1400" b="1">
-                <a:solidFill>
-                  <a:srgbClr val="9AA0B6"/>
-                </a:solidFill>
-                <a:latin typeface="Helvetica Neue"/>
-              </a:rPr>
-              <a:t>Substrate:  EverMind = long-term memory   ·   Butterbase = state / backend   ·   eval harness = the proof (−98.7% tokens)</a:t>
+              <a:t>Proof: same task 11,947 → 299 tokens (−98.7%, tests pass).  Real repo psf/requests: 147,794 → ~1,025 tokens (57×, −99.3%).</a:t>
             </a:r>
           </a:p>
         </p:txBody>
@@ -4720,8 +4010,8 @@
         </p:nvSpPr>
         <p:spPr>
           <a:xfrm>
-            <a:off x="548640" y="6400800"/>
-            <a:ext cx="11155680" cy="365760"/>
+            <a:off x="548640" y="6419088"/>
+            <a:ext cx="11247120" cy="365760"/>
           </a:xfrm>
           <a:prstGeom prst="rect">
             <a:avLst/>
@@ -4740,15 +4030,7 @@
                   <a:srgbClr val="9AA0B6"/>
                 </a:solidFill>
               </a:rPr>
-              <a:t>EverMind + Butterbase: LIVE  ·  app_b197i2548pk2  ·  build0530</a:t>
-            </a:r>
-            <a:r>
-              <a:rPr sz="1000">
-                <a:solidFill>
-                  <a:srgbClr val="9AA0B6"/>
-                </a:solidFill>
-              </a:rPr>
-              <a:t>        3/8</a:t>
+              <a:t>Context Autopilot · Touchdown Labs · Built on EverMind + Butterbase (LIVE) · github.com/OCWC22/context-autopilot</a:t>
             </a:r>
           </a:p>
         </p:txBody>
@@ -4761,7 +4043,7 @@
         </p:nvSpPr>
         <p:spPr>
           <a:xfrm>
-            <a:off x="548640" y="502920"/>
+            <a:off x="548640" y="457200"/>
             <a:ext cx="10972800" cy="457200"/>
           </a:xfrm>
           <a:prstGeom prst="rect">
@@ -4777,17 +4059,17 @@
           <a:p>
             <a:pPr algn="l">
               <a:spcAft>
-                <a:spcPts val="600"/>
+                <a:spcPts val="800"/>
               </a:spcAft>
             </a:pPr>
             <a:r>
               <a:rPr sz="1500" b="1">
                 <a:solidFill>
-                  <a:srgbClr val="A78BFA"/>
+                  <a:srgbClr val="2DD4A7"/>
                 </a:solidFill>
                 <a:latin typeface="Helvetica Neue"/>
               </a:rPr>
-              <a:t>SPONSORS — HOW IT CONNECTS</a:t>
+              <a:t>SLIDE 3 — DEMO</a:t>
             </a:r>
           </a:p>
         </p:txBody>
@@ -4801,7 +4083,7 @@
         <p:spPr>
           <a:xfrm>
             <a:off x="548640" y="914400"/>
-            <a:ext cx="11155680" cy="731520"/>
+            <a:ext cx="11064240" cy="640080"/>
           </a:xfrm>
           <a:prstGeom prst="rect">
             <a:avLst/>
@@ -4816,2420 +4098,17 @@
           <a:p>
             <a:pPr algn="l">
               <a:spcAft>
-                <a:spcPts val="600"/>
+                <a:spcPts val="800"/>
               </a:spcAft>
             </a:pPr>
             <a:r>
-              <a:rPr sz="2600" b="1">
+              <a:rPr sz="2400" b="1">
                 <a:solidFill>
                   <a:srgbClr val="E8EAF2"/>
                 </a:solidFill>
                 <a:latin typeface="Helvetica Neue"/>
               </a:rPr>
-              <a:t>Local source of truth × cloud memory × durable state</a:t>
-            </a:r>
-          </a:p>
-        </p:txBody>
-      </p:sp>
-      <p:sp>
-        <p:nvSpPr>
-          <p:cNvPr id="7" name="Rounded Rectangle 6"/>
-          <p:cNvSpPr/>
-          <p:nvPr/>
-        </p:nvSpPr>
-        <p:spPr>
-          <a:xfrm>
-            <a:off x="548640" y="1874519"/>
-            <a:ext cx="5440680" cy="3200400"/>
-          </a:xfrm>
-          <a:prstGeom prst="roundRect">
-            <a:avLst/>
-          </a:prstGeom>
-          <a:solidFill>
-            <a:srgbClr val="10131E"/>
-          </a:solidFill>
-          <a:ln w="15875">
-            <a:solidFill>
-              <a:srgbClr val="A78BFA"/>
-            </a:solidFill>
-          </a:ln>
-          <a:effectLst/>
-        </p:spPr>
-        <p:style>
-          <a:lnRef idx="1">
-            <a:schemeClr val="accent1"/>
-          </a:lnRef>
-          <a:fillRef idx="3">
-            <a:schemeClr val="accent1"/>
-          </a:fillRef>
-          <a:effectRef idx="2">
-            <a:schemeClr val="accent1"/>
-          </a:effectRef>
-          <a:fontRef idx="minor">
-            <a:schemeClr val="lt1"/>
-          </a:fontRef>
-        </p:style>
-        <p:txBody>
-          <a:bodyPr rtlCol="0" anchor="t" wrap="square" lIns="256032" tIns="201168" rIns="182880"/>
-          <a:lstStyle/>
-          <a:p>
-            <a:pPr algn="l">
-              <a:spcAft>
-                <a:spcPts val="600"/>
-              </a:spcAft>
-            </a:pPr>
-            <a:r>
-              <a:rPr sz="1800" b="1">
-                <a:solidFill>
-                  <a:srgbClr val="A78BFA"/>
-                </a:solidFill>
-                <a:latin typeface="Helvetica Neue"/>
-              </a:rPr>
-              <a:t>EverMind / EverOS — long-term memory</a:t>
-            </a:r>
-          </a:p>
-          <a:p>
-            <a:pPr algn="l">
-              <a:spcAft>
-                <a:spcPts val="1000"/>
-              </a:spcAft>
-            </a:pPr>
-            <a:r>
-              <a:rPr sz="1400" b="0">
-                <a:solidFill>
-                  <a:srgbClr val="E8EAF2"/>
-                </a:solidFill>
-                <a:latin typeface="Helvetica Neue"/>
-              </a:rPr>
-              <a:t>We EXTEND it with a LOCAL source of truth: the $0 index keeps your current files, structure &amp; decisions fresh and deterministic, on-device.</a:t>
-            </a:r>
-          </a:p>
-          <a:p>
-            <a:pPr algn="l">
-              <a:spcAft>
-                <a:spcPts val="600"/>
-              </a:spcAft>
-            </a:pPr>
-            <a:r>
-              <a:rPr sz="1400" b="0">
-                <a:solidFill>
-                  <a:srgbClr val="E8EAF2"/>
-                </a:solidFill>
-                <a:latin typeface="Helvetica Neue"/>
-              </a:rPr>
-              <a:t>Those traces flow into EverMind, so memory is both fresh (local) and persistent across sessions — long-context personal memory.</a:t>
-            </a:r>
-          </a:p>
-        </p:txBody>
-      </p:sp>
-      <p:sp>
-        <p:nvSpPr>
-          <p:cNvPr id="8" name="Rounded Rectangle 7"/>
-          <p:cNvSpPr/>
-          <p:nvPr/>
-        </p:nvSpPr>
-        <p:spPr>
-          <a:xfrm>
-            <a:off x="6199632" y="1874519"/>
-            <a:ext cx="5440680" cy="3200400"/>
-          </a:xfrm>
-          <a:prstGeom prst="roundRect">
-            <a:avLst/>
-          </a:prstGeom>
-          <a:solidFill>
-            <a:srgbClr val="10131E"/>
-          </a:solidFill>
-          <a:ln w="15875">
-            <a:solidFill>
-              <a:srgbClr val="4AA8FF"/>
-            </a:solidFill>
-          </a:ln>
-          <a:effectLst/>
-        </p:spPr>
-        <p:style>
-          <a:lnRef idx="1">
-            <a:schemeClr val="accent1"/>
-          </a:lnRef>
-          <a:fillRef idx="3">
-            <a:schemeClr val="accent1"/>
-          </a:fillRef>
-          <a:effectRef idx="2">
-            <a:schemeClr val="accent1"/>
-          </a:effectRef>
-          <a:fontRef idx="minor">
-            <a:schemeClr val="lt1"/>
-          </a:fontRef>
-        </p:style>
-        <p:txBody>
-          <a:bodyPr rtlCol="0" anchor="t" wrap="square" lIns="256032" tIns="201168" rIns="182880"/>
-          <a:lstStyle/>
-          <a:p>
-            <a:pPr algn="l">
-              <a:spcAft>
-                <a:spcPts val="600"/>
-              </a:spcAft>
-            </a:pPr>
-            <a:r>
-              <a:rPr sz="1800" b="1">
-                <a:solidFill>
-                  <a:srgbClr val="4AA8FF"/>
-                </a:solidFill>
-                <a:latin typeface="Helvetica Neue"/>
-              </a:rPr>
-              <a:t>Butterbase — state &amp; backend</a:t>
-            </a:r>
-          </a:p>
-          <a:p>
-            <a:pPr algn="l">
-              <a:spcAft>
-                <a:spcPts val="1000"/>
-              </a:spcAft>
-            </a:pPr>
-            <a:r>
-              <a:rPr sz="1400" b="0">
-                <a:solidFill>
-                  <a:srgbClr val="E8EAF2"/>
-                </a:solidFill>
-                <a:latin typeface="Helvetica Neue"/>
-              </a:rPr>
-              <a:t>We CONNECT via the Data API: projects, task state, tool-call traces, eval results &amp; artifacts persist as structured rows (Postgres + auth + storage).</a:t>
-            </a:r>
-          </a:p>
-          <a:p>
-            <a:pPr algn="l">
-              <a:spcAft>
-                <a:spcPts val="600"/>
-              </a:spcAft>
-            </a:pPr>
-            <a:r>
-              <a:rPr sz="1400" b="0">
-                <a:solidFill>
-                  <a:srgbClr val="E8EAF2"/>
-                </a:solidFill>
-                <a:latin typeface="Helvetica Neue"/>
-              </a:rPr>
-              <a:t>Agents read/write durable state instead of holding it in context. Live: app app_b197i2548pk2.</a:t>
-            </a:r>
-          </a:p>
-        </p:txBody>
-      </p:sp>
-      <p:sp>
-        <p:nvSpPr>
-          <p:cNvPr id="9" name="TextBox 8"/>
-          <p:cNvSpPr txBox="1"/>
-          <p:nvPr/>
-        </p:nvSpPr>
-        <p:spPr>
-          <a:xfrm>
-            <a:off x="548640" y="5303520"/>
-            <a:ext cx="11155680" cy="640080"/>
-          </a:xfrm>
-          <a:prstGeom prst="rect">
-            <a:avLst/>
-          </a:prstGeom>
-          <a:noFill/>
-        </p:spPr>
-        <p:txBody>
-          <a:bodyPr wrap="none">
-            <a:spAutoFit/>
-          </a:bodyPr>
-          <a:lstStyle/>
-          <a:p>
-            <a:pPr algn="l">
-              <a:spcAft>
-                <a:spcPts val="600"/>
-              </a:spcAft>
-            </a:pPr>
-            <a:r>
-              <a:rPr sz="1600" b="1">
-                <a:solidFill>
-                  <a:srgbClr val="2DD4A7"/>
-                </a:solidFill>
-                <a:latin typeface="Helvetica Neue"/>
-              </a:rPr>
-              <a:t>Local = source of truth (now)   ·   EverMind = memory (over time)   ·   Butterbase = state (durable)</a:t>
-            </a:r>
-          </a:p>
-        </p:txBody>
-      </p:sp>
-    </p:spTree>
-  </p:cSld>
-  <p:clrMapOvr>
-    <a:masterClrMapping/>
-  </p:clrMapOvr>
-</p:sld>
-</file>
-
-<file path=ppt/slides/slide4.xml><?xml version="1.0" encoding="utf-8"?>
-<p:sld xmlns:a="http://schemas.openxmlformats.org/drawingml/2006/main" xmlns:p="http://schemas.openxmlformats.org/presentationml/2006/main" xmlns:r="http://schemas.openxmlformats.org/officeDocument/2006/relationships">
-  <p:cSld>
-    <p:spTree>
-      <p:nvGrpSpPr>
-        <p:cNvPr id="1" name=""/>
-        <p:cNvGrpSpPr/>
-        <p:nvPr/>
-      </p:nvGrpSpPr>
-      <p:grpSpPr/>
-      <p:sp>
-        <p:nvSpPr>
-          <p:cNvPr id="2" name="Rectangle 1"/>
-          <p:cNvSpPr/>
-          <p:nvPr/>
-        </p:nvSpPr>
-        <p:spPr>
-          <a:xfrm>
-            <a:off x="0" y="0"/>
-            <a:ext cx="12191695" cy="6858000"/>
-          </a:xfrm>
-          <a:prstGeom prst="rect">
-            <a:avLst/>
-          </a:prstGeom>
-          <a:solidFill>
-            <a:srgbClr val="0A0C14"/>
-          </a:solidFill>
-          <a:ln>
-            <a:noFill/>
-          </a:ln>
-          <a:effectLst/>
-        </p:spPr>
-        <p:style>
-          <a:lnRef idx="1">
-            <a:schemeClr val="accent1"/>
-          </a:lnRef>
-          <a:fillRef idx="3">
-            <a:schemeClr val="accent1"/>
-          </a:fillRef>
-          <a:effectRef idx="2">
-            <a:schemeClr val="accent1"/>
-          </a:effectRef>
-          <a:fontRef idx="minor">
-            <a:schemeClr val="lt1"/>
-          </a:fontRef>
-        </p:style>
-        <p:txBody>
-          <a:bodyPr rtlCol="0" anchor="ctr"/>
-          <a:lstStyle/>
-          <a:p>
-            <a:pPr algn="ctr"/>
-          </a:p>
-        </p:txBody>
-      </p:sp>
-      <p:sp>
-        <p:nvSpPr>
-          <p:cNvPr id="3" name="Rectangle 2"/>
-          <p:cNvSpPr/>
-          <p:nvPr/>
-        </p:nvSpPr>
-        <p:spPr>
-          <a:xfrm>
-            <a:off x="0" y="0"/>
-            <a:ext cx="128016" cy="6858000"/>
-          </a:xfrm>
-          <a:prstGeom prst="rect">
-            <a:avLst/>
-          </a:prstGeom>
-          <a:solidFill>
-            <a:srgbClr val="2DD4A7"/>
-          </a:solidFill>
-          <a:ln>
-            <a:noFill/>
-          </a:ln>
-          <a:effectLst/>
-        </p:spPr>
-        <p:style>
-          <a:lnRef idx="1">
-            <a:schemeClr val="accent1"/>
-          </a:lnRef>
-          <a:fillRef idx="3">
-            <a:schemeClr val="accent1"/>
-          </a:fillRef>
-          <a:effectRef idx="2">
-            <a:schemeClr val="accent1"/>
-          </a:effectRef>
-          <a:fontRef idx="minor">
-            <a:schemeClr val="lt1"/>
-          </a:fontRef>
-        </p:style>
-        <p:txBody>
-          <a:bodyPr rtlCol="0" anchor="ctr"/>
-          <a:lstStyle/>
-          <a:p>
-            <a:pPr algn="ctr"/>
-          </a:p>
-        </p:txBody>
-      </p:sp>
-      <p:sp>
-        <p:nvSpPr>
-          <p:cNvPr id="4" name="TextBox 3"/>
-          <p:cNvSpPr txBox="1"/>
-          <p:nvPr/>
-        </p:nvSpPr>
-        <p:spPr>
-          <a:xfrm>
-            <a:off x="548640" y="6400800"/>
-            <a:ext cx="11155680" cy="365760"/>
-          </a:xfrm>
-          <a:prstGeom prst="rect">
-            <a:avLst/>
-          </a:prstGeom>
-          <a:noFill/>
-        </p:spPr>
-        <p:txBody>
-          <a:bodyPr wrap="none">
-            <a:spAutoFit/>
-          </a:bodyPr>
-          <a:lstStyle/>
-          <a:p>
-            <a:r>
-              <a:rPr sz="1000">
-                <a:solidFill>
-                  <a:srgbClr val="9AA0B6"/>
-                </a:solidFill>
-              </a:rPr>
-              <a:t>EverMind + Butterbase: LIVE  ·  app_b197i2548pk2  ·  build0530</a:t>
-            </a:r>
-            <a:r>
-              <a:rPr sz="1000">
-                <a:solidFill>
-                  <a:srgbClr val="9AA0B6"/>
-                </a:solidFill>
-              </a:rPr>
-              <a:t>        4/8</a:t>
-            </a:r>
-          </a:p>
-        </p:txBody>
-      </p:sp>
-      <p:sp>
-        <p:nvSpPr>
-          <p:cNvPr id="5" name="TextBox 4"/>
-          <p:cNvSpPr txBox="1"/>
-          <p:nvPr/>
-        </p:nvSpPr>
-        <p:spPr>
-          <a:xfrm>
-            <a:off x="548640" y="502920"/>
-            <a:ext cx="10972800" cy="457200"/>
-          </a:xfrm>
-          <a:prstGeom prst="rect">
-            <a:avLst/>
-          </a:prstGeom>
-          <a:noFill/>
-        </p:spPr>
-        <p:txBody>
-          <a:bodyPr wrap="none">
-            <a:spAutoFit/>
-          </a:bodyPr>
-          <a:lstStyle/>
-          <a:p>
-            <a:pPr algn="l">
-              <a:spcAft>
-                <a:spcPts val="600"/>
-              </a:spcAft>
-            </a:pPr>
-            <a:r>
-              <a:rPr sz="1500" b="1">
-                <a:solidFill>
-                  <a:srgbClr val="2DD4A7"/>
-                </a:solidFill>
-                <a:latin typeface="Helvetica Neue"/>
-              </a:rPr>
-              <a:t>MODULAR — NOT JUST CODE</a:t>
-            </a:r>
-          </a:p>
-        </p:txBody>
-      </p:sp>
-      <p:sp>
-        <p:nvSpPr>
-          <p:cNvPr id="6" name="TextBox 5"/>
-          <p:cNvSpPr txBox="1"/>
-          <p:nvPr/>
-        </p:nvSpPr>
-        <p:spPr>
-          <a:xfrm>
-            <a:off x="548640" y="914400"/>
-            <a:ext cx="11155680" cy="731520"/>
-          </a:xfrm>
-          <a:prstGeom prst="rect">
-            <a:avLst/>
-          </a:prstGeom>
-          <a:noFill/>
-        </p:spPr>
-        <p:txBody>
-          <a:bodyPr wrap="none">
-            <a:spAutoFit/>
-          </a:bodyPr>
-          <a:lstStyle/>
-          <a:p>
-            <a:pPr algn="l">
-              <a:spcAft>
-                <a:spcPts val="600"/>
-              </a:spcAft>
-            </a:pPr>
-            <a:r>
-              <a:rPr sz="3000" b="1">
-                <a:solidFill>
-                  <a:srgbClr val="E8EAF2"/>
-                </a:solidFill>
-                <a:latin typeface="Helvetica Neue"/>
-              </a:rPr>
-              <a:t>Index anything on your computer</a:t>
-            </a:r>
-          </a:p>
-        </p:txBody>
-      </p:sp>
-      <p:sp>
-        <p:nvSpPr>
-          <p:cNvPr id="7" name="TextBox 6"/>
-          <p:cNvSpPr txBox="1"/>
-          <p:nvPr/>
-        </p:nvSpPr>
-        <p:spPr>
-          <a:xfrm>
-            <a:off x="548640" y="1572768"/>
-            <a:ext cx="11155680" cy="548640"/>
-          </a:xfrm>
-          <a:prstGeom prst="rect">
-            <a:avLst/>
-          </a:prstGeom>
-          <a:noFill/>
-        </p:spPr>
-        <p:txBody>
-          <a:bodyPr wrap="none">
-            <a:spAutoFit/>
-          </a:bodyPr>
-          <a:lstStyle/>
-          <a:p>
-            <a:pPr algn="l">
-              <a:spcAft>
-                <a:spcPts val="600"/>
-              </a:spcAft>
-            </a:pPr>
-            <a:r>
-              <a:rPr sz="1500" b="0">
-                <a:solidFill>
-                  <a:srgbClr val="9AA0B6"/>
-                </a:solidFill>
-                <a:latin typeface="Helvetica Neue"/>
-              </a:rPr>
-              <a:t>One CLI turns any folder into reusable structured context (SKILL.md + index) — agents load it instead of re-reading from scratch.</a:t>
-            </a:r>
-          </a:p>
-        </p:txBody>
-      </p:sp>
-      <p:sp>
-        <p:nvSpPr>
-          <p:cNvPr id="8" name="Rounded Rectangle 7"/>
-          <p:cNvSpPr/>
-          <p:nvPr/>
-        </p:nvSpPr>
-        <p:spPr>
-          <a:xfrm>
-            <a:off x="548640" y="2286000"/>
-            <a:ext cx="3447288" cy="960120"/>
-          </a:xfrm>
-          <a:prstGeom prst="roundRect">
-            <a:avLst/>
-          </a:prstGeom>
-          <a:solidFill>
-            <a:srgbClr val="10131E"/>
-          </a:solidFill>
-          <a:ln w="15875">
-            <a:solidFill>
-              <a:srgbClr val="2DD4A7"/>
-            </a:solidFill>
-          </a:ln>
-          <a:effectLst/>
-        </p:spPr>
-        <p:style>
-          <a:lnRef idx="1">
-            <a:schemeClr val="accent1"/>
-          </a:lnRef>
-          <a:fillRef idx="3">
-            <a:schemeClr val="accent1"/>
-          </a:fillRef>
-          <a:effectRef idx="2">
-            <a:schemeClr val="accent1"/>
-          </a:effectRef>
-          <a:fontRef idx="minor">
-            <a:schemeClr val="lt1"/>
-          </a:fontRef>
-        </p:style>
-        <p:txBody>
-          <a:bodyPr rtlCol="0" anchor="ctr" wrap="square"/>
-          <a:lstStyle/>
-          <a:p>
-            <a:pPr algn="ctr">
-              <a:spcAft>
-                <a:spcPts val="600"/>
-              </a:spcAft>
-            </a:pPr>
-            <a:r>
-              <a:rPr sz="1600" b="1">
-                <a:solidFill>
-                  <a:srgbClr val="2DD4A7"/>
-                </a:solidFill>
-                <a:latin typeface="Helvetica Neue"/>
-              </a:rPr>
-              <a:t>Codebases</a:t>
-            </a:r>
-          </a:p>
-        </p:txBody>
-      </p:sp>
-      <p:sp>
-        <p:nvSpPr>
-          <p:cNvPr id="9" name="Rounded Rectangle 8"/>
-          <p:cNvSpPr/>
-          <p:nvPr/>
-        </p:nvSpPr>
-        <p:spPr>
-          <a:xfrm>
-            <a:off x="4361688" y="2286000"/>
-            <a:ext cx="3447288" cy="960120"/>
-          </a:xfrm>
-          <a:prstGeom prst="roundRect">
-            <a:avLst/>
-          </a:prstGeom>
-          <a:solidFill>
-            <a:srgbClr val="10131E"/>
-          </a:solidFill>
-          <a:ln w="15875">
-            <a:solidFill>
-              <a:srgbClr val="4AA8FF"/>
-            </a:solidFill>
-          </a:ln>
-          <a:effectLst/>
-        </p:spPr>
-        <p:style>
-          <a:lnRef idx="1">
-            <a:schemeClr val="accent1"/>
-          </a:lnRef>
-          <a:fillRef idx="3">
-            <a:schemeClr val="accent1"/>
-          </a:fillRef>
-          <a:effectRef idx="2">
-            <a:schemeClr val="accent1"/>
-          </a:effectRef>
-          <a:fontRef idx="minor">
-            <a:schemeClr val="lt1"/>
-          </a:fontRef>
-        </p:style>
-        <p:txBody>
-          <a:bodyPr rtlCol="0" anchor="ctr" wrap="square"/>
-          <a:lstStyle/>
-          <a:p>
-            <a:pPr algn="ctr">
-              <a:spcAft>
-                <a:spcPts val="600"/>
-              </a:spcAft>
-            </a:pPr>
-            <a:r>
-              <a:rPr sz="1600" b="1">
-                <a:solidFill>
-                  <a:srgbClr val="4AA8FF"/>
-                </a:solidFill>
-                <a:latin typeface="Helvetica Neue"/>
-              </a:rPr>
-              <a:t>Docs &amp; notes</a:t>
-            </a:r>
-          </a:p>
-        </p:txBody>
-      </p:sp>
-      <p:sp>
-        <p:nvSpPr>
-          <p:cNvPr id="10" name="Rounded Rectangle 9"/>
-          <p:cNvSpPr/>
-          <p:nvPr/>
-        </p:nvSpPr>
-        <p:spPr>
-          <a:xfrm>
-            <a:off x="8174736" y="2286000"/>
-            <a:ext cx="3447288" cy="960120"/>
-          </a:xfrm>
-          <a:prstGeom prst="roundRect">
-            <a:avLst/>
-          </a:prstGeom>
-          <a:solidFill>
-            <a:srgbClr val="10131E"/>
-          </a:solidFill>
-          <a:ln w="15875">
-            <a:solidFill>
-              <a:srgbClr val="A78BFA"/>
-            </a:solidFill>
-          </a:ln>
-          <a:effectLst/>
-        </p:spPr>
-        <p:style>
-          <a:lnRef idx="1">
-            <a:schemeClr val="accent1"/>
-          </a:lnRef>
-          <a:fillRef idx="3">
-            <a:schemeClr val="accent1"/>
-          </a:fillRef>
-          <a:effectRef idx="2">
-            <a:schemeClr val="accent1"/>
-          </a:effectRef>
-          <a:fontRef idx="minor">
-            <a:schemeClr val="lt1"/>
-          </a:fontRef>
-        </p:style>
-        <p:txBody>
-          <a:bodyPr rtlCol="0" anchor="ctr" wrap="square"/>
-          <a:lstStyle/>
-          <a:p>
-            <a:pPr algn="ctr">
-              <a:spcAft>
-                <a:spcPts val="600"/>
-              </a:spcAft>
-            </a:pPr>
-            <a:r>
-              <a:rPr sz="1600" b="1">
-                <a:solidFill>
-                  <a:srgbClr val="A78BFA"/>
-                </a:solidFill>
-                <a:latin typeface="Helvetica Neue"/>
-              </a:rPr>
-              <a:t>Sales materials</a:t>
-            </a:r>
-          </a:p>
-        </p:txBody>
-      </p:sp>
-      <p:sp>
-        <p:nvSpPr>
-          <p:cNvPr id="11" name="Rounded Rectangle 10"/>
-          <p:cNvSpPr/>
-          <p:nvPr/>
-        </p:nvSpPr>
-        <p:spPr>
-          <a:xfrm>
-            <a:off x="548640" y="3520440"/>
-            <a:ext cx="3447288" cy="960120"/>
-          </a:xfrm>
-          <a:prstGeom prst="roundRect">
-            <a:avLst/>
-          </a:prstGeom>
-          <a:solidFill>
-            <a:srgbClr val="10131E"/>
-          </a:solidFill>
-          <a:ln w="15875">
-            <a:solidFill>
-              <a:srgbClr val="FF7849"/>
-            </a:solidFill>
-          </a:ln>
-          <a:effectLst/>
-        </p:spPr>
-        <p:style>
-          <a:lnRef idx="1">
-            <a:schemeClr val="accent1"/>
-          </a:lnRef>
-          <a:fillRef idx="3">
-            <a:schemeClr val="accent1"/>
-          </a:fillRef>
-          <a:effectRef idx="2">
-            <a:schemeClr val="accent1"/>
-          </a:effectRef>
-          <a:fontRef idx="minor">
-            <a:schemeClr val="lt1"/>
-          </a:fontRef>
-        </p:style>
-        <p:txBody>
-          <a:bodyPr rtlCol="0" anchor="ctr" wrap="square"/>
-          <a:lstStyle/>
-          <a:p>
-            <a:pPr algn="ctr">
-              <a:spcAft>
-                <a:spcPts val="600"/>
-              </a:spcAft>
-            </a:pPr>
-            <a:r>
-              <a:rPr sz="1600" b="1">
-                <a:solidFill>
-                  <a:srgbClr val="FF7849"/>
-                </a:solidFill>
-                <a:latin typeface="Helvetica Neue"/>
-              </a:rPr>
-              <a:t>Marketing assets</a:t>
-            </a:r>
-          </a:p>
-        </p:txBody>
-      </p:sp>
-      <p:sp>
-        <p:nvSpPr>
-          <p:cNvPr id="12" name="Rounded Rectangle 11"/>
-          <p:cNvSpPr/>
-          <p:nvPr/>
-        </p:nvSpPr>
-        <p:spPr>
-          <a:xfrm>
-            <a:off x="4361688" y="3520440"/>
-            <a:ext cx="3447288" cy="960120"/>
-          </a:xfrm>
-          <a:prstGeom prst="roundRect">
-            <a:avLst/>
-          </a:prstGeom>
-          <a:solidFill>
-            <a:srgbClr val="10131E"/>
-          </a:solidFill>
-          <a:ln w="15875">
-            <a:solidFill>
-              <a:srgbClr val="2DD4A7"/>
-            </a:solidFill>
-          </a:ln>
-          <a:effectLst/>
-        </p:spPr>
-        <p:style>
-          <a:lnRef idx="1">
-            <a:schemeClr val="accent1"/>
-          </a:lnRef>
-          <a:fillRef idx="3">
-            <a:schemeClr val="accent1"/>
-          </a:fillRef>
-          <a:effectRef idx="2">
-            <a:schemeClr val="accent1"/>
-          </a:effectRef>
-          <a:fontRef idx="minor">
-            <a:schemeClr val="lt1"/>
-          </a:fontRef>
-        </p:style>
-        <p:txBody>
-          <a:bodyPr rtlCol="0" anchor="ctr" wrap="square"/>
-          <a:lstStyle/>
-          <a:p>
-            <a:pPr algn="ctr">
-              <a:spcAft>
-                <a:spcPts val="600"/>
-              </a:spcAft>
-            </a:pPr>
-            <a:r>
-              <a:rPr sz="1600" b="1">
-                <a:solidFill>
-                  <a:srgbClr val="2DD4A7"/>
-                </a:solidFill>
-                <a:latin typeface="Helvetica Neue"/>
-              </a:rPr>
-              <a:t>Customer research</a:t>
-            </a:r>
-          </a:p>
-        </p:txBody>
-      </p:sp>
-      <p:sp>
-        <p:nvSpPr>
-          <p:cNvPr id="13" name="Rounded Rectangle 12"/>
-          <p:cNvSpPr/>
-          <p:nvPr/>
-        </p:nvSpPr>
-        <p:spPr>
-          <a:xfrm>
-            <a:off x="8174736" y="3520440"/>
-            <a:ext cx="3447288" cy="960120"/>
-          </a:xfrm>
-          <a:prstGeom prst="roundRect">
-            <a:avLst/>
-          </a:prstGeom>
-          <a:solidFill>
-            <a:srgbClr val="10131E"/>
-          </a:solidFill>
-          <a:ln w="15875">
-            <a:solidFill>
-              <a:srgbClr val="4AA8FF"/>
-            </a:solidFill>
-          </a:ln>
-          <a:effectLst/>
-        </p:spPr>
-        <p:style>
-          <a:lnRef idx="1">
-            <a:schemeClr val="accent1"/>
-          </a:lnRef>
-          <a:fillRef idx="3">
-            <a:schemeClr val="accent1"/>
-          </a:fillRef>
-          <a:effectRef idx="2">
-            <a:schemeClr val="accent1"/>
-          </a:effectRef>
-          <a:fontRef idx="minor">
-            <a:schemeClr val="lt1"/>
-          </a:fontRef>
-        </p:style>
-        <p:txBody>
-          <a:bodyPr rtlCol="0" anchor="ctr" wrap="square"/>
-          <a:lstStyle/>
-          <a:p>
-            <a:pPr algn="ctr">
-              <a:spcAft>
-                <a:spcPts val="600"/>
-              </a:spcAft>
-            </a:pPr>
-            <a:r>
-              <a:rPr sz="1600" b="1">
-                <a:solidFill>
-                  <a:srgbClr val="4AA8FF"/>
-                </a:solidFill>
-                <a:latin typeface="Helvetica Neue"/>
-              </a:rPr>
-              <a:t>Project folders &amp; workflows</a:t>
-            </a:r>
-          </a:p>
-        </p:txBody>
-      </p:sp>
-      <p:sp>
-        <p:nvSpPr>
-          <p:cNvPr id="14" name="TextBox 13"/>
-          <p:cNvSpPr txBox="1"/>
-          <p:nvPr/>
-        </p:nvSpPr>
-        <p:spPr>
-          <a:xfrm>
-            <a:off x="548640" y="5029200"/>
-            <a:ext cx="11155680" cy="914400"/>
-          </a:xfrm>
-          <a:prstGeom prst="rect">
-            <a:avLst/>
-          </a:prstGeom>
-          <a:noFill/>
-        </p:spPr>
-        <p:txBody>
-          <a:bodyPr wrap="none">
-            <a:spAutoFit/>
-          </a:bodyPr>
-          <a:lstStyle/>
-          <a:p>
-            <a:pPr algn="l">
-              <a:spcAft>
-                <a:spcPts val="600"/>
-              </a:spcAft>
-            </a:pPr>
-            <a:r>
-              <a:rPr sz="1700" b="1">
-                <a:solidFill>
-                  <a:srgbClr val="E8EAF2"/>
-                </a:solidFill>
-                <a:latin typeface="Helvetica Neue"/>
-              </a:rPr>
-              <a:t>Hermes · OpenClaw · Claude Code · any local agent reuse the SAME structured context across tasks — instead of rediscovering everything from scratch every time.</a:t>
-            </a:r>
-          </a:p>
-        </p:txBody>
-      </p:sp>
-    </p:spTree>
-  </p:cSld>
-  <p:clrMapOvr>
-    <a:masterClrMapping/>
-  </p:clrMapOvr>
-</p:sld>
-</file>
-
-<file path=ppt/slides/slide5.xml><?xml version="1.0" encoding="utf-8"?>
-<p:sld xmlns:a="http://schemas.openxmlformats.org/drawingml/2006/main" xmlns:p="http://schemas.openxmlformats.org/presentationml/2006/main" xmlns:r="http://schemas.openxmlformats.org/officeDocument/2006/relationships">
-  <p:cSld>
-    <p:spTree>
-      <p:nvGrpSpPr>
-        <p:cNvPr id="1" name=""/>
-        <p:cNvGrpSpPr/>
-        <p:nvPr/>
-      </p:nvGrpSpPr>
-      <p:grpSpPr/>
-      <p:sp>
-        <p:nvSpPr>
-          <p:cNvPr id="2" name="Rectangle 1"/>
-          <p:cNvSpPr/>
-          <p:nvPr/>
-        </p:nvSpPr>
-        <p:spPr>
-          <a:xfrm>
-            <a:off x="0" y="0"/>
-            <a:ext cx="12191695" cy="6858000"/>
-          </a:xfrm>
-          <a:prstGeom prst="rect">
-            <a:avLst/>
-          </a:prstGeom>
-          <a:solidFill>
-            <a:srgbClr val="0A0C14"/>
-          </a:solidFill>
-          <a:ln>
-            <a:noFill/>
-          </a:ln>
-          <a:effectLst/>
-        </p:spPr>
-        <p:style>
-          <a:lnRef idx="1">
-            <a:schemeClr val="accent1"/>
-          </a:lnRef>
-          <a:fillRef idx="3">
-            <a:schemeClr val="accent1"/>
-          </a:fillRef>
-          <a:effectRef idx="2">
-            <a:schemeClr val="accent1"/>
-          </a:effectRef>
-          <a:fontRef idx="minor">
-            <a:schemeClr val="lt1"/>
-          </a:fontRef>
-        </p:style>
-        <p:txBody>
-          <a:bodyPr rtlCol="0" anchor="ctr"/>
-          <a:lstStyle/>
-          <a:p>
-            <a:pPr algn="ctr"/>
-          </a:p>
-        </p:txBody>
-      </p:sp>
-      <p:sp>
-        <p:nvSpPr>
-          <p:cNvPr id="3" name="Rectangle 2"/>
-          <p:cNvSpPr/>
-          <p:nvPr/>
-        </p:nvSpPr>
-        <p:spPr>
-          <a:xfrm>
-            <a:off x="0" y="0"/>
-            <a:ext cx="128016" cy="6858000"/>
-          </a:xfrm>
-          <a:prstGeom prst="rect">
-            <a:avLst/>
-          </a:prstGeom>
-          <a:solidFill>
-            <a:srgbClr val="2DD4A7"/>
-          </a:solidFill>
-          <a:ln>
-            <a:noFill/>
-          </a:ln>
-          <a:effectLst/>
-        </p:spPr>
-        <p:style>
-          <a:lnRef idx="1">
-            <a:schemeClr val="accent1"/>
-          </a:lnRef>
-          <a:fillRef idx="3">
-            <a:schemeClr val="accent1"/>
-          </a:fillRef>
-          <a:effectRef idx="2">
-            <a:schemeClr val="accent1"/>
-          </a:effectRef>
-          <a:fontRef idx="minor">
-            <a:schemeClr val="lt1"/>
-          </a:fontRef>
-        </p:style>
-        <p:txBody>
-          <a:bodyPr rtlCol="0" anchor="ctr"/>
-          <a:lstStyle/>
-          <a:p>
-            <a:pPr algn="ctr"/>
-          </a:p>
-        </p:txBody>
-      </p:sp>
-      <p:sp>
-        <p:nvSpPr>
-          <p:cNvPr id="4" name="TextBox 3"/>
-          <p:cNvSpPr txBox="1"/>
-          <p:nvPr/>
-        </p:nvSpPr>
-        <p:spPr>
-          <a:xfrm>
-            <a:off x="548640" y="6400800"/>
-            <a:ext cx="11155680" cy="365760"/>
-          </a:xfrm>
-          <a:prstGeom prst="rect">
-            <a:avLst/>
-          </a:prstGeom>
-          <a:noFill/>
-        </p:spPr>
-        <p:txBody>
-          <a:bodyPr wrap="none">
-            <a:spAutoFit/>
-          </a:bodyPr>
-          <a:lstStyle/>
-          <a:p>
-            <a:r>
-              <a:rPr sz="1000">
-                <a:solidFill>
-                  <a:srgbClr val="9AA0B6"/>
-                </a:solidFill>
-              </a:rPr>
-              <a:t>EverMind + Butterbase: LIVE  ·  app_b197i2548pk2  ·  build0530</a:t>
-            </a:r>
-            <a:r>
-              <a:rPr sz="1000">
-                <a:solidFill>
-                  <a:srgbClr val="9AA0B6"/>
-                </a:solidFill>
-              </a:rPr>
-              <a:t>        5/8</a:t>
-            </a:r>
-          </a:p>
-        </p:txBody>
-      </p:sp>
-      <p:sp>
-        <p:nvSpPr>
-          <p:cNvPr id="5" name="TextBox 4"/>
-          <p:cNvSpPr txBox="1"/>
-          <p:nvPr/>
-        </p:nvSpPr>
-        <p:spPr>
-          <a:xfrm>
-            <a:off x="548640" y="502920"/>
-            <a:ext cx="10972800" cy="457200"/>
-          </a:xfrm>
-          <a:prstGeom prst="rect">
-            <a:avLst/>
-          </a:prstGeom>
-          <a:noFill/>
-        </p:spPr>
-        <p:txBody>
-          <a:bodyPr wrap="none">
-            <a:spAutoFit/>
-          </a:bodyPr>
-          <a:lstStyle/>
-          <a:p>
-            <a:pPr algn="l">
-              <a:spcAft>
-                <a:spcPts val="600"/>
-              </a:spcAft>
-            </a:pPr>
-            <a:r>
-              <a:rPr sz="1500" b="1">
-                <a:solidFill>
-                  <a:srgbClr val="2DD4A7"/>
-                </a:solidFill>
-                <a:latin typeface="Helvetica Neue"/>
-              </a:rPr>
-              <a:t>THE FIX</a:t>
-            </a:r>
-          </a:p>
-        </p:txBody>
-      </p:sp>
-      <p:sp>
-        <p:nvSpPr>
-          <p:cNvPr id="6" name="TextBox 5"/>
-          <p:cNvSpPr txBox="1"/>
-          <p:nvPr/>
-        </p:nvSpPr>
-        <p:spPr>
-          <a:xfrm>
-            <a:off x="548640" y="914400"/>
-            <a:ext cx="10972800" cy="822960"/>
-          </a:xfrm>
-          <a:prstGeom prst="rect">
-            <a:avLst/>
-          </a:prstGeom>
-          <a:noFill/>
-        </p:spPr>
-        <p:txBody>
-          <a:bodyPr wrap="none">
-            <a:spAutoFit/>
-          </a:bodyPr>
-          <a:lstStyle/>
-          <a:p>
-            <a:pPr algn="l">
-              <a:spcAft>
-                <a:spcPts val="600"/>
-              </a:spcAft>
-            </a:pPr>
-            <a:r>
-              <a:rPr sz="2800" b="1">
-                <a:solidFill>
-                  <a:srgbClr val="E8EAF2"/>
-                </a:solidFill>
-                <a:latin typeface="Helvetica Neue"/>
-              </a:rPr>
-              <a:t>A $0 local map Claude reads instead of the whole repo</a:t>
-            </a:r>
-          </a:p>
-        </p:txBody>
-      </p:sp>
-      <p:sp>
-        <p:nvSpPr>
-          <p:cNvPr id="7" name="TextBox 6"/>
-          <p:cNvSpPr txBox="1"/>
-          <p:nvPr/>
-        </p:nvSpPr>
-        <p:spPr>
-          <a:xfrm>
-            <a:off x="548640" y="1874519"/>
-            <a:ext cx="11064240" cy="2926080"/>
-          </a:xfrm>
-          <a:prstGeom prst="rect">
-            <a:avLst/>
-          </a:prstGeom>
-          <a:noFill/>
-        </p:spPr>
-        <p:txBody>
-          <a:bodyPr wrap="none">
-            <a:spAutoFit/>
-          </a:bodyPr>
-          <a:lstStyle/>
-          <a:p>
-            <a:pPr algn="l">
-              <a:spcAft>
-                <a:spcPts val="1400"/>
-              </a:spcAft>
-            </a:pPr>
-            <a:r>
-              <a:rPr sz="1900" b="1">
-                <a:solidFill>
-                  <a:srgbClr val="2DD4A7"/>
-                </a:solidFill>
-                <a:latin typeface="Helvetica Neue"/>
-              </a:rPr>
-              <a:t>SKILL.md + DAG  —  </a:t>
-            </a:r>
-            <a:r>
-              <a:rPr sz="1700">
-                <a:solidFill>
-                  <a:srgbClr val="E8EAF2"/>
-                </a:solidFill>
-              </a:rPr>
-              <a:t>commit-versioned: every file, every function, the call graph — refreshed on each change</a:t>
-            </a:r>
-          </a:p>
-          <a:p>
-            <a:pPr algn="l">
-              <a:spcAft>
-                <a:spcPts val="1400"/>
-              </a:spcAft>
-            </a:pPr>
-            <a:r>
-              <a:rPr sz="1900" b="1">
-                <a:solidFill>
-                  <a:srgbClr val="4AA8FF"/>
-                </a:solidFill>
-                <a:latin typeface="Helvetica Neue"/>
-              </a:rPr>
-              <a:t>Selective retrieval  —  </a:t>
-            </a:r>
-            <a:r>
-              <a:rPr sz="1700">
-                <a:solidFill>
-                  <a:srgbClr val="E8EAF2"/>
-                </a:solidFill>
-              </a:rPr>
-              <a:t>send only the relevant slice, compressed (8.8× on a real query)</a:t>
-            </a:r>
-          </a:p>
-          <a:p>
-            <a:pPr algn="l">
-              <a:spcAft>
-                <a:spcPts val="1400"/>
-              </a:spcAft>
-            </a:pPr>
-            <a:r>
-              <a:rPr sz="1900" b="1">
-                <a:solidFill>
-                  <a:srgbClr val="A78BFA"/>
-                </a:solidFill>
-                <a:latin typeface="Helvetica Neue"/>
-              </a:rPr>
-              <a:t>$0 + local  —  </a:t>
-            </a:r>
-            <a:r>
-              <a:rPr sz="1700">
-                <a:solidFill>
-                  <a:srgbClr val="E8EAF2"/>
-                </a:solidFill>
-              </a:rPr>
-              <a:t>the index runs on your machine for nothing; frontier is used only for the hard step</a:t>
-            </a:r>
-          </a:p>
-          <a:p>
-            <a:pPr algn="l">
-              <a:spcAft>
-                <a:spcPts val="1400"/>
-              </a:spcAft>
-            </a:pPr>
-            <a:r>
-              <a:rPr sz="1900" b="1">
-                <a:solidFill>
-                  <a:srgbClr val="FF7849"/>
-                </a:solidFill>
-                <a:latin typeface="Helvetica Neue"/>
-              </a:rPr>
-              <a:t>Sponsors  —  </a:t>
-            </a:r>
-            <a:r>
-              <a:rPr sz="1700">
-                <a:solidFill>
-                  <a:srgbClr val="E8EAF2"/>
-                </a:solidFill>
-              </a:rPr>
-              <a:t>EverMind = long-term memory (prior decisions) · Butterbase = state/backend + judging</a:t>
-            </a:r>
-          </a:p>
-        </p:txBody>
-      </p:sp>
-    </p:spTree>
-  </p:cSld>
-  <p:clrMapOvr>
-    <a:masterClrMapping/>
-  </p:clrMapOvr>
-</p:sld>
-</file>
-
-<file path=ppt/slides/slide6.xml><?xml version="1.0" encoding="utf-8"?>
-<p:sld xmlns:a="http://schemas.openxmlformats.org/drawingml/2006/main" xmlns:p="http://schemas.openxmlformats.org/presentationml/2006/main" xmlns:r="http://schemas.openxmlformats.org/officeDocument/2006/relationships">
-  <p:cSld>
-    <p:spTree>
-      <p:nvGrpSpPr>
-        <p:cNvPr id="1" name=""/>
-        <p:cNvGrpSpPr/>
-        <p:nvPr/>
-      </p:nvGrpSpPr>
-      <p:grpSpPr/>
-      <p:sp>
-        <p:nvSpPr>
-          <p:cNvPr id="2" name="Rectangle 1"/>
-          <p:cNvSpPr/>
-          <p:nvPr/>
-        </p:nvSpPr>
-        <p:spPr>
-          <a:xfrm>
-            <a:off x="0" y="0"/>
-            <a:ext cx="12191695" cy="6858000"/>
-          </a:xfrm>
-          <a:prstGeom prst="rect">
-            <a:avLst/>
-          </a:prstGeom>
-          <a:solidFill>
-            <a:srgbClr val="0A0C14"/>
-          </a:solidFill>
-          <a:ln>
-            <a:noFill/>
-          </a:ln>
-          <a:effectLst/>
-        </p:spPr>
-        <p:style>
-          <a:lnRef idx="1">
-            <a:schemeClr val="accent1"/>
-          </a:lnRef>
-          <a:fillRef idx="3">
-            <a:schemeClr val="accent1"/>
-          </a:fillRef>
-          <a:effectRef idx="2">
-            <a:schemeClr val="accent1"/>
-          </a:effectRef>
-          <a:fontRef idx="minor">
-            <a:schemeClr val="lt1"/>
-          </a:fontRef>
-        </p:style>
-        <p:txBody>
-          <a:bodyPr rtlCol="0" anchor="ctr"/>
-          <a:lstStyle/>
-          <a:p>
-            <a:pPr algn="ctr"/>
-          </a:p>
-        </p:txBody>
-      </p:sp>
-      <p:sp>
-        <p:nvSpPr>
-          <p:cNvPr id="3" name="Rectangle 2"/>
-          <p:cNvSpPr/>
-          <p:nvPr/>
-        </p:nvSpPr>
-        <p:spPr>
-          <a:xfrm>
-            <a:off x="0" y="0"/>
-            <a:ext cx="128016" cy="6858000"/>
-          </a:xfrm>
-          <a:prstGeom prst="rect">
-            <a:avLst/>
-          </a:prstGeom>
-          <a:solidFill>
-            <a:srgbClr val="2DD4A7"/>
-          </a:solidFill>
-          <a:ln>
-            <a:noFill/>
-          </a:ln>
-          <a:effectLst/>
-        </p:spPr>
-        <p:style>
-          <a:lnRef idx="1">
-            <a:schemeClr val="accent1"/>
-          </a:lnRef>
-          <a:fillRef idx="3">
-            <a:schemeClr val="accent1"/>
-          </a:fillRef>
-          <a:effectRef idx="2">
-            <a:schemeClr val="accent1"/>
-          </a:effectRef>
-          <a:fontRef idx="minor">
-            <a:schemeClr val="lt1"/>
-          </a:fontRef>
-        </p:style>
-        <p:txBody>
-          <a:bodyPr rtlCol="0" anchor="ctr"/>
-          <a:lstStyle/>
-          <a:p>
-            <a:pPr algn="ctr"/>
-          </a:p>
-        </p:txBody>
-      </p:sp>
-      <p:sp>
-        <p:nvSpPr>
-          <p:cNvPr id="4" name="TextBox 3"/>
-          <p:cNvSpPr txBox="1"/>
-          <p:nvPr/>
-        </p:nvSpPr>
-        <p:spPr>
-          <a:xfrm>
-            <a:off x="548640" y="6400800"/>
-            <a:ext cx="11155680" cy="365760"/>
-          </a:xfrm>
-          <a:prstGeom prst="rect">
-            <a:avLst/>
-          </a:prstGeom>
-          <a:noFill/>
-        </p:spPr>
-        <p:txBody>
-          <a:bodyPr wrap="none">
-            <a:spAutoFit/>
-          </a:bodyPr>
-          <a:lstStyle/>
-          <a:p>
-            <a:r>
-              <a:rPr sz="1000">
-                <a:solidFill>
-                  <a:srgbClr val="9AA0B6"/>
-                </a:solidFill>
-              </a:rPr>
-              <a:t>EverMind + Butterbase: LIVE  ·  app_b197i2548pk2  ·  build0530</a:t>
-            </a:r>
-            <a:r>
-              <a:rPr sz="1000">
-                <a:solidFill>
-                  <a:srgbClr val="9AA0B6"/>
-                </a:solidFill>
-              </a:rPr>
-              <a:t>        6/8</a:t>
-            </a:r>
-          </a:p>
-        </p:txBody>
-      </p:sp>
-      <p:sp>
-        <p:nvSpPr>
-          <p:cNvPr id="5" name="TextBox 4"/>
-          <p:cNvSpPr txBox="1"/>
-          <p:nvPr/>
-        </p:nvSpPr>
-        <p:spPr>
-          <a:xfrm>
-            <a:off x="548640" y="502920"/>
-            <a:ext cx="10972800" cy="457200"/>
-          </a:xfrm>
-          <a:prstGeom prst="rect">
-            <a:avLst/>
-          </a:prstGeom>
-          <a:noFill/>
-        </p:spPr>
-        <p:txBody>
-          <a:bodyPr wrap="none">
-            <a:spAutoFit/>
-          </a:bodyPr>
-          <a:lstStyle/>
-          <a:p>
-            <a:pPr algn="l">
-              <a:spcAft>
-                <a:spcPts val="600"/>
-              </a:spcAft>
-            </a:pPr>
-            <a:r>
-              <a:rPr sz="1500" b="1">
-                <a:solidFill>
-                  <a:srgbClr val="2DD4A7"/>
-                </a:solidFill>
-                <a:latin typeface="Helvetica Neue"/>
-              </a:rPr>
-              <a:t>DEMO FLOW  (what I'll show live)</a:t>
-            </a:r>
-          </a:p>
-        </p:txBody>
-      </p:sp>
-      <p:sp>
-        <p:nvSpPr>
-          <p:cNvPr id="6" name="TextBox 5"/>
-          <p:cNvSpPr txBox="1"/>
-          <p:nvPr/>
-        </p:nvSpPr>
-        <p:spPr>
-          <a:xfrm>
-            <a:off x="548640" y="914400"/>
-            <a:ext cx="10972800" cy="731520"/>
-          </a:xfrm>
-          <a:prstGeom prst="rect">
-            <a:avLst/>
-          </a:prstGeom>
-          <a:noFill/>
-        </p:spPr>
-        <p:txBody>
-          <a:bodyPr wrap="none">
-            <a:spAutoFit/>
-          </a:bodyPr>
-          <a:lstStyle/>
-          <a:p>
-            <a:pPr algn="l">
-              <a:spcAft>
-                <a:spcPts val="600"/>
-              </a:spcAft>
-            </a:pPr>
-            <a:r>
-              <a:rPr sz="3000" b="1">
-                <a:solidFill>
-                  <a:srgbClr val="E8EAF2"/>
-                </a:solidFill>
-                <a:latin typeface="Helvetica Neue"/>
-              </a:rPr>
-              <a:t>Watch the token meter drop</a:t>
-            </a:r>
-          </a:p>
-        </p:txBody>
-      </p:sp>
-      <p:sp>
-        <p:nvSpPr>
-          <p:cNvPr id="7" name="TextBox 6"/>
-          <p:cNvSpPr txBox="1"/>
-          <p:nvPr/>
-        </p:nvSpPr>
-        <p:spPr>
-          <a:xfrm>
-            <a:off x="548640" y="1828800"/>
-            <a:ext cx="11064240" cy="3291840"/>
-          </a:xfrm>
-          <a:prstGeom prst="rect">
-            <a:avLst/>
-          </a:prstGeom>
-          <a:noFill/>
-        </p:spPr>
-        <p:txBody>
-          <a:bodyPr wrap="none">
-            <a:spAutoFit/>
-          </a:bodyPr>
-          <a:lstStyle/>
-          <a:p>
-            <a:pPr algn="l">
-              <a:spcAft>
-                <a:spcPts val="1600"/>
-              </a:spcAft>
-            </a:pPr>
-            <a:r>
-              <a:rPr sz="2000" b="1">
-                <a:solidFill>
-                  <a:srgbClr val="FF7849"/>
-                </a:solidFill>
-                <a:latin typeface="Helvetica Neue"/>
-              </a:rPr>
-              <a:t>1.  </a:t>
-            </a:r>
-            <a:r>
-              <a:rPr sz="1800">
-                <a:solidFill>
-                  <a:srgbClr val="E8EAF2"/>
-                </a:solidFill>
-              </a:rPr>
-              <a:t>Ask a codebase question the normal way → Claude Code explores files (big token count).</a:t>
-            </a:r>
-          </a:p>
-          <a:p>
-            <a:pPr algn="l">
-              <a:spcAft>
-                <a:spcPts val="1600"/>
-              </a:spcAft>
-            </a:pPr>
-            <a:r>
-              <a:rPr sz="2000" b="1">
-                <a:solidFill>
-                  <a:srgbClr val="2DD4A7"/>
-                </a:solidFill>
-                <a:latin typeface="Helvetica Neue"/>
-              </a:rPr>
-              <a:t>2.  </a:t>
-            </a:r>
-            <a:r>
-              <a:rPr sz="1800">
-                <a:solidFill>
-                  <a:srgbClr val="E8EAF2"/>
-                </a:solidFill>
-              </a:rPr>
-              <a:t>Run  `autopilot index`  → open .autopilot/SKILL.md + ARCHITECTURE.md (the DAG).</a:t>
-            </a:r>
-          </a:p>
-          <a:p>
-            <a:pPr algn="l">
-              <a:spcAft>
-                <a:spcPts val="1600"/>
-              </a:spcAft>
-            </a:pPr>
-            <a:r>
-              <a:rPr sz="2000" b="1">
-                <a:solidFill>
-                  <a:srgbClr val="4AA8FF"/>
-                </a:solidFill>
-                <a:latin typeface="Helvetica Neue"/>
-              </a:rPr>
-              <a:t>3.  </a:t>
-            </a:r>
-            <a:r>
-              <a:rPr sz="1800">
-                <a:solidFill>
-                  <a:srgbClr val="E8EAF2"/>
-                </a:solidFill>
-              </a:rPr>
-              <a:t>Ask again with that saved context → answer from the right slice (tiny token count).</a:t>
-            </a:r>
-          </a:p>
-          <a:p>
-            <a:pPr algn="l">
-              <a:spcAft>
-                <a:spcPts val="1600"/>
-              </a:spcAft>
-            </a:pPr>
-            <a:r>
-              <a:rPr sz="2000" b="1">
-                <a:solidFill>
-                  <a:srgbClr val="A78BFA"/>
-                </a:solidFill>
-                <a:latin typeface="Helvetica Neue"/>
-              </a:rPr>
-              <a:t>4.  </a:t>
-            </a:r>
-            <a:r>
-              <a:rPr sz="1800">
-                <a:solidFill>
-                  <a:srgbClr val="E8EAF2"/>
-                </a:solidFill>
-              </a:rPr>
-              <a:t>Compare:  `autopilot eval`  → 11,947 → 299 tokens, −98.7%, tests still pass.</a:t>
-            </a:r>
-          </a:p>
-        </p:txBody>
-      </p:sp>
-    </p:spTree>
-  </p:cSld>
-  <p:clrMapOvr>
-    <a:masterClrMapping/>
-  </p:clrMapOvr>
-</p:sld>
-</file>
-
-<file path=ppt/slides/slide7.xml><?xml version="1.0" encoding="utf-8"?>
-<p:sld xmlns:a="http://schemas.openxmlformats.org/drawingml/2006/main" xmlns:p="http://schemas.openxmlformats.org/presentationml/2006/main" xmlns:r="http://schemas.openxmlformats.org/officeDocument/2006/relationships">
-  <p:cSld>
-    <p:spTree>
-      <p:nvGrpSpPr>
-        <p:cNvPr id="1" name=""/>
-        <p:cNvGrpSpPr/>
-        <p:nvPr/>
-      </p:nvGrpSpPr>
-      <p:grpSpPr/>
-      <p:sp>
-        <p:nvSpPr>
-          <p:cNvPr id="2" name="Rectangle 1"/>
-          <p:cNvSpPr/>
-          <p:nvPr/>
-        </p:nvSpPr>
-        <p:spPr>
-          <a:xfrm>
-            <a:off x="0" y="0"/>
-            <a:ext cx="12191695" cy="6858000"/>
-          </a:xfrm>
-          <a:prstGeom prst="rect">
-            <a:avLst/>
-          </a:prstGeom>
-          <a:solidFill>
-            <a:srgbClr val="0A0C14"/>
-          </a:solidFill>
-          <a:ln>
-            <a:noFill/>
-          </a:ln>
-          <a:effectLst/>
-        </p:spPr>
-        <p:style>
-          <a:lnRef idx="1">
-            <a:schemeClr val="accent1"/>
-          </a:lnRef>
-          <a:fillRef idx="3">
-            <a:schemeClr val="accent1"/>
-          </a:fillRef>
-          <a:effectRef idx="2">
-            <a:schemeClr val="accent1"/>
-          </a:effectRef>
-          <a:fontRef idx="minor">
-            <a:schemeClr val="lt1"/>
-          </a:fontRef>
-        </p:style>
-        <p:txBody>
-          <a:bodyPr rtlCol="0" anchor="ctr"/>
-          <a:lstStyle/>
-          <a:p>
-            <a:pPr algn="ctr"/>
-          </a:p>
-        </p:txBody>
-      </p:sp>
-      <p:sp>
-        <p:nvSpPr>
-          <p:cNvPr id="3" name="Rectangle 2"/>
-          <p:cNvSpPr/>
-          <p:nvPr/>
-        </p:nvSpPr>
-        <p:spPr>
-          <a:xfrm>
-            <a:off x="0" y="0"/>
-            <a:ext cx="128016" cy="6858000"/>
-          </a:xfrm>
-          <a:prstGeom prst="rect">
-            <a:avLst/>
-          </a:prstGeom>
-          <a:solidFill>
-            <a:srgbClr val="2DD4A7"/>
-          </a:solidFill>
-          <a:ln>
-            <a:noFill/>
-          </a:ln>
-          <a:effectLst/>
-        </p:spPr>
-        <p:style>
-          <a:lnRef idx="1">
-            <a:schemeClr val="accent1"/>
-          </a:lnRef>
-          <a:fillRef idx="3">
-            <a:schemeClr val="accent1"/>
-          </a:fillRef>
-          <a:effectRef idx="2">
-            <a:schemeClr val="accent1"/>
-          </a:effectRef>
-          <a:fontRef idx="minor">
-            <a:schemeClr val="lt1"/>
-          </a:fontRef>
-        </p:style>
-        <p:txBody>
-          <a:bodyPr rtlCol="0" anchor="ctr"/>
-          <a:lstStyle/>
-          <a:p>
-            <a:pPr algn="ctr"/>
-          </a:p>
-        </p:txBody>
-      </p:sp>
-      <p:sp>
-        <p:nvSpPr>
-          <p:cNvPr id="4" name="TextBox 3"/>
-          <p:cNvSpPr txBox="1"/>
-          <p:nvPr/>
-        </p:nvSpPr>
-        <p:spPr>
-          <a:xfrm>
-            <a:off x="548640" y="6400800"/>
-            <a:ext cx="11155680" cy="365760"/>
-          </a:xfrm>
-          <a:prstGeom prst="rect">
-            <a:avLst/>
-          </a:prstGeom>
-          <a:noFill/>
-        </p:spPr>
-        <p:txBody>
-          <a:bodyPr wrap="none">
-            <a:spAutoFit/>
-          </a:bodyPr>
-          <a:lstStyle/>
-          <a:p>
-            <a:r>
-              <a:rPr sz="1000">
-                <a:solidFill>
-                  <a:srgbClr val="9AA0B6"/>
-                </a:solidFill>
-              </a:rPr>
-              <a:t>EverMind + Butterbase: LIVE  ·  app_b197i2548pk2  ·  build0530</a:t>
-            </a:r>
-            <a:r>
-              <a:rPr sz="1000">
-                <a:solidFill>
-                  <a:srgbClr val="9AA0B6"/>
-                </a:solidFill>
-              </a:rPr>
-              <a:t>        7/8</a:t>
-            </a:r>
-          </a:p>
-        </p:txBody>
-      </p:sp>
-      <p:sp>
-        <p:nvSpPr>
-          <p:cNvPr id="5" name="TextBox 4"/>
-          <p:cNvSpPr txBox="1"/>
-          <p:nvPr/>
-        </p:nvSpPr>
-        <p:spPr>
-          <a:xfrm>
-            <a:off x="548640" y="502920"/>
-            <a:ext cx="10972800" cy="457200"/>
-          </a:xfrm>
-          <a:prstGeom prst="rect">
-            <a:avLst/>
-          </a:prstGeom>
-          <a:noFill/>
-        </p:spPr>
-        <p:txBody>
-          <a:bodyPr wrap="none">
-            <a:spAutoFit/>
-          </a:bodyPr>
-          <a:lstStyle/>
-          <a:p>
-            <a:pPr algn="l">
-              <a:spcAft>
-                <a:spcPts val="600"/>
-              </a:spcAft>
-            </a:pPr>
-            <a:r>
-              <a:rPr sz="1500" b="1">
-                <a:solidFill>
-                  <a:srgbClr val="2DD4A7"/>
-                </a:solidFill>
-                <a:latin typeface="Helvetica Neue"/>
-              </a:rPr>
-              <a:t>PROOF  ·  autopilot eval (measured)</a:t>
-            </a:r>
-          </a:p>
-        </p:txBody>
-      </p:sp>
-      <p:sp>
-        <p:nvSpPr>
-          <p:cNvPr id="6" name="TextBox 5"/>
-          <p:cNvSpPr txBox="1"/>
-          <p:nvPr/>
-        </p:nvSpPr>
-        <p:spPr>
-          <a:xfrm>
-            <a:off x="548640" y="914400"/>
-            <a:ext cx="10972800" cy="731520"/>
-          </a:xfrm>
-          <a:prstGeom prst="rect">
-            <a:avLst/>
-          </a:prstGeom>
-          <a:noFill/>
-        </p:spPr>
-        <p:txBody>
-          <a:bodyPr wrap="none">
-            <a:spAutoFit/>
-          </a:bodyPr>
-          <a:lstStyle/>
-          <a:p>
-            <a:pPr algn="l">
-              <a:spcAft>
-                <a:spcPts val="600"/>
-              </a:spcAft>
-            </a:pPr>
-            <a:r>
-              <a:rPr sz="2800" b="1">
-                <a:solidFill>
-                  <a:srgbClr val="E8EAF2"/>
-                </a:solidFill>
-                <a:latin typeface="Helvetica Neue"/>
-              </a:rPr>
-              <a:t>Same task. Same result. 98.7% fewer tokens.</a:t>
-            </a:r>
-          </a:p>
-        </p:txBody>
-      </p:sp>
-      <p:sp>
-        <p:nvSpPr>
-          <p:cNvPr id="7" name="Rounded Rectangle 6"/>
-          <p:cNvSpPr/>
-          <p:nvPr/>
-        </p:nvSpPr>
-        <p:spPr>
-          <a:xfrm>
-            <a:off x="548640" y="1920240"/>
-            <a:ext cx="2697480" cy="1737360"/>
-          </a:xfrm>
-          <a:prstGeom prst="roundRect">
-            <a:avLst/>
-          </a:prstGeom>
-          <a:solidFill>
-            <a:srgbClr val="10131E"/>
-          </a:solidFill>
-          <a:ln w="15875">
-            <a:solidFill>
-              <a:srgbClr val="2DD4A7"/>
-            </a:solidFill>
-          </a:ln>
-          <a:effectLst/>
-        </p:spPr>
-        <p:style>
-          <a:lnRef idx="1">
-            <a:schemeClr val="accent1"/>
-          </a:lnRef>
-          <a:fillRef idx="3">
-            <a:schemeClr val="accent1"/>
-          </a:fillRef>
-          <a:effectRef idx="2">
-            <a:schemeClr val="accent1"/>
-          </a:effectRef>
-          <a:fontRef idx="minor">
-            <a:schemeClr val="lt1"/>
-          </a:fontRef>
-        </p:style>
-        <p:txBody>
-          <a:bodyPr rtlCol="0" anchor="ctr"/>
-          <a:lstStyle/>
-          <a:p>
-            <a:pPr algn="ctr">
-              <a:spcAft>
-                <a:spcPts val="200"/>
-              </a:spcAft>
-            </a:pPr>
-            <a:r>
-              <a:rPr sz="4000" b="1">
-                <a:solidFill>
-                  <a:srgbClr val="2DD4A7"/>
-                </a:solidFill>
-                <a:latin typeface="Helvetica Neue"/>
-              </a:rPr>
-              <a:t>−98.7%</a:t>
-            </a:r>
-          </a:p>
-          <a:p>
-            <a:pPr algn="ctr">
-              <a:spcAft>
-                <a:spcPts val="600"/>
-              </a:spcAft>
-            </a:pPr>
-            <a:r>
-              <a:rPr sz="1600" b="0">
-                <a:solidFill>
-                  <a:srgbClr val="9AA0B6"/>
-                </a:solidFill>
-                <a:latin typeface="Helvetica Neue"/>
-              </a:rPr>
-              <a:t>tokens</a:t>
-            </a:r>
-          </a:p>
-        </p:txBody>
-      </p:sp>
-      <p:sp>
-        <p:nvSpPr>
-          <p:cNvPr id="8" name="Rounded Rectangle 7"/>
-          <p:cNvSpPr/>
-          <p:nvPr/>
-        </p:nvSpPr>
-        <p:spPr>
-          <a:xfrm>
-            <a:off x="3383280" y="1920240"/>
-            <a:ext cx="2697480" cy="1737360"/>
-          </a:xfrm>
-          <a:prstGeom prst="roundRect">
-            <a:avLst/>
-          </a:prstGeom>
-          <a:solidFill>
-            <a:srgbClr val="10131E"/>
-          </a:solidFill>
-          <a:ln w="15875">
-            <a:solidFill>
-              <a:srgbClr val="4AA8FF"/>
-            </a:solidFill>
-          </a:ln>
-          <a:effectLst/>
-        </p:spPr>
-        <p:style>
-          <a:lnRef idx="1">
-            <a:schemeClr val="accent1"/>
-          </a:lnRef>
-          <a:fillRef idx="3">
-            <a:schemeClr val="accent1"/>
-          </a:fillRef>
-          <a:effectRef idx="2">
-            <a:schemeClr val="accent1"/>
-          </a:effectRef>
-          <a:fontRef idx="minor">
-            <a:schemeClr val="lt1"/>
-          </a:fontRef>
-        </p:style>
-        <p:txBody>
-          <a:bodyPr rtlCol="0" anchor="ctr"/>
-          <a:lstStyle/>
-          <a:p>
-            <a:pPr algn="ctr">
-              <a:spcAft>
-                <a:spcPts val="200"/>
-              </a:spcAft>
-            </a:pPr>
-            <a:r>
-              <a:rPr sz="4000" b="1">
-                <a:solidFill>
-                  <a:srgbClr val="4AA8FF"/>
-                </a:solidFill>
-                <a:latin typeface="Helvetica Neue"/>
-              </a:rPr>
-              <a:t>−98%</a:t>
-            </a:r>
-          </a:p>
-          <a:p>
-            <a:pPr algn="ctr">
-              <a:spcAft>
-                <a:spcPts val="600"/>
-              </a:spcAft>
-            </a:pPr>
-            <a:r>
-              <a:rPr sz="1600" b="0">
-                <a:solidFill>
-                  <a:srgbClr val="9AA0B6"/>
-                </a:solidFill>
-                <a:latin typeface="Helvetica Neue"/>
-              </a:rPr>
-              <a:t>time</a:t>
-            </a:r>
-          </a:p>
-        </p:txBody>
-      </p:sp>
-      <p:sp>
-        <p:nvSpPr>
-          <p:cNvPr id="9" name="Rounded Rectangle 8"/>
-          <p:cNvSpPr/>
-          <p:nvPr/>
-        </p:nvSpPr>
-        <p:spPr>
-          <a:xfrm>
-            <a:off x="6217920" y="1920240"/>
-            <a:ext cx="2697480" cy="1737360"/>
-          </a:xfrm>
-          <a:prstGeom prst="roundRect">
-            <a:avLst/>
-          </a:prstGeom>
-          <a:solidFill>
-            <a:srgbClr val="10131E"/>
-          </a:solidFill>
-          <a:ln w="15875">
-            <a:solidFill>
-              <a:srgbClr val="A78BFA"/>
-            </a:solidFill>
-          </a:ln>
-          <a:effectLst/>
-        </p:spPr>
-        <p:style>
-          <a:lnRef idx="1">
-            <a:schemeClr val="accent1"/>
-          </a:lnRef>
-          <a:fillRef idx="3">
-            <a:schemeClr val="accent1"/>
-          </a:fillRef>
-          <a:effectRef idx="2">
-            <a:schemeClr val="accent1"/>
-          </a:effectRef>
-          <a:fontRef idx="minor">
-            <a:schemeClr val="lt1"/>
-          </a:fontRef>
-        </p:style>
-        <p:txBody>
-          <a:bodyPr rtlCol="0" anchor="ctr"/>
-          <a:lstStyle/>
-          <a:p>
-            <a:pPr algn="ctr">
-              <a:spcAft>
-                <a:spcPts val="200"/>
-              </a:spcAft>
-            </a:pPr>
-            <a:r>
-              <a:rPr sz="4000" b="1">
-                <a:solidFill>
-                  <a:srgbClr val="A78BFA"/>
-                </a:solidFill>
-                <a:latin typeface="Helvetica Neue"/>
-              </a:rPr>
-              <a:t>−94%</a:t>
-            </a:r>
-          </a:p>
-          <a:p>
-            <a:pPr algn="ctr">
-              <a:spcAft>
-                <a:spcPts val="600"/>
-              </a:spcAft>
-            </a:pPr>
-            <a:r>
-              <a:rPr sz="1600" b="0">
-                <a:solidFill>
-                  <a:srgbClr val="9AA0B6"/>
-                </a:solidFill>
-                <a:latin typeface="Helvetica Neue"/>
-              </a:rPr>
-              <a:t>cost</a:t>
-            </a:r>
-          </a:p>
-        </p:txBody>
-      </p:sp>
-      <p:sp>
-        <p:nvSpPr>
-          <p:cNvPr id="10" name="Rounded Rectangle 9"/>
-          <p:cNvSpPr/>
-          <p:nvPr/>
-        </p:nvSpPr>
-        <p:spPr>
-          <a:xfrm>
-            <a:off x="9052560" y="1920240"/>
-            <a:ext cx="2697480" cy="1737360"/>
-          </a:xfrm>
-          <a:prstGeom prst="roundRect">
-            <a:avLst/>
-          </a:prstGeom>
-          <a:solidFill>
-            <a:srgbClr val="10131E"/>
-          </a:solidFill>
-          <a:ln w="15875">
-            <a:solidFill>
-              <a:srgbClr val="FF7849"/>
-            </a:solidFill>
-          </a:ln>
-          <a:effectLst/>
-        </p:spPr>
-        <p:style>
-          <a:lnRef idx="1">
-            <a:schemeClr val="accent1"/>
-          </a:lnRef>
-          <a:fillRef idx="3">
-            <a:schemeClr val="accent1"/>
-          </a:fillRef>
-          <a:effectRef idx="2">
-            <a:schemeClr val="accent1"/>
-          </a:effectRef>
-          <a:fontRef idx="minor">
-            <a:schemeClr val="lt1"/>
-          </a:fontRef>
-        </p:style>
-        <p:txBody>
-          <a:bodyPr rtlCol="0" anchor="ctr"/>
-          <a:lstStyle/>
-          <a:p>
-            <a:pPr algn="ctr">
-              <a:spcAft>
-                <a:spcPts val="200"/>
-              </a:spcAft>
-            </a:pPr>
-            <a:r>
-              <a:rPr sz="4000" b="1">
-                <a:solidFill>
-                  <a:srgbClr val="FF7849"/>
-                </a:solidFill>
-                <a:latin typeface="Helvetica Neue"/>
-              </a:rPr>
-              <a:t>+0.32</a:t>
-            </a:r>
-          </a:p>
-          <a:p>
-            <a:pPr algn="ctr">
-              <a:spcAft>
-                <a:spcPts val="600"/>
-              </a:spcAft>
-            </a:pPr>
-            <a:r>
-              <a:rPr sz="1600" b="0">
-                <a:solidFill>
-                  <a:srgbClr val="9AA0B6"/>
-                </a:solidFill>
-                <a:latin typeface="Helvetica Neue"/>
-              </a:rPr>
-              <a:t>retrieval F1</a:t>
-            </a:r>
-          </a:p>
-        </p:txBody>
-      </p:sp>
-      <p:sp>
-        <p:nvSpPr>
-          <p:cNvPr id="11" name="TextBox 10"/>
-          <p:cNvSpPr txBox="1"/>
-          <p:nvPr/>
-        </p:nvSpPr>
-        <p:spPr>
-          <a:xfrm>
-            <a:off x="548640" y="3977639"/>
-            <a:ext cx="11064240" cy="2194560"/>
-          </a:xfrm>
-          <a:prstGeom prst="rect">
-            <a:avLst/>
-          </a:prstGeom>
-          <a:noFill/>
-        </p:spPr>
-        <p:txBody>
-          <a:bodyPr wrap="none">
-            <a:spAutoFit/>
-          </a:bodyPr>
-          <a:lstStyle/>
-          <a:p>
-            <a:pPr algn="l">
-              <a:spcAft>
-                <a:spcPts val="1000"/>
-              </a:spcAft>
-            </a:pPr>
-            <a:r>
-              <a:rPr sz="1700" b="1">
-                <a:solidFill>
-                  <a:srgbClr val="E8EAF2"/>
-                </a:solidFill>
-                <a:latin typeface="Helvetica Neue"/>
-              </a:rPr>
-              <a:t>11,947 → 299 tokens · 1 frontier call avoided · task success preserved (tests pass)</a:t>
-            </a:r>
-          </a:p>
-          <a:p>
-            <a:pPr algn="l">
-              <a:spcAft>
-                <a:spcPts val="1000"/>
-              </a:spcAft>
-            </a:pPr>
-            <a:r>
-              <a:rPr sz="1700" b="1">
-                <a:solidFill>
-                  <a:srgbClr val="2DD4A7"/>
-                </a:solidFill>
-                <a:latin typeface="Helvetica Neue"/>
-              </a:rPr>
-              <a:t>Real public repo (psf/requests): whole repo ≈147,794 tokens → ~1,025 for the right answer — 57×, −99.3%.</a:t>
-            </a:r>
-          </a:p>
-          <a:p>
-            <a:pPr algn="l">
-              <a:spcAft>
-                <a:spcPts val="1000"/>
-              </a:spcAft>
-            </a:pPr>
-            <a:r>
-              <a:rPr sz="1500" b="0">
-                <a:solidFill>
-                  <a:srgbClr val="9AA0B6"/>
-                </a:solidFill>
-                <a:latin typeface="Helvetica Neue"/>
-              </a:rPr>
-              <a:t>Live now: Butterbase app app_b197i2548pk2 (real rows) · EverMind memory written · 27/27 tests.</a:t>
-            </a:r>
-          </a:p>
-          <a:p>
-            <a:pPr algn="l">
-              <a:spcAft>
-                <a:spcPts val="600"/>
-              </a:spcAft>
-            </a:pPr>
-            <a:r>
-              <a:rPr sz="1500" b="1">
-                <a:solidFill>
-                  <a:srgbClr val="2DD4A7"/>
-                </a:solidFill>
-                <a:latin typeface="Helvetica Neue"/>
-              </a:rPr>
-              <a:t>Reproduce on stage:  autopilot index  ·  autopilot eval  ·  bash demo/run_demo.sh</a:t>
-            </a:r>
-          </a:p>
-        </p:txBody>
-      </p:sp>
-    </p:spTree>
-  </p:cSld>
-  <p:clrMapOvr>
-    <a:masterClrMapping/>
-  </p:clrMapOvr>
-</p:sld>
-</file>
-
-<file path=ppt/slides/slide8.xml><?xml version="1.0" encoding="utf-8"?>
-<p:sld xmlns:a="http://schemas.openxmlformats.org/drawingml/2006/main" xmlns:p="http://schemas.openxmlformats.org/presentationml/2006/main" xmlns:r="http://schemas.openxmlformats.org/officeDocument/2006/relationships">
-  <p:cSld>
-    <p:spTree>
-      <p:nvGrpSpPr>
-        <p:cNvPr id="1" name=""/>
-        <p:cNvGrpSpPr/>
-        <p:nvPr/>
-      </p:nvGrpSpPr>
-      <p:grpSpPr/>
-      <p:sp>
-        <p:nvSpPr>
-          <p:cNvPr id="2" name="Rectangle 1"/>
-          <p:cNvSpPr/>
-          <p:nvPr/>
-        </p:nvSpPr>
-        <p:spPr>
-          <a:xfrm>
-            <a:off x="0" y="0"/>
-            <a:ext cx="12191695" cy="6858000"/>
-          </a:xfrm>
-          <a:prstGeom prst="rect">
-            <a:avLst/>
-          </a:prstGeom>
-          <a:solidFill>
-            <a:srgbClr val="0A0C14"/>
-          </a:solidFill>
-          <a:ln>
-            <a:noFill/>
-          </a:ln>
-          <a:effectLst/>
-        </p:spPr>
-        <p:style>
-          <a:lnRef idx="1">
-            <a:schemeClr val="accent1"/>
-          </a:lnRef>
-          <a:fillRef idx="3">
-            <a:schemeClr val="accent1"/>
-          </a:fillRef>
-          <a:effectRef idx="2">
-            <a:schemeClr val="accent1"/>
-          </a:effectRef>
-          <a:fontRef idx="minor">
-            <a:schemeClr val="lt1"/>
-          </a:fontRef>
-        </p:style>
-        <p:txBody>
-          <a:bodyPr rtlCol="0" anchor="ctr"/>
-          <a:lstStyle/>
-          <a:p>
-            <a:pPr algn="ctr"/>
-          </a:p>
-        </p:txBody>
-      </p:sp>
-      <p:sp>
-        <p:nvSpPr>
-          <p:cNvPr id="3" name="Rectangle 2"/>
-          <p:cNvSpPr/>
-          <p:nvPr/>
-        </p:nvSpPr>
-        <p:spPr>
-          <a:xfrm>
-            <a:off x="0" y="0"/>
-            <a:ext cx="128016" cy="6858000"/>
-          </a:xfrm>
-          <a:prstGeom prst="rect">
-            <a:avLst/>
-          </a:prstGeom>
-          <a:solidFill>
-            <a:srgbClr val="2DD4A7"/>
-          </a:solidFill>
-          <a:ln>
-            <a:noFill/>
-          </a:ln>
-          <a:effectLst/>
-        </p:spPr>
-        <p:style>
-          <a:lnRef idx="1">
-            <a:schemeClr val="accent1"/>
-          </a:lnRef>
-          <a:fillRef idx="3">
-            <a:schemeClr val="accent1"/>
-          </a:fillRef>
-          <a:effectRef idx="2">
-            <a:schemeClr val="accent1"/>
-          </a:effectRef>
-          <a:fontRef idx="minor">
-            <a:schemeClr val="lt1"/>
-          </a:fontRef>
-        </p:style>
-        <p:txBody>
-          <a:bodyPr rtlCol="0" anchor="ctr"/>
-          <a:lstStyle/>
-          <a:p>
-            <a:pPr algn="ctr"/>
-          </a:p>
-        </p:txBody>
-      </p:sp>
-      <p:sp>
-        <p:nvSpPr>
-          <p:cNvPr id="4" name="TextBox 3"/>
-          <p:cNvSpPr txBox="1"/>
-          <p:nvPr/>
-        </p:nvSpPr>
-        <p:spPr>
-          <a:xfrm>
-            <a:off x="548640" y="6400800"/>
-            <a:ext cx="11155680" cy="365760"/>
-          </a:xfrm>
-          <a:prstGeom prst="rect">
-            <a:avLst/>
-          </a:prstGeom>
-          <a:noFill/>
-        </p:spPr>
-        <p:txBody>
-          <a:bodyPr wrap="none">
-            <a:spAutoFit/>
-          </a:bodyPr>
-          <a:lstStyle/>
-          <a:p>
-            <a:r>
-              <a:rPr sz="1000">
-                <a:solidFill>
-                  <a:srgbClr val="9AA0B6"/>
-                </a:solidFill>
-              </a:rPr>
-              <a:t>EverMind + Butterbase: LIVE  ·  app_b197i2548pk2  ·  build0530</a:t>
-            </a:r>
-            <a:r>
-              <a:rPr sz="1000">
-                <a:solidFill>
-                  <a:srgbClr val="9AA0B6"/>
-                </a:solidFill>
-              </a:rPr>
-              <a:t>        8/8</a:t>
-            </a:r>
-          </a:p>
-        </p:txBody>
-      </p:sp>
-      <p:sp>
-        <p:nvSpPr>
-          <p:cNvPr id="5" name="TextBox 4"/>
-          <p:cNvSpPr txBox="1"/>
-          <p:nvPr/>
-        </p:nvSpPr>
-        <p:spPr>
-          <a:xfrm>
-            <a:off x="548640" y="502920"/>
-            <a:ext cx="10972800" cy="457200"/>
-          </a:xfrm>
-          <a:prstGeom prst="rect">
-            <a:avLst/>
-          </a:prstGeom>
-          <a:noFill/>
-        </p:spPr>
-        <p:txBody>
-          <a:bodyPr wrap="none">
-            <a:spAutoFit/>
-          </a:bodyPr>
-          <a:lstStyle/>
-          <a:p>
-            <a:pPr algn="l">
-              <a:spcAft>
-                <a:spcPts val="600"/>
-              </a:spcAft>
-            </a:pPr>
-            <a:r>
-              <a:rPr sz="1500" b="1">
-                <a:solidFill>
-                  <a:srgbClr val="2DD4A7"/>
-                </a:solidFill>
-                <a:latin typeface="Helvetica Neue"/>
-              </a:rPr>
-              <a:t>DEMO  ·  the token drop in 30s</a:t>
-            </a:r>
-          </a:p>
-        </p:txBody>
-      </p:sp>
-      <p:sp>
-        <p:nvSpPr>
-          <p:cNvPr id="6" name="TextBox 5"/>
-          <p:cNvSpPr txBox="1"/>
-          <p:nvPr/>
-        </p:nvSpPr>
-        <p:spPr>
-          <a:xfrm>
-            <a:off x="548640" y="914400"/>
-            <a:ext cx="10972800" cy="731520"/>
-          </a:xfrm>
-          <a:prstGeom prst="rect">
-            <a:avLst/>
-          </a:prstGeom>
-          <a:noFill/>
-        </p:spPr>
-        <p:txBody>
-          <a:bodyPr wrap="none">
-            <a:spAutoFit/>
-          </a:bodyPr>
-          <a:lstStyle/>
-          <a:p>
-            <a:pPr algn="l">
-              <a:spcAft>
-                <a:spcPts val="600"/>
-              </a:spcAft>
-            </a:pPr>
-            <a:r>
-              <a:rPr sz="2600" b="1">
-                <a:solidFill>
-                  <a:srgbClr val="E8EAF2"/>
-                </a:solidFill>
-                <a:latin typeface="Helvetica Neue"/>
-              </a:rPr>
-              <a:t>Same task, two ways — watch tokens go 11,947 → 299</a:t>
+              <a:t>Working product — watch the token meter drop (≤2 min)</a:t>
             </a:r>
           </a:p>
         </p:txBody>
@@ -7259,8 +4138,8 @@
         </p:blipFill>
         <p:spPr>
           <a:xfrm>
-            <a:off x="1706727" y="1600200"/>
-            <a:ext cx="8778240" cy="4937760"/>
+            <a:off x="1569567" y="1554480"/>
+            <a:ext cx="9052560" cy="5093208"/>
           </a:xfrm>
           <a:prstGeom prst="rect">
             <a:avLst/>

</xml_diff>